<commit_message>
sync: update poster, slides, and add ICASSP/CIKM materials
</commit_message>
<xml_diff>
--- a/interview-presentation.pptx
+++ b/interview-presentation.pptx
@@ -2648,7 +2648,7 @@
       </p:sp>
       <p:pic>
         <p:nvPicPr>
-          <p:cNvPr id="5" name="Image 0" descr="/Users/sunxin/resume/papers/01_KBQA-R1_images/x2.png">    </p:cNvPr>
+          <p:cNvPr id="5" name="Image 0" descr="/Users/sunxin/resume/ppt-workspace/slides/images/kbqa-x2.png">    </p:cNvPr>
           <p:cNvPicPr>
             <a:picLocks noChangeAspect="1"/>
           </p:cNvPicPr>
@@ -6228,7 +6228,7 @@
       </p:sp>
       <p:pic>
         <p:nvPicPr>
-          <p:cNvPr id="5" name="Image 0" descr="/Users/sunxin/resume/papers/01_KBQA-R1_images/x3.png">    </p:cNvPr>
+          <p:cNvPr id="5" name="Image 0" descr="/Users/sunxin/resume/ppt-workspace/slides/images/kbqa-x3.png">    </p:cNvPr>
           <p:cNvPicPr>
             <a:picLocks noChangeAspect="1"/>
           </p:cNvPicPr>
@@ -6519,7 +6519,7 @@
       </p:sp>
       <p:pic>
         <p:nvPicPr>
-          <p:cNvPr id="11" name="Image 1" descr="/Users/sunxin/resume/papers/01_KBQA-R1_images/x4.png">    </p:cNvPr>
+          <p:cNvPr id="11" name="Image 1" descr="/Users/sunxin/resume/ppt-workspace/slides/images/kbqa-x4.png">    </p:cNvPr>
           <p:cNvPicPr>
             <a:picLocks noChangeAspect="1"/>
           </p:cNvPicPr>
@@ -6630,7 +6630,7 @@
       </p:sp>
       <p:pic>
         <p:nvPicPr>
-          <p:cNvPr id="14" name="Image 2" descr="/Users/sunxin/resume/papers/01_KBQA-R1_images/x6.png">    </p:cNvPr>
+          <p:cNvPr id="14" name="Image 2" descr="/Users/sunxin/resume/ppt-workspace/slides/images/kbqa-x6.png">    </p:cNvPr>
           <p:cNvPicPr>
             <a:picLocks noChangeAspect="1"/>
           </p:cNvPicPr>
@@ -7007,7 +7007,7 @@
                 <a:ea typeface="Arial" pitchFamily="34" charset="-122"/>
                 <a:cs typeface="Arial" pitchFamily="34" charset="-120"/>
               </a:rPr>
-              <a:t>Predict the Retrieval!</a:t>
+              <a:t>DIVE</a:t>
             </a:r>
             <a:pPr algn="l" indent="0" marL="0">
               <a:spcBef>
@@ -7027,7 +7027,7 @@
                 <a:ea typeface="Arial" pitchFamily="34" charset="-122"/>
                 <a:cs typeface="Arial" pitchFamily="34" charset="-120"/>
               </a:rPr>
-              <a:t> —ICASSP 2026 | 一作</a:t>
+              <a:t> —KDD 2024 | 一作</a:t>
             </a:r>
             <a:endParaRPr lang="en-US" sz="850" dirty="0"/>
           </a:p>
@@ -7072,7 +7072,7 @@
                 <a:ea typeface="Arial" pitchFamily="34" charset="-122"/>
                 <a:cs typeface="Arial" pitchFamily="34" charset="-120"/>
               </a:rPr>
-              <a:t>测试时自适应 RAG，无需额外训练判断何时检索</a:t>
+              <a:t>子图不一致性学习，图 OOD 泛化</a:t>
             </a:r>
             <a:endParaRPr lang="en-US" sz="850" dirty="0"/>
           </a:p>
@@ -7170,7 +7170,7 @@
                 <a:ea typeface="Arial" pitchFamily="34" charset="-122"/>
                 <a:cs typeface="Arial" pitchFamily="34" charset="-120"/>
               </a:rPr>
-              <a:t>ToolWeaver</a:t>
+              <a:t>Uncertainty Calibration</a:t>
             </a:r>
             <a:pPr algn="l" indent="0" marL="0">
               <a:spcBef>
@@ -7190,7 +7190,7 @@
                 <a:ea typeface="Arial" pitchFamily="34" charset="-122"/>
                 <a:cs typeface="Arial" pitchFamily="34" charset="-120"/>
               </a:rPr>
-              <a:t> —ICLR 2026 | 合作</a:t>
+              <a:t> —IEEE TKDE | 共一</a:t>
             </a:r>
             <a:endParaRPr lang="en-US" sz="850" dirty="0"/>
           </a:p>
@@ -7235,7 +7235,7 @@
                 <a:ea typeface="Arial" pitchFamily="34" charset="-122"/>
                 <a:cs typeface="Arial" pitchFamily="34" charset="-120"/>
               </a:rPr>
-              <a:t>协作语义编织实现可扩展工具使用</a:t>
+              <a:t>反事实倾向估计的不确定性校准，提升推荐系统 CVR 预估</a:t>
             </a:r>
             <a:endParaRPr lang="en-US" sz="850" dirty="0"/>
           </a:p>
@@ -7333,7 +7333,7 @@
                 <a:ea typeface="Arial" pitchFamily="34" charset="-122"/>
                 <a:cs typeface="Arial" pitchFamily="34" charset="-120"/>
               </a:rPr>
-              <a:t>DIVE</a:t>
+              <a:t>ToolWeaver</a:t>
             </a:r>
             <a:pPr algn="l" indent="0" marL="0">
               <a:spcBef>
@@ -7353,7 +7353,7 @@
                 <a:ea typeface="Arial" pitchFamily="34" charset="-122"/>
                 <a:cs typeface="Arial" pitchFamily="34" charset="-120"/>
               </a:rPr>
-              <a:t> —KDD 2024 | 一作</a:t>
+              <a:t> —ICLR 2026 | 合作</a:t>
             </a:r>
             <a:endParaRPr lang="en-US" sz="850" dirty="0"/>
           </a:p>
@@ -7398,7 +7398,7 @@
                 <a:ea typeface="Arial" pitchFamily="34" charset="-122"/>
                 <a:cs typeface="Arial" pitchFamily="34" charset="-120"/>
               </a:rPr>
-              <a:t>子图不一致性学习，图 OOD 泛化</a:t>
+              <a:t>协作语义编织实现可扩展工具使用</a:t>
             </a:r>
             <a:endParaRPr lang="en-US" sz="850" dirty="0"/>
           </a:p>
@@ -12129,7 +12129,7 @@
       </p:sp>
       <p:pic>
         <p:nvPicPr>
-          <p:cNvPr id="17" name="Image 0" descr="/Users/sunxin/resume/papers/02_Divide-Then-Align_images/x1.png">    </p:cNvPr>
+          <p:cNvPr id="17" name="Image 0" descr="/Users/sunxin/resume/ppt-workspace/slides/images/dta-x1.png">    </p:cNvPr>
           <p:cNvPicPr>
             <a:picLocks noChangeAspect="1"/>
           </p:cNvPicPr>
@@ -12254,7 +12254,7 @@
       </p:sp>
       <p:pic>
         <p:nvPicPr>
-          <p:cNvPr id="4" name="Image 0" descr="/Users/sunxin/resume/papers/02_Divide-Then-Align_images/x2.png">    </p:cNvPr>
+          <p:cNvPr id="4" name="Image 0" descr="/Users/sunxin/resume/ppt-workspace/slides/images/dta-x2.png">    </p:cNvPr>
           <p:cNvPicPr>
             <a:picLocks noChangeAspect="1"/>
           </p:cNvPicPr>
@@ -13811,7 +13811,7 @@
       </p:sp>
       <p:pic>
         <p:nvPicPr>
-          <p:cNvPr id="22" name="Image 0" descr="/Users/sunxin/resume/papers/03_Predict-the-Retrieval_images/x1.png">    </p:cNvPr>
+          <p:cNvPr id="22" name="Image 0" descr="/Users/sunxin/resume/ppt-workspace/slides/images/ttarag-x1.png">    </p:cNvPr>
           <p:cNvPicPr>
             <a:picLocks noChangeAspect="1"/>
           </p:cNvPicPr>
@@ -15142,7 +15142,7 @@
       </p:sp>
       <p:pic>
         <p:nvPicPr>
-          <p:cNvPr id="5" name="Image 0" descr="/Users/sunxin/resume/papers/01_KBQA-R1_images/x1.png">    </p:cNvPr>
+          <p:cNvPr id="5" name="Image 0" descr="/Users/sunxin/resume/ppt-workspace/slides/images/kbqa-x1.png">    </p:cNvPr>
           <p:cNvPicPr>
             <a:picLocks noChangeAspect="1"/>
           </p:cNvPicPr>

</xml_diff>

<commit_message>
Update interview presentation to v7
</commit_message>
<xml_diff>
--- a/interview-presentation.pptx
+++ b/interview-presentation.pptx
@@ -2,46 +2,48 @@
 <file path=ppt/presentation.xml><?xml version="1.0" encoding="utf-8"?>
 <p:presentation xmlns:p="http://schemas.openxmlformats.org/presentationml/2006/main">
   <p:sldMasterIdLst>
-    <p:sldMasterId xmlns:r="http://schemas.openxmlformats.org/officeDocument/2006/relationships" id="2147483648" r:id="R7d281219ac9c41d1"/>
+    <p:sldMasterId xmlns:r="http://schemas.openxmlformats.org/officeDocument/2006/relationships" id="2147483648" r:id="Rcf88fa4f801d4797"/>
   </p:sldMasterIdLst>
   <p:notesMasterIdLst>
-    <p:notesMasterId xmlns:r="http://schemas.openxmlformats.org/officeDocument/2006/relationships" r:id="Rc9477f205aa74faf"/>
+    <p:notesMasterId xmlns:r="http://schemas.openxmlformats.org/officeDocument/2006/relationships" r:id="Rc3a2526a7b2b4c7b"/>
   </p:notesMasterIdLst>
   <p:sldIdLst>
-    <p:sldId xmlns:r="http://schemas.openxmlformats.org/officeDocument/2006/relationships" id="256" r:id="R2afccdaa940c419f"/>
-    <p:sldId xmlns:r="http://schemas.openxmlformats.org/officeDocument/2006/relationships" id="257" r:id="R7560e4ca94de4c89"/>
-    <p:sldId xmlns:r="http://schemas.openxmlformats.org/officeDocument/2006/relationships" id="258" r:id="Rc31d9f0156ef4fa0"/>
-    <p:sldId xmlns:r="http://schemas.openxmlformats.org/officeDocument/2006/relationships" id="259" r:id="Rdb2b599c882b4b38"/>
-    <p:sldId xmlns:r="http://schemas.openxmlformats.org/officeDocument/2006/relationships" id="260" r:id="R8e54502c3c774886"/>
-    <p:sldId xmlns:r="http://schemas.openxmlformats.org/officeDocument/2006/relationships" id="261" r:id="Rffbf5a192bdb4e19"/>
-    <p:sldId xmlns:r="http://schemas.openxmlformats.org/officeDocument/2006/relationships" id="262" r:id="Rcc0e97c104de4f0e"/>
-    <p:sldId xmlns:r="http://schemas.openxmlformats.org/officeDocument/2006/relationships" id="263" r:id="R331ff1f96d8f4cc6"/>
-    <p:sldId xmlns:r="http://schemas.openxmlformats.org/officeDocument/2006/relationships" id="264" r:id="R5757a7be1da14479"/>
-    <p:sldId xmlns:r="http://schemas.openxmlformats.org/officeDocument/2006/relationships" id="265" r:id="R73566f5f75e84cd6"/>
-    <p:sldId xmlns:r="http://schemas.openxmlformats.org/officeDocument/2006/relationships" id="266" r:id="R4eea38a15d814f18"/>
-    <p:sldId xmlns:r="http://schemas.openxmlformats.org/officeDocument/2006/relationships" id="267" r:id="Re827fda978124252"/>
-    <p:sldId xmlns:r="http://schemas.openxmlformats.org/officeDocument/2006/relationships" id="268" r:id="R679e3a531e4b4685"/>
-    <p:sldId xmlns:r="http://schemas.openxmlformats.org/officeDocument/2006/relationships" id="269" r:id="R14df1d8a4ecd4a7b"/>
-    <p:sldId xmlns:r="http://schemas.openxmlformats.org/officeDocument/2006/relationships" id="270" r:id="R812dbf37a2724cc2"/>
-    <p:sldId xmlns:r="http://schemas.openxmlformats.org/officeDocument/2006/relationships" id="271" r:id="Re082546ba2fc4c22"/>
-    <p:sldId xmlns:r="http://schemas.openxmlformats.org/officeDocument/2006/relationships" id="272" r:id="Rf28719e80fca4939"/>
-    <p:sldId xmlns:r="http://schemas.openxmlformats.org/officeDocument/2006/relationships" id="273" r:id="R753cdfa9a0804c42"/>
-    <p:sldId xmlns:r="http://schemas.openxmlformats.org/officeDocument/2006/relationships" id="274" r:id="R969de29fb5ad4c6d"/>
-    <p:sldId xmlns:r="http://schemas.openxmlformats.org/officeDocument/2006/relationships" id="275" r:id="R27b14f5d99dd4806"/>
-    <p:sldId xmlns:r="http://schemas.openxmlformats.org/officeDocument/2006/relationships" id="276" r:id="Re2142ce135db49d2"/>
-    <p:sldId xmlns:r="http://schemas.openxmlformats.org/officeDocument/2006/relationships" id="277" r:id="Raf4352f798ba4343"/>
-    <p:sldId xmlns:r="http://schemas.openxmlformats.org/officeDocument/2006/relationships" id="278" r:id="R15e26ce8a553411b"/>
-    <p:sldId xmlns:r="http://schemas.openxmlformats.org/officeDocument/2006/relationships" id="279" r:id="R891cd075d7cc4518"/>
-    <p:sldId xmlns:r="http://schemas.openxmlformats.org/officeDocument/2006/relationships" id="280" r:id="Rab5b9bb80fb24cc5"/>
-    <p:sldId xmlns:r="http://schemas.openxmlformats.org/officeDocument/2006/relationships" id="281" r:id="Re8b23225e2fd46a7"/>
-    <p:sldId xmlns:r="http://schemas.openxmlformats.org/officeDocument/2006/relationships" id="282" r:id="R68484325db4740b7"/>
-    <p:sldId xmlns:r="http://schemas.openxmlformats.org/officeDocument/2006/relationships" id="283" r:id="R8db3f74937b641da"/>
-    <p:sldId xmlns:r="http://schemas.openxmlformats.org/officeDocument/2006/relationships" id="284" r:id="Rd3292f13b8384dfd"/>
-    <p:sldId xmlns:r="http://schemas.openxmlformats.org/officeDocument/2006/relationships" id="285" r:id="Rf44b48591ab44d53"/>
-    <p:sldId xmlns:r="http://schemas.openxmlformats.org/officeDocument/2006/relationships" id="286" r:id="R143b59ea0e204df0"/>
-    <p:sldId xmlns:r="http://schemas.openxmlformats.org/officeDocument/2006/relationships" id="287" r:id="R59c1dd1cbf0e41ed"/>
-    <p:sldId xmlns:r="http://schemas.openxmlformats.org/officeDocument/2006/relationships" id="288" r:id="R3af20494b7464845"/>
-    <p:sldId xmlns:r="http://schemas.openxmlformats.org/officeDocument/2006/relationships" id="289" r:id="Rf9a8f0c3556c48c5"/>
+    <p:sldId xmlns:r="http://schemas.openxmlformats.org/officeDocument/2006/relationships" id="256" r:id="R3929e7200f8645f5"/>
+    <p:sldId xmlns:r="http://schemas.openxmlformats.org/officeDocument/2006/relationships" id="257" r:id="R9ca4dd6be8504706"/>
+    <p:sldId xmlns:r="http://schemas.openxmlformats.org/officeDocument/2006/relationships" id="258" r:id="R26ee41ead1d5458b"/>
+    <p:sldId xmlns:r="http://schemas.openxmlformats.org/officeDocument/2006/relationships" id="259" r:id="Rc51158e735014841"/>
+    <p:sldId xmlns:r="http://schemas.openxmlformats.org/officeDocument/2006/relationships" id="260" r:id="Rc02300584a8e42b7"/>
+    <p:sldId xmlns:r="http://schemas.openxmlformats.org/officeDocument/2006/relationships" id="261" r:id="Rb4b56b0ef43142c6"/>
+    <p:sldId xmlns:r="http://schemas.openxmlformats.org/officeDocument/2006/relationships" id="262" r:id="R3c7ed0d39cdc4270"/>
+    <p:sldId xmlns:r="http://schemas.openxmlformats.org/officeDocument/2006/relationships" id="263" r:id="Rf15325bae76447c6"/>
+    <p:sldId xmlns:r="http://schemas.openxmlformats.org/officeDocument/2006/relationships" id="264" r:id="R7961f9e599f2418d"/>
+    <p:sldId xmlns:r="http://schemas.openxmlformats.org/officeDocument/2006/relationships" id="265" r:id="R154d104227b6462b"/>
+    <p:sldId xmlns:r="http://schemas.openxmlformats.org/officeDocument/2006/relationships" id="266" r:id="R9fb825362ac046a1"/>
+    <p:sldId xmlns:r="http://schemas.openxmlformats.org/officeDocument/2006/relationships" id="267" r:id="Rde22dc17d1454504"/>
+    <p:sldId xmlns:r="http://schemas.openxmlformats.org/officeDocument/2006/relationships" id="268" r:id="Rf96411d9574a47ff"/>
+    <p:sldId xmlns:r="http://schemas.openxmlformats.org/officeDocument/2006/relationships" id="269" r:id="Rcd6558f65f6f452c"/>
+    <p:sldId xmlns:r="http://schemas.openxmlformats.org/officeDocument/2006/relationships" id="270" r:id="Rafac868fc47b40c8"/>
+    <p:sldId xmlns:r="http://schemas.openxmlformats.org/officeDocument/2006/relationships" id="271" r:id="R2af40c5651c54482"/>
+    <p:sldId xmlns:r="http://schemas.openxmlformats.org/officeDocument/2006/relationships" id="272" r:id="R10d0aa8bcdd04b33"/>
+    <p:sldId xmlns:r="http://schemas.openxmlformats.org/officeDocument/2006/relationships" id="273" r:id="Rea999e5bb9c44360"/>
+    <p:sldId xmlns:r="http://schemas.openxmlformats.org/officeDocument/2006/relationships" id="274" r:id="Rcaafce0a51cb4927"/>
+    <p:sldId xmlns:r="http://schemas.openxmlformats.org/officeDocument/2006/relationships" id="275" r:id="R059caf6d6bd24685"/>
+    <p:sldId xmlns:r="http://schemas.openxmlformats.org/officeDocument/2006/relationships" id="276" r:id="R5d377fbdef504b04"/>
+    <p:sldId xmlns:r="http://schemas.openxmlformats.org/officeDocument/2006/relationships" id="277" r:id="R00da1d8fef6343ce"/>
+    <p:sldId xmlns:r="http://schemas.openxmlformats.org/officeDocument/2006/relationships" id="278" r:id="Re9dc57a3bd0c4461"/>
+    <p:sldId xmlns:r="http://schemas.openxmlformats.org/officeDocument/2006/relationships" id="279" r:id="R037c536ff1cc470a"/>
+    <p:sldId xmlns:r="http://schemas.openxmlformats.org/officeDocument/2006/relationships" id="280" r:id="Rc3999770209f4ce6"/>
+    <p:sldId xmlns:r="http://schemas.openxmlformats.org/officeDocument/2006/relationships" id="281" r:id="R5c3eaedd19134322"/>
+    <p:sldId xmlns:r="http://schemas.openxmlformats.org/officeDocument/2006/relationships" id="282" r:id="R8f96bc995e7448fb"/>
+    <p:sldId xmlns:r="http://schemas.openxmlformats.org/officeDocument/2006/relationships" id="283" r:id="R8d53d6e2cb684bdf"/>
+    <p:sldId xmlns:r="http://schemas.openxmlformats.org/officeDocument/2006/relationships" id="284" r:id="R197df63de5b24d41"/>
+    <p:sldId xmlns:r="http://schemas.openxmlformats.org/officeDocument/2006/relationships" id="285" r:id="Rea07884679744daa"/>
+    <p:sldId xmlns:r="http://schemas.openxmlformats.org/officeDocument/2006/relationships" id="286" r:id="R58a2f1f8b061460e"/>
+    <p:sldId xmlns:r="http://schemas.openxmlformats.org/officeDocument/2006/relationships" id="287" r:id="R385dd29e174647e3"/>
+    <p:sldId xmlns:r="http://schemas.openxmlformats.org/officeDocument/2006/relationships" id="288" r:id="R7b9eaecbed61480f"/>
+    <p:sldId xmlns:r="http://schemas.openxmlformats.org/officeDocument/2006/relationships" id="289" r:id="Rce89e3a666b546a8"/>
+    <p:sldId xmlns:r="http://schemas.openxmlformats.org/officeDocument/2006/relationships" id="290" r:id="R19b913b845734903"/>
+    <p:sldId xmlns:r="http://schemas.openxmlformats.org/officeDocument/2006/relationships" id="291" r:id="R6f030cd71dab47c8"/>
   </p:sldIdLst>
   <p:sldSz cx="12192000" cy="6858000"/>
   <p:notesSz cx="6858000" cy="9144000"/>
@@ -2282,7 +2284,7 @@
           </a:p>
           <a:p xmlns:a="http://schemas.openxmlformats.org/drawingml/2006/main">
             <a:r>
-              <a:t>- User-provided resume and publication status.</a:t>
+              <a:t>- User-provided resume update: GAPD accepted to EMNLP 2026 Findings; the TKDE paper lists the student first author; classification label is CCF-A / TH-CPL A.</a:t>
             </a:r>
           </a:p>
           <a:p xmlns:a="http://schemas.openxmlformats.org/drawingml/2006/main">
@@ -2455,20 +2457,17 @@
           </a:p>
           <a:p xmlns:a="http://schemas.openxmlformats.org/drawingml/2006/main">
             <a:r>
-              <a:t>- User-provided Trojail multi-turn attacker design and experiment context.</a:t>
+              <a:t>- Yuque: Agentic jailbreak, section 2.1 Multi-session &amp;&amp; Skill Augmented Harness: https://yuque.antfin.com/fengyi.sx/kdssqn/qma7a55r6panppyy</a:t>
+            </a:r>
+          </a:p>
+          <a:p xmlns:a="http://schemas.openxmlformats.org/drawingml/2006/main">
+            <a:r>
+              <a:t>- User-authored source-equivalent framework figure: /Users/sunxin/agentic-jailbreak-survey/worktrees/hb200-baselines/docs/figures/multisession_attack_framework.png (SHA-256 d10c13944540459b76e0262e488b97edc762a29008227f4bcf3ce31e87bc6c2b)</a:t>
             </a:r>
           </a:p>
           <a:p xmlns:a="http://schemas.openxmlformats.org/drawingml/2006/main">
             <a:r>
               <a:t>[/Sources]</a:t>
-            </a:r>
-          </a:p>
-          <a:p xmlns:a="http://schemas.openxmlformats.org/drawingml/2006/main">
-            <a:endParaRPr/>
-          </a:p>
-          <a:p xmlns:a="http://schemas.openxmlformats.org/drawingml/2006/main">
-            <a:r>
-              <a:t>Narrative: jailbreak is modeled as sequential policy learning over victim feedback, turns, and sessions.</a:t>
             </a:r>
           </a:p>
         </p:txBody>
@@ -2656,52 +2655,27 @@
           </a:p>
           <a:p xmlns:a="http://schemas.openxmlformats.org/drawingml/2006/main">
             <a:r>
-              <a:t>- https://yuque.antfin.com/fengyi.sx/kdssqn/qma7a55r6panppyy — final bilingual 27B result and comparison table, updated 2026-08-21.</a:t>
-            </a:r>
-          </a:p>
-          <a:p xmlns:a="http://schemas.openxmlformats.org/drawingml/2006/main">
-            <a:r>
-              <a:t>- Final step-240 re-evaluation: ASR@3 95.5% on Qwen3.5-122B-A10B, HarmBench core200, HarmBench-cls.</a:t>
-            </a:r>
-          </a:p>
-          <a:p xmlns:a="http://schemas.openxmlformats.org/drawingml/2006/main">
-            <a:r>
-              <a:t>- Heretic-122B zero-shot under the current harness: ASR@3 75.5%.</a:t>
-            </a:r>
-          </a:p>
-          <a:p xmlns:a="http://schemas.openxmlformats.org/drawingml/2006/main">
-            <a:r>
-              <a:t>- Historical pre-RL 27B reference: ASR@3 28.0% under a 5-turn/no-skill harness.</a:t>
+              <a:t>- Local result figure: /Users/sunxin/agentic-jailbreak-survey/assets/multiturn_attacker/yuque_defense/13-mix-training-before-after-zero-shot.png (SHA-256 d52ef16225ea713c79e67ab9128dec6d14432633a4725d4693461be038fd2fc8)</a:t>
+            </a:r>
+          </a:p>
+          <a:p xmlns:a="http://schemas.openxmlformats.org/drawingml/2006/main">
+            <a:r>
+              <a:t>- Evaluation shown in the figure: Qwen3.5-122B-A10B victim; HarmBench core200; HarmBench-cls; ASR@3.</a:t>
+            </a:r>
+          </a:p>
+          <a:p xmlns:a="http://schemas.openxmlformats.org/drawingml/2006/main">
+            <a:r>
+              <a:t>- Values shown: 27B historical before-RL reference 28.0%; 122B Heretic zero-shot under current harness 62.5%; bilingual 27B step240 final evaluation 95.5%.</a:t>
+            </a:r>
+          </a:p>
+          <a:p xmlns:a="http://schemas.openxmlformats.org/drawingml/2006/main">
+            <a:r>
+              <a:t>- Methodology caution: the 28.0% before-RL reference uses a historical 5-turn, no-skill harness. The +67.5 pp change is an end-to-end system difference, not a strict same-protocol pure-RL ablation.</a:t>
             </a:r>
           </a:p>
           <a:p xmlns:a="http://schemas.openxmlformats.org/drawingml/2006/main">
             <a:r>
               <a:t>[/Sources]</a:t>
-            </a:r>
-          </a:p>
-          <a:p xmlns:a="http://schemas.openxmlformats.org/drawingml/2006/main">
-            <a:r>
-              <a:t/>
-            </a:r>
-          </a:p>
-          <a:p xmlns:a="http://schemas.openxmlformats.org/drawingml/2006/main">
-            <a:r>
-              <a:t>[Caveat]</a:t>
-            </a:r>
-          </a:p>
-          <a:p xmlns:a="http://schemas.openxmlformats.org/drawingml/2006/main">
-            <a:r>
-              <a:t>- 96.8% is the online validation peak at step 240; 95.5% is the final checkpoint re-evaluation and is used as the main reported result.</a:t>
-            </a:r>
-          </a:p>
-          <a:p xmlns:a="http://schemas.openxmlformats.org/drawingml/2006/main">
-            <a:r>
-              <a:t>- The 28.0% pre-RL reference uses an older harness and is directional rather than a strict single-variable ablation.</a:t>
-            </a:r>
-          </a:p>
-          <a:p xmlns:a="http://schemas.openxmlformats.org/drawingml/2006/main">
-            <a:r>
-              <a:t>[/Caveat]</a:t>
             </a:r>
           </a:p>
         </p:txBody>
@@ -2846,6 +2820,231 @@
 </p:notes>
 </file>
 
+<file path=ppt/notesSlides/notesSlide35.xml><?xml version="1.0" encoding="utf-8"?>
+<p:notes xmlns:p="http://schemas.openxmlformats.org/presentationml/2006/main">
+  <p:cSld>
+    <p:spTree>
+      <p:nvGrpSpPr>
+        <p:cNvPr id="1" name=""/>
+        <p:cNvGrpSpPr/>
+        <p:nvPr/>
+      </p:nvGrpSpPr>
+      <p:grpSpPr>
+        <a:xfrm xmlns:a="http://schemas.openxmlformats.org/drawingml/2006/main"/>
+      </p:grpSpPr>
+      <p:sp>
+        <p:nvSpPr>
+          <p:cNvPr id="2" name="Slide Image Placeholder 1"/>
+          <p:cNvSpPr>
+            <a:spLocks xmlns:a="http://schemas.openxmlformats.org/drawingml/2006/main" noGrp="1"/>
+          </p:cNvSpPr>
+          <p:nvPr>
+            <p:ph type="sldImg" idx="0"/>
+          </p:nvPr>
+        </p:nvSpPr>
+        <p:spPr/>
+      </p:sp>
+      <p:sp>
+        <p:nvSpPr>
+          <p:cNvPr id="3" name="Notes Placeholder 2"/>
+          <p:cNvSpPr>
+            <a:spLocks xmlns:a="http://schemas.openxmlformats.org/drawingml/2006/main" noGrp="1"/>
+          </p:cNvSpPr>
+          <p:nvPr>
+            <p:ph type="body" idx="1"/>
+          </p:nvPr>
+        </p:nvSpPr>
+        <p:spPr/>
+        <p:txBody>
+          <a:bodyPr xmlns:a="http://schemas.openxmlformats.org/drawingml/2006/main"/>
+          <a:lstStyle xmlns:a="http://schemas.openxmlformats.org/drawingml/2006/main"/>
+          <a:p xmlns:a="http://schemas.openxmlformats.org/drawingml/2006/main">
+            <a:r>
+              <a:t>[Sources]</a:t>
+            </a:r>
+          </a:p>
+          <a:p xmlns:a="http://schemas.openxmlformats.org/drawingml/2006/main">
+            <a:r>
+              <a:t>- /Users/sunxin/agentic-jailbreak-survey/.codex_tmp/step-judge-analysis-latest/docs/oc_4victim_direct_4dataset.md — latest pulled direct single-turn baseline and canonical base27B skill multi-turn comparison, 2026-08-31.</a:t>
+            </a:r>
+          </a:p>
+          <a:p xmlns:a="http://schemas.openxmlformats.org/drawingml/2006/main">
+            <a:r>
+              <a:t>- HarmBench direct→multi victim macro: 1.85%→29.45%.</a:t>
+            </a:r>
+          </a:p>
+          <a:p xmlns:a="http://schemas.openxmlformats.org/drawingml/2006/main">
+            <a:r>
+              <a:t>- JailbreakBench direct→multi victim macro: 1.425%→26.75%.</a:t>
+            </a:r>
+          </a:p>
+          <a:p xmlns:a="http://schemas.openxmlformats.org/drawingml/2006/main">
+            <a:r>
+              <a:t>- StrongREJECT direct→multi victim macro: 0.30%→23.80%.</a:t>
+            </a:r>
+          </a:p>
+          <a:p xmlns:a="http://schemas.openxmlformats.org/drawingml/2006/main">
+            <a:r>
+              <a:t>[/Sources]</a:t>
+            </a:r>
+          </a:p>
+          <a:p xmlns:a="http://schemas.openxmlformats.org/drawingml/2006/main">
+            <a:r>
+              <a:t/>
+            </a:r>
+          </a:p>
+          <a:p xmlns:a="http://schemas.openxmlformats.org/drawingml/2006/main">
+            <a:r>
+              <a:t>[Calculation]</a:t>
+            </a:r>
+          </a:p>
+          <a:p xmlns:a="http://schemas.openxmlformats.org/drawingml/2006/main">
+            <a:r>
+              <a:t>- Across HB/JBB/SR × four victims: direct macro = 14.3/12 = 1.19%; multi-turn macro = 320.0/12 = 26.67%; uplift = 25.48pp; relative = 22.4×.</a:t>
+            </a:r>
+          </a:p>
+          <a:p xmlns:a="http://schemas.openxmlformats.org/drawingml/2006/main">
+            <a:r>
+              <a:t>[/Calculation]</a:t>
+            </a:r>
+          </a:p>
+          <a:p xmlns:a="http://schemas.openxmlformats.org/drawingml/2006/main">
+            <a:r>
+              <a:t/>
+            </a:r>
+          </a:p>
+          <a:p xmlns:a="http://schemas.openxmlformats.org/drawingml/2006/main">
+            <a:r>
+              <a:t>[Protocol]</a:t>
+            </a:r>
+          </a:p>
+          <a:p xmlns:a="http://schemas.openxmlformats.org/drawingml/2006/main">
+            <a:r>
+              <a:t>- Direct = objective sent verbatim once, without an attacker LLM. Multi-turn = canonical base27B skill arm. Errors count as failures.</a:t>
+            </a:r>
+          </a:p>
+          <a:p xmlns:a="http://schemas.openxmlformats.org/drawingml/2006/main">
+            <a:r>
+              <a:t>[/Protocol]</a:t>
+            </a:r>
+          </a:p>
+        </p:txBody>
+      </p:sp>
+      <p:sp>
+        <p:nvSpPr>
+          <p:cNvPr id="4" name="Slide Number Placeholder 3"/>
+          <p:cNvSpPr>
+            <a:spLocks xmlns:a="http://schemas.openxmlformats.org/drawingml/2006/main" noGrp="1"/>
+          </p:cNvSpPr>
+          <p:nvPr>
+            <p:ph type="sldNum" idx="5"/>
+          </p:nvPr>
+        </p:nvSpPr>
+        <p:spPr/>
+        <p:txBody>
+          <a:bodyPr xmlns:a="http://schemas.openxmlformats.org/drawingml/2006/main"/>
+          <a:lstStyle xmlns:a="http://schemas.openxmlformats.org/drawingml/2006/main"/>
+          <a:p xmlns:a="http://schemas.openxmlformats.org/drawingml/2006/main"/>
+        </p:txBody>
+      </p:sp>
+    </p:spTree>
+  </p:cSld>
+  <p:clrMapOvr>
+    <a:masterClrMapping xmlns:a="http://schemas.openxmlformats.org/drawingml/2006/main"/>
+  </p:clrMapOvr>
+</p:notes>
+</file>
+
+<file path=ppt/notesSlides/notesSlide36.xml><?xml version="1.0" encoding="utf-8"?>
+<p:notes xmlns:p="http://schemas.openxmlformats.org/presentationml/2006/main">
+  <p:cSld>
+    <p:spTree>
+      <p:nvGrpSpPr>
+        <p:cNvPr id="1" name=""/>
+        <p:cNvGrpSpPr/>
+        <p:nvPr/>
+      </p:nvGrpSpPr>
+      <p:grpSpPr>
+        <a:xfrm xmlns:a="http://schemas.openxmlformats.org/drawingml/2006/main"/>
+      </p:grpSpPr>
+      <p:sp>
+        <p:nvSpPr>
+          <p:cNvPr id="2" name="Slide Image Placeholder 1"/>
+          <p:cNvSpPr>
+            <a:spLocks xmlns:a="http://schemas.openxmlformats.org/drawingml/2006/main" noGrp="1"/>
+          </p:cNvSpPr>
+          <p:nvPr>
+            <p:ph type="sldImg" idx="0"/>
+          </p:nvPr>
+        </p:nvSpPr>
+        <p:spPr/>
+      </p:sp>
+      <p:sp>
+        <p:nvSpPr>
+          <p:cNvPr id="3" name="Notes Placeholder 2"/>
+          <p:cNvSpPr>
+            <a:spLocks xmlns:a="http://schemas.openxmlformats.org/drawingml/2006/main" noGrp="1"/>
+          </p:cNvSpPr>
+          <p:nvPr>
+            <p:ph type="body" idx="1"/>
+          </p:nvPr>
+        </p:nvSpPr>
+        <p:spPr/>
+        <p:txBody>
+          <a:bodyPr xmlns:a="http://schemas.openxmlformats.org/drawingml/2006/main"/>
+          <a:lstStyle xmlns:a="http://schemas.openxmlformats.org/drawingml/2006/main"/>
+          <a:p xmlns:a="http://schemas.openxmlformats.org/drawingml/2006/main">
+            <a:r>
+              <a:t>[Sources]</a:t>
+            </a:r>
+          </a:p>
+          <a:p xmlns:a="http://schemas.openxmlformats.org/drawingml/2006/main">
+            <a:r>
+              <a:t>- /Users/sunxin/agentic-jailbreak-survey/reports/yuque_section4_restructured.md — pure-English 27B held-out cross-dataset results.</a:t>
+            </a:r>
+          </a:p>
+          <a:p xmlns:a="http://schemas.openxmlformats.org/drawingml/2006/main">
+            <a:r>
+              <a:t>- /Users/sunxin/agentic-jailbreak-survey/assets/multiturn_attacker/yuque_defense/20-english27b-cross-dataset-zh.png — chart generated from the reported values.</a:t>
+            </a:r>
+          </a:p>
+          <a:p xmlns:a="http://schemas.openxmlformats.org/drawingml/2006/main">
+            <a:r>
+              <a:t>- HarmBench core200: 95.5% ASR@3; JailbreakBench: 93.8%; StrongREJECT: 96.0%.</a:t>
+            </a:r>
+          </a:p>
+          <a:p xmlns:a="http://schemas.openxmlformats.org/drawingml/2006/main">
+            <a:r>
+              <a:t>[/Sources]</a:t>
+            </a:r>
+          </a:p>
+        </p:txBody>
+      </p:sp>
+      <p:sp>
+        <p:nvSpPr>
+          <p:cNvPr id="4" name="Slide Number Placeholder 3"/>
+          <p:cNvSpPr>
+            <a:spLocks xmlns:a="http://schemas.openxmlformats.org/drawingml/2006/main" noGrp="1"/>
+          </p:cNvSpPr>
+          <p:nvPr>
+            <p:ph type="sldNum" idx="5"/>
+          </p:nvPr>
+        </p:nvSpPr>
+        <p:spPr/>
+        <p:txBody>
+          <a:bodyPr xmlns:a="http://schemas.openxmlformats.org/drawingml/2006/main"/>
+          <a:lstStyle xmlns:a="http://schemas.openxmlformats.org/drawingml/2006/main"/>
+          <a:p xmlns:a="http://schemas.openxmlformats.org/drawingml/2006/main"/>
+        </p:txBody>
+      </p:sp>
+    </p:spTree>
+  </p:cSld>
+  <p:clrMapOvr>
+    <a:masterClrMapping xmlns:a="http://schemas.openxmlformats.org/drawingml/2006/main"/>
+  </p:clrMapOvr>
+</p:notes>
+</file>
+
 <file path=ppt/notesSlides/notesSlide4.xml><?xml version="1.0" encoding="utf-8"?>
 <p:notes xmlns:p="http://schemas.openxmlformats.org/presentationml/2006/main">
   <p:cSld>
@@ -2891,7 +3090,7 @@
           </a:p>
           <a:p xmlns:a="http://schemas.openxmlformats.org/drawingml/2006/main">
             <a:r>
-              <a:t>- User-provided publication timeline and primary paper sequence.</a:t>
+              <a:t>- User-provided publication timeline update, 2026-08-31: GAPD accepted to EMNLP 2026 Findings; TKDE paper is student-first-author work.</a:t>
             </a:r>
           </a:p>
           <a:p xmlns:a="http://schemas.openxmlformats.org/drawingml/2006/main">
@@ -3364,7 +3563,7 @@
   </p:cSld>
   <p:clrMap bg1="lt1" tx1="dk1" bg2="lt2" tx2="dk2" accent1="accent1" accent2="accent2" accent3="accent3" accent4="accent4" accent5="accent5" accent6="accent6" hlink="hlink" folHlink="folHlink"/>
   <p:sldLayoutIdLst>
-    <p:sldLayoutId xmlns:r="http://schemas.openxmlformats.org/officeDocument/2006/relationships" id="2147483649" r:id="R4720bd69e107484f"/>
+    <p:sldLayoutId xmlns:r="http://schemas.openxmlformats.org/officeDocument/2006/relationships" id="2147483649" r:id="R2447a51243f5420a"/>
   </p:sldLayoutIdLst>
   <p:txStyles>
     <p:titleStyle>
@@ -4694,274 +4893,6 @@
 <file path=ppt/slides/charts/chart4.xml><?xml version="1.0" encoding="utf-8"?>
 <c:chartSpace xmlns:c="http://schemas.openxmlformats.org/drawingml/2006/chart">
   <c:lang val="en-US"/>
-  <c:chart>
-    <c:title>
-      <c:tx>
-        <c:rich>
-          <a:bodyPr xmlns:a="http://schemas.openxmlformats.org/drawingml/2006/main"/>
-          <a:lstStyle xmlns:a="http://schemas.openxmlformats.org/drawingml/2006/main"/>
-          <a:p xmlns:a="http://schemas.openxmlformats.org/drawingml/2006/main">
-            <a:r>
-              <a:rPr sz="1125" b="1">
-                <a:solidFill>
-                  <a:srgbClr val="1F2937"/>
-                </a:solidFill>
-              </a:rPr>
-              <a:t>Qwen3.5-122B · HarmBench core200 · ASR@3</a:t>
-            </a:r>
-          </a:p>
-        </c:rich>
-      </c:tx>
-      <c:overlay val="0"/>
-      <c:txPr>
-        <a:bodyPr xmlns:a="http://schemas.openxmlformats.org/drawingml/2006/main" anchorCtr="1"/>
-        <a:lstStyle xmlns:a="http://schemas.openxmlformats.org/drawingml/2006/main"/>
-        <a:p xmlns:a="http://schemas.openxmlformats.org/drawingml/2006/main">
-          <a:pPr>
-            <a:defRPr sz="1125" b="1">
-              <a:solidFill>
-                <a:srgbClr val="1F2937"/>
-              </a:solidFill>
-            </a:defRPr>
-          </a:pPr>
-        </a:p>
-      </c:txPr>
-    </c:title>
-    <c:plotArea>
-      <c:barChart>
-        <c:barDir val="col"/>
-        <c:grouping val="clustered"/>
-        <c:varyColors val="1"/>
-        <c:ser>
-          <c:idx val="0"/>
-          <c:order val="0"/>
-          <c:tx>
-            <c:v>ASR@3</c:v>
-          </c:tx>
-          <c:dPt>
-            <c:idx val="0"/>
-            <c:invertIfNegative val="0"/>
-            <c:spPr>
-              <a:solidFill xmlns:a="http://schemas.openxmlformats.org/drawingml/2006/main">
-                <a:srgbClr val="9AA6B8"/>
-              </a:solidFill>
-            </c:spPr>
-          </c:dPt>
-          <c:dPt>
-            <c:idx val="1"/>
-            <c:invertIfNegative val="0"/>
-            <c:spPr>
-              <a:solidFill xmlns:a="http://schemas.openxmlformats.org/drawingml/2006/main">
-                <a:srgbClr val="F59E0B"/>
-              </a:solidFill>
-            </c:spPr>
-          </c:dPt>
-          <c:dPt>
-            <c:idx val="2"/>
-            <c:invertIfNegative val="0"/>
-            <c:spPr>
-              <a:solidFill xmlns:a="http://schemas.openxmlformats.org/drawingml/2006/main">
-                <a:srgbClr val="2F6DF6"/>
-              </a:solidFill>
-            </c:spPr>
-          </c:dPt>
-          <c:cat>
-            <c:strLit>
-              <c:ptCount val="3"/>
-              <c:pt idx="0">
-                <c:v>27B before RL</c:v>
-              </c:pt>
-              <c:pt idx="1">
-                <c:v>Heretic-122B
-zero-shot</c:v>
-              </c:pt>
-              <c:pt idx="2">
-                <c:v>27B bilingual RL</c:v>
-              </c:pt>
-            </c:strLit>
-          </c:cat>
-          <c:val>
-            <c:numLit>
-              <c:formatCode>0</c:formatCode>
-              <c:ptCount val="3"/>
-              <c:pt idx="0">
-                <c:v>28</c:v>
-              </c:pt>
-              <c:pt idx="1">
-                <c:v>75.5</c:v>
-              </c:pt>
-              <c:pt idx="2">
-                <c:v>95.5</c:v>
-              </c:pt>
-            </c:numLit>
-          </c:val>
-        </c:ser>
-        <c:dLbls>
-          <c:txPr>
-            <a:bodyPr xmlns:a="http://schemas.openxmlformats.org/drawingml/2006/main" anchorCtr="1"/>
-            <a:lstStyle xmlns:a="http://schemas.openxmlformats.org/drawingml/2006/main"/>
-            <a:p xmlns:a="http://schemas.openxmlformats.org/drawingml/2006/main">
-              <a:pPr>
-                <a:defRPr sz="825" b="1">
-                  <a:solidFill>
-                    <a:srgbClr val="1F2937"/>
-                  </a:solidFill>
-                </a:defRPr>
-              </a:pPr>
-            </a:p>
-          </c:txPr>
-          <c:dLblPos val="outEnd"/>
-          <c:showLegendKey val="0"/>
-          <c:showVal val="1"/>
-          <c:showCatName val="0"/>
-          <c:showSerName val="0"/>
-          <c:showPercent val="0"/>
-          <c:showBubbleSize val="0"/>
-          <c:showLeaderLines val="0"/>
-        </c:dLbls>
-        <c:gapWidth val="75"/>
-        <c:axId val="48650112"/>
-        <c:axId val="48672768"/>
-      </c:barChart>
-      <c:catAx>
-        <c:axId val="48650112"/>
-        <c:scaling>
-          <c:orientation val="minMax"/>
-        </c:scaling>
-        <c:delete val="0"/>
-        <c:axPos val="b"/>
-        <c:numFmt formatCode="General"/>
-        <c:majorTickMark val="none"/>
-        <c:minorTickMark val="none"/>
-        <c:spPr>
-          <a:ln xmlns:a="http://schemas.openxmlformats.org/drawingml/2006/main" w="9525">
-            <a:solidFill>
-              <a:srgbClr val="AAB3C0"/>
-            </a:solidFill>
-            <a:prstDash val="solid"/>
-          </a:ln>
-        </c:spPr>
-        <c:txPr>
-          <a:bodyPr xmlns:a="http://schemas.openxmlformats.org/drawingml/2006/main" anchorCtr="1"/>
-          <a:lstStyle xmlns:a="http://schemas.openxmlformats.org/drawingml/2006/main"/>
-          <a:p xmlns:a="http://schemas.openxmlformats.org/drawingml/2006/main">
-            <a:pPr>
-              <a:defRPr sz="750" b="1">
-                <a:solidFill>
-                  <a:srgbClr val="374151"/>
-                </a:solidFill>
-              </a:defRPr>
-            </a:pPr>
-          </a:p>
-        </c:txPr>
-        <c:crossAx val="48672768"/>
-      </c:catAx>
-      <c:valAx>
-        <c:axId val="48672768"/>
-        <c:scaling>
-          <c:orientation val="minMax"/>
-          <c:max val="100"/>
-          <c:min val="0"/>
-        </c:scaling>
-        <c:delete val="0"/>
-        <c:axPos val="l"/>
-        <c:majorGridlines>
-          <c:spPr>
-            <a:ln xmlns:a="http://schemas.openxmlformats.org/drawingml/2006/main" w="9525">
-              <a:solidFill>
-                <a:srgbClr val="E5E7EB"/>
-              </a:solidFill>
-              <a:prstDash val="solid"/>
-            </a:ln>
-          </c:spPr>
-        </c:majorGridlines>
-        <c:title>
-          <c:tx>
-            <c:rich>
-              <a:bodyPr xmlns:a="http://schemas.openxmlformats.org/drawingml/2006/main"/>
-              <a:lstStyle xmlns:a="http://schemas.openxmlformats.org/drawingml/2006/main"/>
-              <a:p xmlns:a="http://schemas.openxmlformats.org/drawingml/2006/main">
-                <a:r>
-                  <a:rPr sz="825">
-                    <a:solidFill>
-                      <a:srgbClr val="374151"/>
-                    </a:solidFill>
-                  </a:rPr>
-                  <a:t>ASR@3 (%)</a:t>
-                </a:r>
-              </a:p>
-            </c:rich>
-          </c:tx>
-          <c:overlay val="0"/>
-          <c:txPr>
-            <a:bodyPr xmlns:a="http://schemas.openxmlformats.org/drawingml/2006/main" anchorCtr="1"/>
-            <a:lstStyle xmlns:a="http://schemas.openxmlformats.org/drawingml/2006/main"/>
-            <a:p xmlns:a="http://schemas.openxmlformats.org/drawingml/2006/main">
-              <a:pPr>
-                <a:defRPr sz="825">
-                  <a:solidFill>
-                    <a:srgbClr val="374151"/>
-                  </a:solidFill>
-                </a:defRPr>
-              </a:pPr>
-            </a:p>
-          </c:txPr>
-        </c:title>
-        <c:numFmt formatCode="0"/>
-        <c:majorTickMark val="none"/>
-        <c:minorTickMark val="none"/>
-        <c:spPr>
-          <a:ln xmlns:a="http://schemas.openxmlformats.org/drawingml/2006/main" w="9525">
-            <a:solidFill>
-              <a:srgbClr val="AAB3C0"/>
-            </a:solidFill>
-            <a:prstDash val="solid"/>
-          </a:ln>
-        </c:spPr>
-        <c:txPr>
-          <a:bodyPr xmlns:a="http://schemas.openxmlformats.org/drawingml/2006/main" anchorCtr="1"/>
-          <a:lstStyle xmlns:a="http://schemas.openxmlformats.org/drawingml/2006/main"/>
-          <a:p xmlns:a="http://schemas.openxmlformats.org/drawingml/2006/main">
-            <a:pPr>
-              <a:defRPr sz="750">
-                <a:solidFill>
-                  <a:srgbClr val="6B7280"/>
-                </a:solidFill>
-              </a:defRPr>
-            </a:pPr>
-          </a:p>
-        </c:txPr>
-        <c:crossAx val="48650112"/>
-        <c:crossBetween val="between"/>
-        <c:majorUnit val="20"/>
-      </c:valAx>
-      <c:spPr>
-        <a:solidFill xmlns:a="http://schemas.openxmlformats.org/drawingml/2006/main">
-          <a:srgbClr val="FFFFFF"/>
-        </a:solidFill>
-        <a:ln xmlns:a="http://schemas.openxmlformats.org/drawingml/2006/main" w="0">
-          <a:noFill/>
-          <a:prstDash val="solid"/>
-        </a:ln>
-      </c:spPr>
-    </c:plotArea>
-    <c:plotVisOnly val="1"/>
-  </c:chart>
-  <c:spPr>
-    <a:solidFill xmlns:a="http://schemas.openxmlformats.org/drawingml/2006/main">
-      <a:srgbClr val="FFFFFF"/>
-    </a:solidFill>
-    <a:ln xmlns:a="http://schemas.openxmlformats.org/drawingml/2006/main" w="0">
-      <a:noFill/>
-      <a:prstDash val="solid"/>
-    </a:ln>
-  </c:spPr>
-</c:chartSpace>
-</file>
-
-<file path=ppt/slides/charts/chart5.xml><?xml version="1.0" encoding="utf-8"?>
-<c:chartSpace xmlns:c="http://schemas.openxmlformats.org/drawingml/2006/chart">
-  <c:lang val="en-US"/>
   <c:roundedCorners val="1"/>
   <c:style val="2"/>
   <c:chart>
@@ -5257,6 +5188,276 @@
 </c:chartSpace>
 </file>
 
+<file path=ppt/slides/charts/chart5.xml><?xml version="1.0" encoding="utf-8"?>
+<c:chartSpace xmlns:c="http://schemas.openxmlformats.org/drawingml/2006/chart">
+  <c:lang val="en-US"/>
+  <c:chart>
+    <c:title>
+      <c:tx>
+        <c:rich>
+          <a:bodyPr xmlns:a="http://schemas.openxmlformats.org/drawingml/2006/main"/>
+          <a:lstStyle xmlns:a="http://schemas.openxmlformats.org/drawingml/2006/main"/>
+          <a:p xmlns:a="http://schemas.openxmlformats.org/drawingml/2006/main">
+            <a:r>
+              <a:rPr sz="900" b="1">
+                <a:solidFill>
+                  <a:srgbClr val="334155"/>
+                </a:solidFill>
+              </a:rPr>
+              <a:t>Victim macro ASR (%) · 4 victims per dataset</a:t>
+            </a:r>
+          </a:p>
+        </c:rich>
+      </c:tx>
+      <c:overlay val="0"/>
+      <c:txPr>
+        <a:bodyPr xmlns:a="http://schemas.openxmlformats.org/drawingml/2006/main" anchorCtr="1"/>
+        <a:lstStyle xmlns:a="http://schemas.openxmlformats.org/drawingml/2006/main"/>
+        <a:p xmlns:a="http://schemas.openxmlformats.org/drawingml/2006/main">
+          <a:pPr>
+            <a:defRPr sz="900" b="1">
+              <a:solidFill>
+                <a:srgbClr val="334155"/>
+              </a:solidFill>
+            </a:defRPr>
+          </a:pPr>
+        </a:p>
+      </c:txPr>
+    </c:title>
+    <c:plotArea>
+      <c:barChart>
+        <c:barDir val="bar"/>
+        <c:grouping val="clustered"/>
+        <c:varyColors val="0"/>
+        <c:ser>
+          <c:idx val="0"/>
+          <c:order val="0"/>
+          <c:tx>
+            <c:v>Direct</c:v>
+          </c:tx>
+          <c:spPr>
+            <a:solidFill xmlns:a="http://schemas.openxmlformats.org/drawingml/2006/main">
+              <a:srgbClr val="CBD5E1"/>
+            </a:solidFill>
+          </c:spPr>
+          <c:cat>
+            <c:strLit>
+              <c:ptCount val="3"/>
+              <c:pt idx="0">
+                <c:v>HarmBench</c:v>
+              </c:pt>
+              <c:pt idx="1">
+                <c:v>JailbreakBench</c:v>
+              </c:pt>
+              <c:pt idx="2">
+                <c:v>StrongREJECT</c:v>
+              </c:pt>
+            </c:strLit>
+          </c:cat>
+          <c:val>
+            <c:numLit>
+              <c:formatCode>0.0</c:formatCode>
+              <c:ptCount val="3"/>
+              <c:pt idx="0">
+                <c:v>1.85</c:v>
+              </c:pt>
+              <c:pt idx="1">
+                <c:v>1.425</c:v>
+              </c:pt>
+              <c:pt idx="2">
+                <c:v>0.3</c:v>
+              </c:pt>
+            </c:numLit>
+          </c:val>
+        </c:ser>
+        <c:ser>
+          <c:idx val="1"/>
+          <c:order val="1"/>
+          <c:tx>
+            <c:v>Multi-turn</c:v>
+          </c:tx>
+          <c:spPr>
+            <a:solidFill xmlns:a="http://schemas.openxmlformats.org/drawingml/2006/main">
+              <a:srgbClr val="2F6DF6"/>
+            </a:solidFill>
+          </c:spPr>
+          <c:cat>
+            <c:strLit>
+              <c:ptCount val="3"/>
+              <c:pt idx="0">
+                <c:v>HarmBench</c:v>
+              </c:pt>
+              <c:pt idx="1">
+                <c:v>JailbreakBench</c:v>
+              </c:pt>
+              <c:pt idx="2">
+                <c:v>StrongREJECT</c:v>
+              </c:pt>
+            </c:strLit>
+          </c:cat>
+          <c:val>
+            <c:numLit>
+              <c:formatCode>0.0</c:formatCode>
+              <c:ptCount val="3"/>
+              <c:pt idx="0">
+                <c:v>29.45</c:v>
+              </c:pt>
+              <c:pt idx="1">
+                <c:v>26.75</c:v>
+              </c:pt>
+              <c:pt idx="2">
+                <c:v>23.8</c:v>
+              </c:pt>
+            </c:numLit>
+          </c:val>
+        </c:ser>
+        <c:dLbls>
+          <c:txPr>
+            <a:bodyPr xmlns:a="http://schemas.openxmlformats.org/drawingml/2006/main" anchorCtr="1"/>
+            <a:lstStyle xmlns:a="http://schemas.openxmlformats.org/drawingml/2006/main"/>
+            <a:p xmlns:a="http://schemas.openxmlformats.org/drawingml/2006/main">
+              <a:pPr>
+                <a:defRPr sz="750" b="1">
+                  <a:solidFill>
+                    <a:srgbClr val="1F2937"/>
+                  </a:solidFill>
+                </a:defRPr>
+              </a:pPr>
+            </a:p>
+          </c:txPr>
+          <c:dLblPos val="outEnd"/>
+          <c:showLegendKey val="0"/>
+          <c:showVal val="1"/>
+          <c:showCatName val="0"/>
+          <c:showSerName val="0"/>
+          <c:showPercent val="0"/>
+          <c:showBubbleSize val="0"/>
+          <c:showLeaderLines val="0"/>
+        </c:dLbls>
+        <c:gapWidth val="48"/>
+        <c:axId val="48650112"/>
+        <c:axId val="48672768"/>
+      </c:barChart>
+      <c:catAx>
+        <c:axId val="48650112"/>
+        <c:scaling>
+          <c:orientation val="minMax"/>
+        </c:scaling>
+        <c:delete val="0"/>
+        <c:axPos val="l"/>
+        <c:majorGridlines>
+          <c:spPr>
+            <a:ln xmlns:a="http://schemas.openxmlformats.org/drawingml/2006/main" w="9525">
+              <a:solidFill>
+                <a:srgbClr val="E2E8F0"/>
+              </a:solidFill>
+              <a:prstDash val="solid"/>
+            </a:ln>
+          </c:spPr>
+        </c:majorGridlines>
+        <c:numFmt formatCode="0&quot;%&quot;"/>
+        <c:majorTickMark val="none"/>
+        <c:minorTickMark val="none"/>
+        <c:spPr>
+          <a:ln xmlns:a="http://schemas.openxmlformats.org/drawingml/2006/main" w="9525">
+            <a:solidFill>
+              <a:srgbClr val="CBD5E1"/>
+            </a:solidFill>
+            <a:prstDash val="solid"/>
+          </a:ln>
+        </c:spPr>
+        <c:txPr>
+          <a:bodyPr xmlns:a="http://schemas.openxmlformats.org/drawingml/2006/main" anchorCtr="1"/>
+          <a:lstStyle xmlns:a="http://schemas.openxmlformats.org/drawingml/2006/main"/>
+          <a:p xmlns:a="http://schemas.openxmlformats.org/drawingml/2006/main">
+            <a:pPr>
+              <a:defRPr sz="750">
+                <a:solidFill>
+                  <a:srgbClr val="64748B"/>
+                </a:solidFill>
+              </a:defRPr>
+            </a:pPr>
+          </a:p>
+        </c:txPr>
+        <c:crossAx val="48672768"/>
+      </c:catAx>
+      <c:valAx>
+        <c:axId val="48672768"/>
+        <c:scaling>
+          <c:orientation val="minMax"/>
+        </c:scaling>
+        <c:delete val="0"/>
+        <c:axPos val="b"/>
+        <c:numFmt formatCode="General"/>
+        <c:majorTickMark val="none"/>
+        <c:minorTickMark val="none"/>
+        <c:spPr>
+          <a:ln xmlns:a="http://schemas.openxmlformats.org/drawingml/2006/main" w="9525">
+            <a:solidFill>
+              <a:srgbClr val="CBD5E1"/>
+            </a:solidFill>
+            <a:prstDash val="solid"/>
+          </a:ln>
+        </c:spPr>
+        <c:txPr>
+          <a:bodyPr xmlns:a="http://schemas.openxmlformats.org/drawingml/2006/main" anchorCtr="1"/>
+          <a:lstStyle xmlns:a="http://schemas.openxmlformats.org/drawingml/2006/main"/>
+          <a:p xmlns:a="http://schemas.openxmlformats.org/drawingml/2006/main">
+            <a:pPr>
+              <a:defRPr sz="825" b="1">
+                <a:solidFill>
+                  <a:srgbClr val="334155"/>
+                </a:solidFill>
+              </a:defRPr>
+            </a:pPr>
+          </a:p>
+        </c:txPr>
+        <c:crossAx val="48650112"/>
+        <c:crossBetween val="between"/>
+      </c:valAx>
+      <c:spPr>
+        <a:noFill xmlns:a="http://schemas.openxmlformats.org/drawingml/2006/main"/>
+        <a:ln xmlns:a="http://schemas.openxmlformats.org/drawingml/2006/main" w="0">
+          <a:solidFill>
+            <a:srgbClr val="FFFFFF"/>
+          </a:solidFill>
+          <a:prstDash val="solid"/>
+        </a:ln>
+      </c:spPr>
+    </c:plotArea>
+    <c:legend>
+      <c:legendPos val="b"/>
+      <c:overlay val="0"/>
+      <c:txPr>
+        <a:bodyPr xmlns:a="http://schemas.openxmlformats.org/drawingml/2006/main" anchorCtr="1"/>
+        <a:lstStyle xmlns:a="http://schemas.openxmlformats.org/drawingml/2006/main"/>
+        <a:p xmlns:a="http://schemas.openxmlformats.org/drawingml/2006/main">
+          <a:pPr>
+            <a:defRPr sz="750">
+              <a:solidFill>
+                <a:srgbClr val="475569"/>
+              </a:solidFill>
+            </a:defRPr>
+          </a:pPr>
+        </a:p>
+      </c:txPr>
+    </c:legend>
+    <c:plotVisOnly val="1"/>
+  </c:chart>
+  <c:spPr>
+    <a:solidFill xmlns:a="http://schemas.openxmlformats.org/drawingml/2006/main">
+      <a:srgbClr val="FFFFFF"/>
+    </a:solidFill>
+    <a:ln xmlns:a="http://schemas.openxmlformats.org/drawingml/2006/main" w="0">
+      <a:solidFill>
+        <a:srgbClr val="FFFFFF"/>
+      </a:solidFill>
+      <a:prstDash val="solid"/>
+    </a:ln>
+  </c:spPr>
+</c:chartSpace>
+</file>
+
 <file path=ppt/slides/slide1.xml><?xml version="1.0" encoding="utf-8"?>
 <p:sld xmlns:p="http://schemas.openxmlformats.org/presentationml/2006/main">
   <p:cSld>
@@ -6431,7 +6632,7 @@
           <p:nvPr/>
         </p:nvPicPr>
         <p:blipFill>
-          <a:blip xmlns:r="http://schemas.openxmlformats.org/officeDocument/2006/relationships" xmlns:a="http://schemas.openxmlformats.org/drawingml/2006/main" r:embed="Rd3d88eabbbeb40de"/>
+          <a:blip xmlns:r="http://schemas.openxmlformats.org/officeDocument/2006/relationships" xmlns:a="http://schemas.openxmlformats.org/drawingml/2006/main" r:embed="Rdefdf3fc2b4b436f"/>
           <a:stretch xmlns:a="http://schemas.openxmlformats.org/drawingml/2006/main">
             <a:fillRect l="0" t="0" r="0" b="0"/>
           </a:stretch>
@@ -6803,7 +7004,7 @@
       </p:sp>
       <p:cxnSp>
         <p:nvCxnSpPr>
-          <p:cNvPr id="370" name="rule"/>
+          <p:cNvPr id="510" name="rule"/>
           <p:cNvCxnSpPr/>
           <p:nvPr/>
         </p:nvCxnSpPr>
@@ -6943,7 +7144,7 @@
       </p:sp>
       <p:cxnSp>
         <p:nvCxnSpPr>
-          <p:cNvPr id="373" name="rule"/>
+          <p:cNvPr id="513" name="rule"/>
           <p:cNvCxnSpPr/>
           <p:nvPr/>
         </p:nvCxnSpPr>
@@ -7083,7 +7284,7 @@
       </p:sp>
       <p:cxnSp>
         <p:nvCxnSpPr>
-          <p:cNvPr id="376" name="rule"/>
+          <p:cNvPr id="516" name="rule"/>
           <p:cNvCxnSpPr/>
           <p:nvPr/>
         </p:nvCxnSpPr>
@@ -7313,14 +7514,14 @@
       </p:sp>
       <p:pic>
         <p:nvPicPr>
-          <p:cNvPr id="381" name="图片 4"/>
+          <p:cNvPr id="521" name="图片 4"/>
           <p:cNvPicPr>
             <a:picLocks xmlns:a="http://schemas.openxmlformats.org/drawingml/2006/main" noChangeAspect="1"/>
           </p:cNvPicPr>
           <p:nvPr/>
         </p:nvPicPr>
         <p:blipFill>
-          <a:blip xmlns:r="http://schemas.openxmlformats.org/officeDocument/2006/relationships" xmlns:a="http://schemas.openxmlformats.org/drawingml/2006/main" r:embed="R657c69b59dd941e5"/>
+          <a:blip xmlns:r="http://schemas.openxmlformats.org/officeDocument/2006/relationships" xmlns:a="http://schemas.openxmlformats.org/drawingml/2006/main" r:embed="R346a25df8e6b4a00"/>
           <a:stretch xmlns:a="http://schemas.openxmlformats.org/drawingml/2006/main">
             <a:fillRect l="0" t="0" r="0" b="0"/>
           </a:stretch>
@@ -8092,7 +8293,7 @@
           <p:nvPr/>
         </p:nvPicPr>
         <p:blipFill>
-          <a:blip xmlns:r="http://schemas.openxmlformats.org/officeDocument/2006/relationships" xmlns:a="http://schemas.openxmlformats.org/drawingml/2006/main" r:embed="R7e6dddab311b4811"/>
+          <a:blip xmlns:r="http://schemas.openxmlformats.org/officeDocument/2006/relationships" xmlns:a="http://schemas.openxmlformats.org/drawingml/2006/main" r:embed="Rfd256c15ada54995"/>
           <a:stretch xmlns:a="http://schemas.openxmlformats.org/drawingml/2006/main"/>
         </p:blipFill>
         <p:spPr>
@@ -8368,7 +8569,7 @@
       </p:sp>
       <p:cxnSp>
         <p:nvCxnSpPr>
-          <p:cNvPr id="163" name="rule"/>
+          <p:cNvPr id="213" name="rule"/>
           <p:cNvCxnSpPr/>
           <p:nvPr/>
         </p:nvCxnSpPr>
@@ -13161,7 +13362,7 @@
           <p:nvPr/>
         </p:nvPicPr>
         <p:blipFill>
-          <a:blip xmlns:r="http://schemas.openxmlformats.org/officeDocument/2006/relationships" xmlns:a="http://schemas.openxmlformats.org/drawingml/2006/main" r:embed="R685f2d34e88544ad"/>
+          <a:blip xmlns:r="http://schemas.openxmlformats.org/officeDocument/2006/relationships" xmlns:a="http://schemas.openxmlformats.org/drawingml/2006/main" r:embed="Rb022e874f15c4698"/>
           <a:stretch xmlns:a="http://schemas.openxmlformats.org/drawingml/2006/main"/>
         </p:blipFill>
         <p:spPr>
@@ -14163,7 +14364,7 @@
         </p:xfrm>
         <a:graphic xmlns:a="http://schemas.openxmlformats.org/drawingml/2006/main">
           <a:graphicData uri="http://schemas.openxmlformats.org/drawingml/2006/chart">
-            <c:chart xmlns:r="http://schemas.openxmlformats.org/officeDocument/2006/relationships" xmlns:c="http://schemas.openxmlformats.org/drawingml/2006/chart" r:id="R70879309485f4202"/>
+            <c:chart xmlns:r="http://schemas.openxmlformats.org/officeDocument/2006/relationships" xmlns:c="http://schemas.openxmlformats.org/drawingml/2006/chart" r:id="R3e6c0794c7794bf2"/>
           </a:graphicData>
         </a:graphic>
       </p:graphicFrame>
@@ -17789,7 +17990,7 @@
       </p:sp>
       <p:cxnSp>
         <p:nvCxnSpPr>
-          <p:cNvPr id="356" name="rule"/>
+          <p:cNvPr id="496" name="rule"/>
           <p:cNvCxnSpPr/>
           <p:nvPr/>
         </p:nvCxnSpPr>
@@ -17929,7 +18130,7 @@
       </p:sp>
       <p:cxnSp>
         <p:nvCxnSpPr>
-          <p:cNvPr id="359" name="rule"/>
+          <p:cNvPr id="499" name="rule"/>
           <p:cNvCxnSpPr/>
           <p:nvPr/>
         </p:nvCxnSpPr>
@@ -18069,7 +18270,7 @@
       </p:sp>
       <p:cxnSp>
         <p:nvCxnSpPr>
-          <p:cNvPr id="362" name="rule"/>
+          <p:cNvPr id="502" name="rule"/>
           <p:cNvCxnSpPr/>
           <p:nvPr/>
         </p:nvCxnSpPr>
@@ -18209,7 +18410,7 @@
       </p:sp>
       <p:cxnSp>
         <p:nvCxnSpPr>
-          <p:cNvPr id="365" name="rule"/>
+          <p:cNvPr id="505" name="rule"/>
           <p:cNvCxnSpPr/>
           <p:nvPr/>
         </p:nvCxnSpPr>
@@ -18689,7 +18890,7 @@
       </p:sp>
       <p:cxnSp>
         <p:nvCxnSpPr>
-          <p:cNvPr id="174" name="rule"/>
+          <p:cNvPr id="234" name="rule"/>
           <p:cNvCxnSpPr/>
           <p:nvPr/>
         </p:nvCxnSpPr>
@@ -21565,14 +21766,14 @@
       </p:sp>
       <p:pic>
         <p:nvPicPr>
-          <p:cNvPr id="385" name="图片 114"/>
+          <p:cNvPr id="535" name="图片 114"/>
           <p:cNvPicPr>
             <a:picLocks xmlns:a="http://schemas.openxmlformats.org/drawingml/2006/main" noChangeAspect="1"/>
           </p:cNvPicPr>
           <p:nvPr/>
         </p:nvPicPr>
         <p:blipFill>
-          <a:blip xmlns:r="http://schemas.openxmlformats.org/officeDocument/2006/relationships" xmlns:a="http://schemas.openxmlformats.org/drawingml/2006/main" r:embed="R10f14771277c4376"/>
+          <a:blip xmlns:r="http://schemas.openxmlformats.org/officeDocument/2006/relationships" xmlns:a="http://schemas.openxmlformats.org/drawingml/2006/main" r:embed="R9de8f4a552e642c6"/>
           <a:stretch xmlns:a="http://schemas.openxmlformats.org/drawingml/2006/main"/>
         </p:blipFill>
         <p:spPr>
@@ -21766,7 +21967,7 @@
       </p:sp>
       <p:cxnSp>
         <p:nvCxnSpPr>
-          <p:cNvPr id="389" name="rule"/>
+          <p:cNvPr id="539" name="rule"/>
           <p:cNvCxnSpPr/>
           <p:nvPr/>
         </p:nvCxnSpPr>
@@ -22086,7 +22287,7 @@
       </p:sp>
       <p:cxnSp>
         <p:nvCxnSpPr>
-          <p:cNvPr id="393" name="rule"/>
+          <p:cNvPr id="543" name="rule"/>
           <p:cNvCxnSpPr/>
           <p:nvPr/>
         </p:nvCxnSpPr>
@@ -22748,7 +22949,7 @@
         </p:xfrm>
         <a:graphic xmlns:a="http://schemas.openxmlformats.org/drawingml/2006/main">
           <a:graphicData uri="http://schemas.openxmlformats.org/drawingml/2006/chart">
-            <c:chart xmlns:r="http://schemas.openxmlformats.org/officeDocument/2006/relationships" xmlns:c="http://schemas.openxmlformats.org/drawingml/2006/chart" r:id="R69d69cad9bfd43ed"/>
+            <c:chart xmlns:r="http://schemas.openxmlformats.org/officeDocument/2006/relationships" xmlns:c="http://schemas.openxmlformats.org/drawingml/2006/chart" r:id="R05726e1bee844579"/>
           </a:graphicData>
         </a:graphic>
       </p:graphicFrame>
@@ -24950,7 +25151,7 @@
           <p:nvPr/>
         </p:nvPicPr>
         <p:blipFill>
-          <a:blip xmlns:r="http://schemas.openxmlformats.org/officeDocument/2006/relationships" xmlns:a="http://schemas.openxmlformats.org/drawingml/2006/main" r:embed="R9d94d88520e641d9"/>
+          <a:blip xmlns:r="http://schemas.openxmlformats.org/officeDocument/2006/relationships" xmlns:a="http://schemas.openxmlformats.org/drawingml/2006/main" r:embed="Rcb0499354ac44a4f"/>
           <a:stretch xmlns:a="http://schemas.openxmlformats.org/drawingml/2006/main"/>
         </p:blipFill>
         <p:spPr>
@@ -26688,7 +26889,7 @@
           <p:nvPr/>
         </p:nvPicPr>
         <p:blipFill>
-          <a:blip xmlns:r="http://schemas.openxmlformats.org/officeDocument/2006/relationships" xmlns:a="http://schemas.openxmlformats.org/drawingml/2006/main" r:embed="Rcb33da9f54ec48a3"/>
+          <a:blip xmlns:r="http://schemas.openxmlformats.org/officeDocument/2006/relationships" xmlns:a="http://schemas.openxmlformats.org/drawingml/2006/main" r:embed="Rd5c73961ffac4768"/>
           <a:stretch xmlns:a="http://schemas.openxmlformats.org/drawingml/2006/main">
             <a:fillRect l="0" t="0" r="0" b="0"/>
           </a:stretch>
@@ -27365,7 +27566,7 @@
           <p:nvPr/>
         </p:nvPicPr>
         <p:blipFill>
-          <a:blip xmlns:r="http://schemas.openxmlformats.org/officeDocument/2006/relationships" xmlns:a="http://schemas.openxmlformats.org/drawingml/2006/main" r:embed="R5a83eefb02f24f7c"/>
+          <a:blip xmlns:r="http://schemas.openxmlformats.org/officeDocument/2006/relationships" xmlns:a="http://schemas.openxmlformats.org/drawingml/2006/main" r:embed="Rb36b378b0ca24aad"/>
           <a:stretch xmlns:a="http://schemas.openxmlformats.org/drawingml/2006/main"/>
         </p:blipFill>
         <p:spPr>
@@ -29018,7 +29219,7 @@
       </p:sp>
       <p:graphicFrame>
         <p:nvGraphicFramePr>
-          <p:cNvPr id="482" name="Chart"/>
+          <p:cNvPr id="672" name="Chart"/>
           <p:cNvGraphicFramePr/>
           <p:nvPr/>
         </p:nvGraphicFramePr>
@@ -29028,7 +29229,7 @@
         </p:xfrm>
         <a:graphic xmlns:a="http://schemas.openxmlformats.org/drawingml/2006/main">
           <a:graphicData uri="http://schemas.openxmlformats.org/drawingml/2006/chart">
-            <c:chart xmlns:r="http://schemas.openxmlformats.org/officeDocument/2006/relationships" xmlns:c="http://schemas.openxmlformats.org/drawingml/2006/chart" r:id="R02f594a6e7304343"/>
+            <c:chart xmlns:r="http://schemas.openxmlformats.org/officeDocument/2006/relationships" xmlns:c="http://schemas.openxmlformats.org/drawingml/2006/chart" r:id="R3d8634c1956c4e09"/>
           </a:graphicData>
         </a:graphic>
       </p:graphicFrame>
@@ -29270,7 +29471,7 @@
       </p:sp>
       <p:cxnSp>
         <p:nvCxnSpPr>
-          <p:cNvPr id="487" name="rule"/>
+          <p:cNvPr id="677" name="rule"/>
           <p:cNvCxnSpPr/>
           <p:nvPr/>
         </p:nvCxnSpPr>
@@ -29469,7 +29670,7 @@
       </p:sp>
       <p:cxnSp>
         <p:nvCxnSpPr>
-          <p:cNvPr id="491" name="rule"/>
+          <p:cNvPr id="681" name="rule"/>
           <p:cNvCxnSpPr/>
           <p:nvPr/>
         </p:nvCxnSpPr>
@@ -29668,7 +29869,7 @@
       </p:sp>
       <p:cxnSp>
         <p:nvCxnSpPr>
-          <p:cNvPr id="495" name="rule"/>
+          <p:cNvPr id="685" name="rule"/>
           <p:cNvCxnSpPr/>
           <p:nvPr/>
         </p:nvCxnSpPr>
@@ -30399,7 +30600,7 @@
         </p:spPr>
         <p:txBody>
           <a:bodyPr xmlns:a="http://schemas.openxmlformats.org/drawingml/2006/main" wrap="square" lIns="0" tIns="0" rIns="0" bIns="0" anchor="t">
-            <a:normAutofit/>
+            <a:normAutofit fontScale="100000"/>
           </a:bodyPr>
           <a:lstStyle xmlns:a="http://schemas.openxmlformats.org/drawingml/2006/main"/>
           <a:p xmlns:a="http://schemas.openxmlformats.org/drawingml/2006/main">
@@ -30423,7 +30624,7 @@
                 <a:ea typeface="PingFang SC"/>
                 <a:cs typeface="PingFang SC"/>
               </a:rPr>
-              <a:t>覆盖 RAG、Agent RL、可靠评测</a:t>
+              <a:t>RAG / Agent RL</a:t>
             </a:r>
           </a:p>
         </p:txBody>
@@ -30489,7 +30690,7 @@
         </p:spPr>
         <p:txBody>
           <a:bodyPr xmlns:a="http://schemas.openxmlformats.org/drawingml/2006/main" wrap="square" lIns="0" tIns="0" rIns="0" bIns="0" anchor="t">
-            <a:normAutofit/>
+            <a:normAutofit fontScale="100000"/>
           </a:bodyPr>
           <a:lstStyle xmlns:a="http://schemas.openxmlformats.org/drawingml/2006/main"/>
           <a:p xmlns:a="http://schemas.openxmlformats.org/drawingml/2006/main">
@@ -30513,7 +30714,7 @@
                 <a:ea typeface="Helvetica Neue"/>
                 <a:cs typeface="Helvetica Neue"/>
               </a:rPr>
-              <a:t>6</a:t>
+              <a:t>7</a:t>
             </a:r>
           </a:p>
         </p:txBody>
@@ -30607,7 +30808,7 @@
         </p:spPr>
         <p:txBody>
           <a:bodyPr xmlns:a="http://schemas.openxmlformats.org/drawingml/2006/main" wrap="square" lIns="0" tIns="0" rIns="0" bIns="0" anchor="t">
-            <a:normAutofit/>
+            <a:normAutofit fontScale="100000"/>
           </a:bodyPr>
           <a:lstStyle xmlns:a="http://schemas.openxmlformats.org/drawingml/2006/main"/>
           <a:p xmlns:a="http://schemas.openxmlformats.org/drawingml/2006/main">
@@ -30631,7 +30832,8 @@
                 <a:ea typeface="PingFang SC"/>
                 <a:cs typeface="PingFang SC"/>
               </a:rPr>
-              <a:t>CCF-A 4 篇 · CCF-B 2 篇</a:t>
+              <a:t>CCF-A / TH-CPL A：6 篇
+CCF-B：1 篇</a:t>
             </a:r>
           </a:p>
         </p:txBody>
@@ -30697,7 +30899,7 @@
         </p:spPr>
         <p:txBody>
           <a:bodyPr xmlns:a="http://schemas.openxmlformats.org/drawingml/2006/main" wrap="square" lIns="0" tIns="0" rIns="0" bIns="0" anchor="t">
-            <a:normAutofit/>
+            <a:normAutofit fontScale="100000"/>
           </a:bodyPr>
           <a:lstStyle xmlns:a="http://schemas.openxmlformats.org/drawingml/2006/main"/>
           <a:p xmlns:a="http://schemas.openxmlformats.org/drawingml/2006/main">
@@ -30721,7 +30923,7 @@
                 <a:ea typeface="Helvetica Neue"/>
                 <a:cs typeface="Helvetica Neue"/>
               </a:rPr>
-              <a:t>3</a:t>
+              <a:t>2</a:t>
             </a:r>
           </a:p>
         </p:txBody>
@@ -30815,7 +31017,7 @@
         </p:spPr>
         <p:txBody>
           <a:bodyPr xmlns:a="http://schemas.openxmlformats.org/drawingml/2006/main" wrap="square" lIns="0" tIns="0" rIns="0" bIns="0" anchor="t">
-            <a:normAutofit/>
+            <a:normAutofit fontScale="100000"/>
           </a:bodyPr>
           <a:lstStyle xmlns:a="http://schemas.openxmlformats.org/drawingml/2006/main"/>
           <a:p xmlns:a="http://schemas.openxmlformats.org/drawingml/2006/main">
@@ -30839,7 +31041,7 @@
                 <a:ea typeface="PingFang SC"/>
                 <a:cs typeface="PingFang SC"/>
               </a:rPr>
-              <a:t>EMNLP 2026 · AAAI 2027 × 2</a:t>
+              <a:t>AAAI 2027 × 2</a:t>
             </a:r>
           </a:p>
         </p:txBody>
@@ -31200,7 +31402,7 @@
       </p:sp>
       <p:cxnSp>
         <p:nvCxnSpPr>
-          <p:cNvPr id="458" name="rule"/>
+          <p:cNvPr id="638" name="rule"/>
           <p:cNvCxnSpPr/>
           <p:nvPr/>
         </p:nvCxnSpPr>
@@ -31399,7 +31601,7 @@
       </p:sp>
       <p:cxnSp>
         <p:nvCxnSpPr>
-          <p:cNvPr id="462" name="rule"/>
+          <p:cNvPr id="642" name="rule"/>
           <p:cNvCxnSpPr/>
           <p:nvPr/>
         </p:nvCxnSpPr>
@@ -31598,7 +31800,7 @@
       </p:sp>
       <p:cxnSp>
         <p:nvCxnSpPr>
-          <p:cNvPr id="466" name="rule"/>
+          <p:cNvPr id="646" name="rule"/>
           <p:cNvCxnSpPr/>
           <p:nvPr/>
         </p:nvCxnSpPr>
@@ -31797,7 +31999,7 @@
       </p:sp>
       <p:cxnSp>
         <p:nvCxnSpPr>
-          <p:cNvPr id="470" name="rule"/>
+          <p:cNvPr id="650" name="rule"/>
           <p:cNvCxnSpPr/>
           <p:nvPr/>
         </p:nvCxnSpPr>
@@ -31966,10 +32168,10 @@
       </p:grpSpPr>
       <p:sp>
         <p:nvSpPr>
-          <p:cNvPr id="16" name="section-kicker">
-            <a:extLst xmlns:a="http://schemas.openxmlformats.org/drawingml/2006/main">
-              <a:ext uri="{FF2B5EF4-FFF2-40B4-BE49-F238E27FC236}">
-                <a16:creationId xmlns:a16="http://schemas.microsoft.com/office/drawing/2014/main" id="{C4275210-2F28-421E-B38C-FB3466FA8B45}"/>
+          <p:cNvPr id="17" name="section-kicker">
+            <a:extLst xmlns:a="http://schemas.openxmlformats.org/drawingml/2006/main">
+              <a:ext uri="{FF2B5EF4-FFF2-40B4-BE49-F238E27FC236}">
+                <a16:creationId xmlns:a16="http://schemas.microsoft.com/office/drawing/2014/main" id="{A07FB4AA-710F-4E87-AACA-77E3DAFAB71C}"/>
               </a:ext>
             </a:extLst>
           </p:cNvPr>
@@ -32018,7 +32220,7 @@
                 <a:ea typeface="Helvetica Neue"/>
                 <a:cs typeface="Helvetica Neue"/>
               </a:rPr>
-              <a:t>MULTI-TURN ATTACKER · POLICY LEARNING</a:t>
+              <a:t>MULTI-TURN ATTACKER · FRAMEWORK</a:t>
             </a:r>
           </a:p>
         </p:txBody>
@@ -32028,7 +32230,7 @@
           <p:cNvPr id="2" name="slide-title">
             <a:extLst xmlns:a="http://schemas.openxmlformats.org/drawingml/2006/main">
               <a:ext uri="{FF2B5EF4-FFF2-40B4-BE49-F238E27FC236}">
-                <a16:creationId xmlns:a16="http://schemas.microsoft.com/office/drawing/2014/main" id="{D404A63A-EA2B-464E-B166-4719055AB6AF}"/>
+                <a16:creationId xmlns:a16="http://schemas.microsoft.com/office/drawing/2014/main" id="{0AB68E79-FE67-4F15-8262-963D89D18C22}"/>
               </a:ext>
             </a:extLst>
           </p:cNvPr>
@@ -32053,7 +32255,7 @@
         </p:spPr>
         <p:txBody>
           <a:bodyPr xmlns:a="http://schemas.openxmlformats.org/drawingml/2006/main" wrap="square" lIns="0" tIns="0" rIns="0" bIns="0" anchor="t">
-            <a:normAutofit/>
+            <a:normAutofit fontScale="100000"/>
           </a:bodyPr>
           <a:lstStyle xmlns:a="http://schemas.openxmlformats.org/drawingml/2006/main"/>
           <a:p xmlns:a="http://schemas.openxmlformats.org/drawingml/2006/main">
@@ -32087,7 +32289,7 @@
           <p:cNvPr id="3" name="title-accent">
             <a:extLst xmlns:a="http://schemas.openxmlformats.org/drawingml/2006/main">
               <a:ext uri="{FF2B5EF4-FFF2-40B4-BE49-F238E27FC236}">
-                <a16:creationId xmlns:a16="http://schemas.microsoft.com/office/drawing/2014/main" id="{77B0B4E5-DE74-49E8-AFA8-9102E368F8CC}"/>
+                <a16:creationId xmlns:a16="http://schemas.microsoft.com/office/drawing/2014/main" id="{FF47AB6C-34CD-4012-9125-03FF460B8A1E}"/>
               </a:ext>
             </a:extLst>
           </p:cNvPr>
@@ -32118,7 +32320,7 @@
           <p:cNvPr id="4" name="page-number">
             <a:extLst xmlns:a="http://schemas.openxmlformats.org/drawingml/2006/main">
               <a:ext uri="{FF2B5EF4-FFF2-40B4-BE49-F238E27FC236}">
-                <a16:creationId xmlns:a16="http://schemas.microsoft.com/office/drawing/2014/main" id="{8C869D20-F06D-476D-807B-5E775C81C507}"/>
+                <a16:creationId xmlns:a16="http://schemas.microsoft.com/office/drawing/2014/main" id="{D8302D7A-002C-4448-8BEB-845DCB925374}"/>
               </a:ext>
             </a:extLst>
           </p:cNvPr>
@@ -32172,735 +32374,33 @@
           </a:p>
         </p:txBody>
       </p:sp>
-      <p:sp>
-        <p:nvSpPr>
-          <p:cNvPr id="5" name="panel">
-            <a:extLst xmlns:a="http://schemas.openxmlformats.org/drawingml/2006/main">
-              <a:ext uri="{FF2B5EF4-FFF2-40B4-BE49-F238E27FC236}">
-                <a16:creationId xmlns:a16="http://schemas.microsoft.com/office/drawing/2014/main" id="{02713856-54E8-4ECF-8347-649A6E47E52E}"/>
-              </a:ext>
-            </a:extLst>
-          </p:cNvPr>
-          <p:cNvSpPr>
-            <a:spLocks xmlns:a="http://schemas.openxmlformats.org/drawingml/2006/main" noGrp="1"/>
-          </p:cNvSpPr>
-          <p:nvPr/>
-        </p:nvSpPr>
-        <p:spPr>
-          <a:xfrm xmlns:a="http://schemas.openxmlformats.org/drawingml/2006/main">
-            <a:off x="400050" y="1714500"/>
-            <a:ext cx="5219700" cy="3619500"/>
-          </a:xfrm>
-          <a:prstGeom xmlns:a="http://schemas.openxmlformats.org/drawingml/2006/main" prst="rect">
-            <a:avLst/>
-          </a:prstGeom>
-          <a:solidFill xmlns:a="http://schemas.openxmlformats.org/drawingml/2006/main">
-            <a:srgbClr val="EAF6ED"/>
-          </a:solidFill>
-          <a:ln xmlns:a="http://schemas.openxmlformats.org/drawingml/2006/main" w="0">
-            <a:noFill/>
-            <a:prstDash val="solid"/>
-          </a:ln>
-        </p:spPr>
-      </p:sp>
-      <p:sp>
-        <p:nvSpPr>
-          <p:cNvPr id="6" name="text">
-            <a:extLst xmlns:a="http://schemas.openxmlformats.org/drawingml/2006/main">
-              <a:ext uri="{FF2B5EF4-FFF2-40B4-BE49-F238E27FC236}">
-                <a16:creationId xmlns:a16="http://schemas.microsoft.com/office/drawing/2014/main" id="{392D4441-BBAA-41FA-B003-EA5912D58460}"/>
-              </a:ext>
-            </a:extLst>
-          </p:cNvPr>
-          <p:cNvSpPr>
-            <a:spLocks xmlns:a="http://schemas.openxmlformats.org/drawingml/2006/main" noGrp="1"/>
-          </p:cNvSpPr>
-          <p:nvPr/>
-        </p:nvSpPr>
-        <p:spPr>
-          <a:xfrm xmlns:a="http://schemas.openxmlformats.org/drawingml/2006/main">
-            <a:off x="666750" y="2000250"/>
-            <a:ext cx="2476500" cy="285750"/>
-          </a:xfrm>
-          <a:prstGeom xmlns:a="http://schemas.openxmlformats.org/drawingml/2006/main" prst="rect">
-            <a:avLst/>
-          </a:prstGeom>
-          <a:noFill xmlns:a="http://schemas.openxmlformats.org/drawingml/2006/main"/>
-          <a:ln xmlns:a="http://schemas.openxmlformats.org/drawingml/2006/main" w="0">
-            <a:noFill/>
-            <a:prstDash val="solid"/>
-          </a:ln>
-        </p:spPr>
-        <p:txBody>
-          <a:bodyPr xmlns:a="http://schemas.openxmlformats.org/drawingml/2006/main" wrap="square" lIns="0" tIns="0" rIns="0" bIns="0" anchor="t">
-            <a:noAutofit/>
-          </a:bodyPr>
-          <a:lstStyle xmlns:a="http://schemas.openxmlformats.org/drawingml/2006/main"/>
-          <a:p xmlns:a="http://schemas.openxmlformats.org/drawingml/2006/main">
-            <a:pPr algn="l">
-              <a:buNone/>
-              <a:defRPr sz="1350" b="1" i="0">
-                <a:solidFill>
-                  <a:srgbClr val="2BA84A"/>
-                </a:solidFill>
-                <a:latin typeface="Helvetica Neue"/>
-                <a:ea typeface="Helvetica Neue"/>
-                <a:cs typeface="Helvetica Neue"/>
-              </a:defRPr>
-            </a:pPr>
-            <a:r>
-              <a:rPr sz="1350" b="1" i="0">
-                <a:solidFill>
-                  <a:srgbClr val="2BA84A"/>
-                </a:solidFill>
-                <a:latin typeface="Helvetica Neue"/>
-                <a:ea typeface="Helvetica Neue"/>
-                <a:cs typeface="Helvetica Neue"/>
-              </a:rPr>
-              <a:t>SINGLE-TURN ATTACK</a:t>
-            </a:r>
-          </a:p>
-        </p:txBody>
-      </p:sp>
-      <p:sp>
-        <p:nvSpPr>
-          <p:cNvPr id="7" name="text">
-            <a:extLst xmlns:a="http://schemas.openxmlformats.org/drawingml/2006/main">
-              <a:ext uri="{FF2B5EF4-FFF2-40B4-BE49-F238E27FC236}">
-                <a16:creationId xmlns:a16="http://schemas.microsoft.com/office/drawing/2014/main" id="{47AD68AD-F50E-4BB7-9FDF-5CB163BFD04C}"/>
-              </a:ext>
-            </a:extLst>
-          </p:cNvPr>
-          <p:cNvSpPr>
-            <a:spLocks xmlns:a="http://schemas.openxmlformats.org/drawingml/2006/main" noGrp="1"/>
-          </p:cNvSpPr>
-          <p:nvPr/>
-        </p:nvSpPr>
-        <p:spPr>
-          <a:xfrm xmlns:a="http://schemas.openxmlformats.org/drawingml/2006/main">
-            <a:off x="666750" y="2457450"/>
-            <a:ext cx="2476500" cy="533400"/>
-          </a:xfrm>
-          <a:prstGeom xmlns:a="http://schemas.openxmlformats.org/drawingml/2006/main" prst="rect">
-            <a:avLst/>
-          </a:prstGeom>
-          <a:noFill xmlns:a="http://schemas.openxmlformats.org/drawingml/2006/main"/>
-          <a:ln xmlns:a="http://schemas.openxmlformats.org/drawingml/2006/main" w="0">
-            <a:noFill/>
-            <a:prstDash val="solid"/>
-          </a:ln>
-        </p:spPr>
-        <p:txBody>
-          <a:bodyPr xmlns:a="http://schemas.openxmlformats.org/drawingml/2006/main" wrap="square" lIns="0" tIns="0" rIns="0" bIns="0" anchor="t">
-            <a:noAutofit/>
-          </a:bodyPr>
-          <a:lstStyle xmlns:a="http://schemas.openxmlformats.org/drawingml/2006/main"/>
-          <a:p xmlns:a="http://schemas.openxmlformats.org/drawingml/2006/main">
-            <a:pPr algn="l">
-              <a:buNone/>
-              <a:defRPr sz="3300" b="1" i="0">
-                <a:solidFill>
-                  <a:srgbClr val="0A0A0A"/>
-                </a:solidFill>
-                <a:latin typeface="Helvetica Neue"/>
-                <a:ea typeface="Helvetica Neue"/>
-                <a:cs typeface="Helvetica Neue"/>
-              </a:defRPr>
-            </a:pPr>
-            <a:r>
-              <a:rPr sz="3300" b="1" i="0">
-                <a:solidFill>
-                  <a:srgbClr val="0A0A0A"/>
-                </a:solidFill>
-                <a:latin typeface="Helvetica Neue"/>
-                <a:ea typeface="Helvetica Neue"/>
-                <a:cs typeface="Helvetica Neue"/>
-              </a:rPr>
-              <a:t>Prompt</a:t>
-            </a:r>
-          </a:p>
-        </p:txBody>
-      </p:sp>
-      <p:sp>
-        <p:nvSpPr>
-          <p:cNvPr id="8" name="text">
-            <a:extLst xmlns:a="http://schemas.openxmlformats.org/drawingml/2006/main">
-              <a:ext uri="{FF2B5EF4-FFF2-40B4-BE49-F238E27FC236}">
-                <a16:creationId xmlns:a16="http://schemas.microsoft.com/office/drawing/2014/main" id="{7D1E3F34-C61B-43BD-911E-6543EE747610}"/>
-              </a:ext>
-            </a:extLst>
-          </p:cNvPr>
-          <p:cNvSpPr>
-            <a:spLocks xmlns:a="http://schemas.openxmlformats.org/drawingml/2006/main" noGrp="1"/>
-          </p:cNvSpPr>
-          <p:nvPr/>
-        </p:nvSpPr>
-        <p:spPr>
-          <a:xfrm xmlns:a="http://schemas.openxmlformats.org/drawingml/2006/main">
-            <a:off x="666750" y="3143250"/>
-            <a:ext cx="4476750" cy="381000"/>
-          </a:xfrm>
-          <a:prstGeom xmlns:a="http://schemas.openxmlformats.org/drawingml/2006/main" prst="rect">
-            <a:avLst/>
-          </a:prstGeom>
-          <a:noFill xmlns:a="http://schemas.openxmlformats.org/drawingml/2006/main"/>
-          <a:ln xmlns:a="http://schemas.openxmlformats.org/drawingml/2006/main" w="0">
-            <a:noFill/>
-            <a:prstDash val="solid"/>
-          </a:ln>
-        </p:spPr>
-        <p:txBody>
-          <a:bodyPr xmlns:a="http://schemas.openxmlformats.org/drawingml/2006/main" wrap="square" lIns="0" tIns="0" rIns="0" bIns="0" anchor="t">
-            <a:noAutofit/>
-          </a:bodyPr>
-          <a:lstStyle xmlns:a="http://schemas.openxmlformats.org/drawingml/2006/main"/>
-          <a:p xmlns:a="http://schemas.openxmlformats.org/drawingml/2006/main">
-            <a:pPr algn="l">
-              <a:buNone/>
-              <a:defRPr sz="1875" b="1" i="0">
-                <a:solidFill>
-                  <a:srgbClr val="2BA84A"/>
-                </a:solidFill>
-                <a:latin typeface="Helvetica Neue"/>
-                <a:ea typeface="Helvetica Neue"/>
-                <a:cs typeface="Helvetica Neue"/>
-              </a:defRPr>
-            </a:pPr>
-            <a:r>
-              <a:rPr sz="1875" b="1" i="0">
-                <a:solidFill>
-                  <a:srgbClr val="2BA84A"/>
-                </a:solidFill>
-                <a:latin typeface="Helvetica Neue"/>
-                <a:ea typeface="Helvetica Neue"/>
-                <a:cs typeface="Helvetica Neue"/>
-              </a:rPr>
-              <a:t>一次 query，只优化当前回复</a:t>
-            </a:r>
-          </a:p>
-        </p:txBody>
-      </p:sp>
-      <p:sp>
-        <p:nvSpPr>
-          <p:cNvPr id="9" name="bullets">
-            <a:extLst xmlns:a="http://schemas.openxmlformats.org/drawingml/2006/main">
-              <a:ext uri="{FF2B5EF4-FFF2-40B4-BE49-F238E27FC236}">
-                <a16:creationId xmlns:a16="http://schemas.microsoft.com/office/drawing/2014/main" id="{3F2DEAC1-76D6-43E4-861A-6B02A26BB95F}"/>
-              </a:ext>
-            </a:extLst>
-          </p:cNvPr>
-          <p:cNvSpPr>
-            <a:spLocks xmlns:a="http://schemas.openxmlformats.org/drawingml/2006/main" noGrp="1"/>
-          </p:cNvSpPr>
-          <p:nvPr/>
-        </p:nvSpPr>
-        <p:spPr>
-          <a:xfrm xmlns:a="http://schemas.openxmlformats.org/drawingml/2006/main">
-            <a:off x="666750" y="3810000"/>
-            <a:ext cx="4476750" cy="1257300"/>
-          </a:xfrm>
-          <a:prstGeom xmlns:a="http://schemas.openxmlformats.org/drawingml/2006/main" prst="rect">
-            <a:avLst/>
-          </a:prstGeom>
-          <a:noFill xmlns:a="http://schemas.openxmlformats.org/drawingml/2006/main"/>
-          <a:ln xmlns:a="http://schemas.openxmlformats.org/drawingml/2006/main" w="0">
-            <a:noFill/>
-            <a:prstDash val="solid"/>
-          </a:ln>
-        </p:spPr>
-        <p:txBody>
-          <a:bodyPr xmlns:a="http://schemas.openxmlformats.org/drawingml/2006/main" wrap="square" lIns="0" tIns="0" rIns="0" bIns="0" anchor="t">
-            <a:normAutofit/>
-          </a:bodyPr>
-          <a:lstStyle xmlns:a="http://schemas.openxmlformats.org/drawingml/2006/main"/>
-          <a:p xmlns:a="http://schemas.openxmlformats.org/drawingml/2006/main">
-            <a:pPr marL="20" indent="-12" algn="l">
-              <a:lnSpc>
-                <a:spcPct val="108000"/>
-              </a:lnSpc>
-              <a:spcAft>
-                <a:spcPts val="10"/>
-              </a:spcAft>
-              <a:buNone/>
-              <a:defRPr sz="1425" b="0" i="0">
-                <a:solidFill>
-                  <a:srgbClr val="0A0A0A"/>
-                </a:solidFill>
-                <a:latin typeface="PingFang SC"/>
-                <a:ea typeface="PingFang SC"/>
-                <a:cs typeface="PingFang SC"/>
-              </a:defRPr>
-            </a:pPr>
-            <a:r>
-              <a:rPr sz="1425" b="0" i="0">
-                <a:solidFill>
-                  <a:srgbClr val="0A0A0A"/>
-                </a:solidFill>
-                <a:latin typeface="PingFang SC"/>
-                <a:ea typeface="PingFang SC"/>
-                <a:cs typeface="PingFang SC"/>
-              </a:rPr>
-              <a:t>输入：固定 harmful objective。</a:t>
-            </a:r>
-          </a:p>
-          <a:p xmlns:a="http://schemas.openxmlformats.org/drawingml/2006/main">
-            <a:pPr marL="20" indent="-12" algn="l">
-              <a:lnSpc>
-                <a:spcPct val="108000"/>
-              </a:lnSpc>
-              <a:spcAft>
-                <a:spcPts val="10"/>
-              </a:spcAft>
-              <a:buNone/>
-              <a:defRPr sz="1425" b="0" i="0">
-                <a:solidFill>
-                  <a:srgbClr val="0A0A0A"/>
-                </a:solidFill>
-                <a:latin typeface="PingFang SC"/>
-                <a:ea typeface="PingFang SC"/>
-                <a:cs typeface="PingFang SC"/>
-              </a:defRPr>
-            </a:pPr>
-            <a:r>
-              <a:rPr sz="1425" b="0" i="0">
-                <a:solidFill>
-                  <a:srgbClr val="0A0A0A"/>
-                </a:solidFill>
-                <a:latin typeface="PingFang SC"/>
-                <a:ea typeface="PingFang SC"/>
-                <a:cs typeface="PingFang SC"/>
-              </a:rPr>
-              <a:t>反馈：一次 victim response。</a:t>
-            </a:r>
-          </a:p>
-          <a:p xmlns:a="http://schemas.openxmlformats.org/drawingml/2006/main">
-            <a:pPr marL="20" indent="-12" algn="l">
-              <a:lnSpc>
-                <a:spcPct val="108000"/>
-              </a:lnSpc>
-              <a:spcAft>
-                <a:spcPts val="10"/>
-              </a:spcAft>
-              <a:buNone/>
-              <a:defRPr sz="1425" b="0" i="0">
-                <a:solidFill>
-                  <a:srgbClr val="0A0A0A"/>
-                </a:solidFill>
-                <a:latin typeface="PingFang SC"/>
-                <a:ea typeface="PingFang SC"/>
-                <a:cs typeface="PingFang SC"/>
-              </a:defRPr>
-            </a:pPr>
-            <a:r>
-              <a:rPr sz="1425" b="0" i="0">
-                <a:solidFill>
-                  <a:srgbClr val="0A0A0A"/>
-                </a:solidFill>
-                <a:latin typeface="PingFang SC"/>
-                <a:ea typeface="PingFang SC"/>
-                <a:cs typeface="PingFang SC"/>
-              </a:rPr>
-              <a:t>局限：无法利用拒答、泄露与上下文变化。</a:t>
-            </a:r>
-          </a:p>
-        </p:txBody>
-      </p:sp>
-      <p:sp>
-        <p:nvSpPr>
-          <p:cNvPr id="10" name="panel">
-            <a:extLst xmlns:a="http://schemas.openxmlformats.org/drawingml/2006/main">
-              <a:ext uri="{FF2B5EF4-FFF2-40B4-BE49-F238E27FC236}">
-                <a16:creationId xmlns:a16="http://schemas.microsoft.com/office/drawing/2014/main" id="{33FABCF5-B2C3-45A3-9F6F-264AD0C7488A}"/>
-              </a:ext>
-            </a:extLst>
-          </p:cNvPr>
-          <p:cNvSpPr>
-            <a:spLocks xmlns:a="http://schemas.openxmlformats.org/drawingml/2006/main" noGrp="1"/>
-          </p:cNvSpPr>
-          <p:nvPr/>
-        </p:nvSpPr>
-        <p:spPr>
-          <a:xfrm xmlns:a="http://schemas.openxmlformats.org/drawingml/2006/main">
-            <a:off x="6172200" y="1714500"/>
-            <a:ext cx="5219700" cy="3619500"/>
-          </a:xfrm>
-          <a:prstGeom xmlns:a="http://schemas.openxmlformats.org/drawingml/2006/main" prst="rect">
-            <a:avLst/>
-          </a:prstGeom>
-          <a:solidFill xmlns:a="http://schemas.openxmlformats.org/drawingml/2006/main">
-            <a:srgbClr val="FFF0E8"/>
-          </a:solidFill>
-          <a:ln xmlns:a="http://schemas.openxmlformats.org/drawingml/2006/main" w="0">
-            <a:noFill/>
-            <a:prstDash val="solid"/>
-          </a:ln>
-        </p:spPr>
-      </p:sp>
-      <p:sp>
-        <p:nvSpPr>
-          <p:cNvPr id="11" name="text">
-            <a:extLst xmlns:a="http://schemas.openxmlformats.org/drawingml/2006/main">
-              <a:ext uri="{FF2B5EF4-FFF2-40B4-BE49-F238E27FC236}">
-                <a16:creationId xmlns:a16="http://schemas.microsoft.com/office/drawing/2014/main" id="{8A02A726-EA3D-43F5-B0F4-F4D98EA1E6C5}"/>
-              </a:ext>
-            </a:extLst>
-          </p:cNvPr>
-          <p:cNvSpPr>
-            <a:spLocks xmlns:a="http://schemas.openxmlformats.org/drawingml/2006/main" noGrp="1"/>
-          </p:cNvSpPr>
-          <p:nvPr/>
-        </p:nvSpPr>
-        <p:spPr>
-          <a:xfrm xmlns:a="http://schemas.openxmlformats.org/drawingml/2006/main">
-            <a:off x="6438900" y="2000250"/>
-            <a:ext cx="2857500" cy="285750"/>
-          </a:xfrm>
-          <a:prstGeom xmlns:a="http://schemas.openxmlformats.org/drawingml/2006/main" prst="rect">
-            <a:avLst/>
-          </a:prstGeom>
-          <a:noFill xmlns:a="http://schemas.openxmlformats.org/drawingml/2006/main"/>
-          <a:ln xmlns:a="http://schemas.openxmlformats.org/drawingml/2006/main" w="0">
-            <a:noFill/>
-            <a:prstDash val="solid"/>
-          </a:ln>
-        </p:spPr>
-        <p:txBody>
-          <a:bodyPr xmlns:a="http://schemas.openxmlformats.org/drawingml/2006/main" wrap="square" lIns="0" tIns="0" rIns="0" bIns="0" anchor="t">
-            <a:noAutofit/>
-          </a:bodyPr>
-          <a:lstStyle xmlns:a="http://schemas.openxmlformats.org/drawingml/2006/main"/>
-          <a:p xmlns:a="http://schemas.openxmlformats.org/drawingml/2006/main">
-            <a:pPr algn="l">
-              <a:buNone/>
-              <a:defRPr sz="1350" b="1" i="0">
-                <a:solidFill>
-                  <a:srgbClr val="F07B4F"/>
-                </a:solidFill>
-                <a:latin typeface="Helvetica Neue"/>
-                <a:ea typeface="Helvetica Neue"/>
-                <a:cs typeface="Helvetica Neue"/>
-              </a:defRPr>
-            </a:pPr>
-            <a:r>
-              <a:rPr sz="1350" b="1" i="0">
-                <a:solidFill>
-                  <a:srgbClr val="F07B4F"/>
-                </a:solidFill>
-                <a:latin typeface="Helvetica Neue"/>
-                <a:ea typeface="Helvetica Neue"/>
-                <a:cs typeface="Helvetica Neue"/>
-              </a:rPr>
-              <a:t>MULTI-TURN ATTACK</a:t>
-            </a:r>
-          </a:p>
-        </p:txBody>
-      </p:sp>
-      <p:sp>
-        <p:nvSpPr>
-          <p:cNvPr id="12" name="text">
-            <a:extLst xmlns:a="http://schemas.openxmlformats.org/drawingml/2006/main">
-              <a:ext uri="{FF2B5EF4-FFF2-40B4-BE49-F238E27FC236}">
-                <a16:creationId xmlns:a16="http://schemas.microsoft.com/office/drawing/2014/main" id="{67E44A0D-3AC4-4A69-AD4F-3978314C1B4E}"/>
-              </a:ext>
-            </a:extLst>
-          </p:cNvPr>
-          <p:cNvSpPr>
-            <a:spLocks xmlns:a="http://schemas.openxmlformats.org/drawingml/2006/main" noGrp="1"/>
-          </p:cNvSpPr>
-          <p:nvPr/>
-        </p:nvSpPr>
-        <p:spPr>
-          <a:xfrm xmlns:a="http://schemas.openxmlformats.org/drawingml/2006/main">
-            <a:off x="6438900" y="2457450"/>
-            <a:ext cx="2476500" cy="533400"/>
-          </a:xfrm>
-          <a:prstGeom xmlns:a="http://schemas.openxmlformats.org/drawingml/2006/main" prst="rect">
-            <a:avLst/>
-          </a:prstGeom>
-          <a:noFill xmlns:a="http://schemas.openxmlformats.org/drawingml/2006/main"/>
-          <a:ln xmlns:a="http://schemas.openxmlformats.org/drawingml/2006/main" w="0">
-            <a:noFill/>
-            <a:prstDash val="solid"/>
-          </a:ln>
-        </p:spPr>
-        <p:txBody>
-          <a:bodyPr xmlns:a="http://schemas.openxmlformats.org/drawingml/2006/main" wrap="square" lIns="0" tIns="0" rIns="0" bIns="0" anchor="t">
-            <a:noAutofit/>
-          </a:bodyPr>
-          <a:lstStyle xmlns:a="http://schemas.openxmlformats.org/drawingml/2006/main"/>
-          <a:p xmlns:a="http://schemas.openxmlformats.org/drawingml/2006/main">
-            <a:pPr algn="l">
-              <a:buNone/>
-              <a:defRPr sz="3300" b="1" i="0">
-                <a:solidFill>
-                  <a:srgbClr val="0A0A0A"/>
-                </a:solidFill>
-                <a:latin typeface="Helvetica Neue"/>
-                <a:ea typeface="Helvetica Neue"/>
-                <a:cs typeface="Helvetica Neue"/>
-              </a:defRPr>
-            </a:pPr>
-            <a:r>
-              <a:rPr sz="3300" b="1" i="0">
-                <a:solidFill>
-                  <a:srgbClr val="0A0A0A"/>
-                </a:solidFill>
-                <a:latin typeface="Helvetica Neue"/>
-                <a:ea typeface="Helvetica Neue"/>
-                <a:cs typeface="Helvetica Neue"/>
-              </a:rPr>
-              <a:t>Policy</a:t>
-            </a:r>
-          </a:p>
-        </p:txBody>
-      </p:sp>
-      <p:sp>
-        <p:nvSpPr>
-          <p:cNvPr id="13" name="text">
-            <a:extLst xmlns:a="http://schemas.openxmlformats.org/drawingml/2006/main">
-              <a:ext uri="{FF2B5EF4-FFF2-40B4-BE49-F238E27FC236}">
-                <a16:creationId xmlns:a16="http://schemas.microsoft.com/office/drawing/2014/main" id="{1A50B476-46FB-4160-A744-4997B96BCCEE}"/>
-              </a:ext>
-            </a:extLst>
-          </p:cNvPr>
-          <p:cNvSpPr>
-            <a:spLocks xmlns:a="http://schemas.openxmlformats.org/drawingml/2006/main" noGrp="1"/>
-          </p:cNvSpPr>
-          <p:nvPr/>
-        </p:nvSpPr>
-        <p:spPr>
-          <a:xfrm xmlns:a="http://schemas.openxmlformats.org/drawingml/2006/main">
-            <a:off x="6438900" y="3143250"/>
-            <a:ext cx="4476750" cy="381000"/>
-          </a:xfrm>
-          <a:prstGeom xmlns:a="http://schemas.openxmlformats.org/drawingml/2006/main" prst="rect">
-            <a:avLst/>
-          </a:prstGeom>
-          <a:noFill xmlns:a="http://schemas.openxmlformats.org/drawingml/2006/main"/>
-          <a:ln xmlns:a="http://schemas.openxmlformats.org/drawingml/2006/main" w="0">
-            <a:noFill/>
-            <a:prstDash val="solid"/>
-          </a:ln>
-        </p:spPr>
-        <p:txBody>
-          <a:bodyPr xmlns:a="http://schemas.openxmlformats.org/drawingml/2006/main" wrap="square" lIns="0" tIns="0" rIns="0" bIns="0" anchor="t">
-            <a:noAutofit/>
-          </a:bodyPr>
-          <a:lstStyle xmlns:a="http://schemas.openxmlformats.org/drawingml/2006/main"/>
-          <a:p xmlns:a="http://schemas.openxmlformats.org/drawingml/2006/main">
-            <a:pPr algn="l">
-              <a:buNone/>
-              <a:defRPr sz="1875" b="1" i="0">
-                <a:solidFill>
-                  <a:srgbClr val="F07B4F"/>
-                </a:solidFill>
-                <a:latin typeface="Helvetica Neue"/>
-                <a:ea typeface="Helvetica Neue"/>
-                <a:cs typeface="Helvetica Neue"/>
-              </a:defRPr>
-            </a:pPr>
-            <a:r>
-              <a:rPr sz="1875" b="1" i="0">
-                <a:solidFill>
-                  <a:srgbClr val="F07B4F"/>
-                </a:solidFill>
-                <a:latin typeface="Helvetica Neue"/>
-                <a:ea typeface="Helvetica Neue"/>
-                <a:cs typeface="Helvetica Neue"/>
-              </a:rPr>
-              <a:t>观察 victim，再决定下一步动作</a:t>
-            </a:r>
-          </a:p>
-        </p:txBody>
-      </p:sp>
-      <p:sp>
-        <p:nvSpPr>
-          <p:cNvPr id="14" name="bullets">
-            <a:extLst xmlns:a="http://schemas.openxmlformats.org/drawingml/2006/main">
-              <a:ext uri="{FF2B5EF4-FFF2-40B4-BE49-F238E27FC236}">
-                <a16:creationId xmlns:a16="http://schemas.microsoft.com/office/drawing/2014/main" id="{F4308090-34C1-42A1-B38F-CC4FAE0EAC7B}"/>
-              </a:ext>
-            </a:extLst>
-          </p:cNvPr>
-          <p:cNvSpPr>
-            <a:spLocks xmlns:a="http://schemas.openxmlformats.org/drawingml/2006/main" noGrp="1"/>
-          </p:cNvSpPr>
-          <p:nvPr/>
-        </p:nvSpPr>
-        <p:spPr>
-          <a:xfrm xmlns:a="http://schemas.openxmlformats.org/drawingml/2006/main">
-            <a:off x="6438900" y="3810000"/>
-            <a:ext cx="4476750" cy="1257300"/>
-          </a:xfrm>
-          <a:prstGeom xmlns:a="http://schemas.openxmlformats.org/drawingml/2006/main" prst="rect">
-            <a:avLst/>
-          </a:prstGeom>
-          <a:noFill xmlns:a="http://schemas.openxmlformats.org/drawingml/2006/main"/>
-          <a:ln xmlns:a="http://schemas.openxmlformats.org/drawingml/2006/main" w="0">
-            <a:noFill/>
-            <a:prstDash val="solid"/>
-          </a:ln>
-        </p:spPr>
-        <p:txBody>
-          <a:bodyPr xmlns:a="http://schemas.openxmlformats.org/drawingml/2006/main" wrap="square" lIns="0" tIns="0" rIns="0" bIns="0" anchor="t">
-            <a:normAutofit/>
-          </a:bodyPr>
-          <a:lstStyle xmlns:a="http://schemas.openxmlformats.org/drawingml/2006/main"/>
-          <a:p xmlns:a="http://schemas.openxmlformats.org/drawingml/2006/main">
-            <a:pPr marL="20" indent="-12" algn="l">
-              <a:lnSpc>
-                <a:spcPct val="108000"/>
-              </a:lnSpc>
-              <a:spcAft>
-                <a:spcPts val="10"/>
-              </a:spcAft>
-              <a:buNone/>
-              <a:defRPr sz="1425" b="0" i="0">
-                <a:solidFill>
-                  <a:srgbClr val="0A0A0A"/>
-                </a:solidFill>
-                <a:latin typeface="PingFang SC"/>
-                <a:ea typeface="PingFang SC"/>
-                <a:cs typeface="PingFang SC"/>
-              </a:defRPr>
-            </a:pPr>
-            <a:r>
-              <a:rPr sz="1425" b="0" i="0">
-                <a:solidFill>
-                  <a:srgbClr val="0A0A0A"/>
-                </a:solidFill>
-                <a:latin typeface="PingFang SC"/>
-                <a:ea typeface="PingFang SC"/>
-                <a:cs typeface="PingFang SC"/>
-              </a:rPr>
-              <a:t>状态：transcript + session memory。</a:t>
-            </a:r>
-          </a:p>
-          <a:p xmlns:a="http://schemas.openxmlformats.org/drawingml/2006/main">
-            <a:pPr marL="20" indent="-12" algn="l">
-              <a:lnSpc>
-                <a:spcPct val="108000"/>
-              </a:lnSpc>
-              <a:spcAft>
-                <a:spcPts val="10"/>
-              </a:spcAft>
-              <a:buNone/>
-              <a:defRPr sz="1425" b="0" i="0">
-                <a:solidFill>
-                  <a:srgbClr val="0A0A0A"/>
-                </a:solidFill>
-                <a:latin typeface="PingFang SC"/>
-                <a:ea typeface="PingFang SC"/>
-                <a:cs typeface="PingFang SC"/>
-              </a:defRPr>
-            </a:pPr>
-            <a:r>
-              <a:rPr sz="1425" b="0" i="0">
-                <a:solidFill>
-                  <a:srgbClr val="0A0A0A"/>
-                </a:solidFill>
-                <a:latin typeface="PingFang SC"/>
-                <a:ea typeface="PingFang SC"/>
-                <a:cs typeface="PingFang SC"/>
-              </a:rPr>
-              <a:t>动作：重写、拆解、换视角或重启 session。</a:t>
-            </a:r>
-          </a:p>
-          <a:p xmlns:a="http://schemas.openxmlformats.org/drawingml/2006/main">
-            <a:pPr marL="20" indent="-12" algn="l">
-              <a:lnSpc>
-                <a:spcPct val="108000"/>
-              </a:lnSpc>
-              <a:spcAft>
-                <a:spcPts val="10"/>
-              </a:spcAft>
-              <a:buNone/>
-              <a:defRPr sz="1425" b="0" i="0">
-                <a:solidFill>
-                  <a:srgbClr val="0A0A0A"/>
-                </a:solidFill>
-                <a:latin typeface="PingFang SC"/>
-                <a:ea typeface="PingFang SC"/>
-                <a:cs typeface="PingFang SC"/>
-              </a:defRPr>
-            </a:pPr>
-            <a:r>
-              <a:rPr sz="1425" b="0" i="0">
-                <a:solidFill>
-                  <a:srgbClr val="0A0A0A"/>
-                </a:solidFill>
-                <a:latin typeface="PingFang SC"/>
-                <a:ea typeface="PingFang SC"/>
-                <a:cs typeface="PingFang SC"/>
-              </a:rPr>
-              <a:t>优化：judge reward → GRPO policy update。</a:t>
-            </a:r>
-          </a:p>
-        </p:txBody>
-      </p:sp>
-      <p:sp>
-        <p:nvSpPr>
-          <p:cNvPr id="15" name="text">
-            <a:extLst xmlns:a="http://schemas.openxmlformats.org/drawingml/2006/main">
-              <a:ext uri="{FF2B5EF4-FFF2-40B4-BE49-F238E27FC236}">
-                <a16:creationId xmlns:a16="http://schemas.microsoft.com/office/drawing/2014/main" id="{57FDAE17-A2FF-4660-94EE-706E0461A4AC}"/>
-              </a:ext>
-            </a:extLst>
-          </p:cNvPr>
-          <p:cNvSpPr>
-            <a:spLocks xmlns:a="http://schemas.openxmlformats.org/drawingml/2006/main" noGrp="1"/>
-          </p:cNvSpPr>
-          <p:nvPr/>
-        </p:nvSpPr>
-        <p:spPr>
-          <a:xfrm xmlns:a="http://schemas.openxmlformats.org/drawingml/2006/main">
-            <a:off x="400050" y="5753100"/>
-            <a:ext cx="10991850" cy="457200"/>
-          </a:xfrm>
-          <a:prstGeom xmlns:a="http://schemas.openxmlformats.org/drawingml/2006/main" prst="rect">
-            <a:avLst/>
-          </a:prstGeom>
-          <a:noFill xmlns:a="http://schemas.openxmlformats.org/drawingml/2006/main"/>
-          <a:ln xmlns:a="http://schemas.openxmlformats.org/drawingml/2006/main" w="0">
-            <a:noFill/>
-            <a:prstDash val="solid"/>
-          </a:ln>
-        </p:spPr>
-        <p:txBody>
-          <a:bodyPr xmlns:a="http://schemas.openxmlformats.org/drawingml/2006/main" wrap="square" lIns="0" tIns="0" rIns="0" bIns="0" anchor="t">
-            <a:normAutofit/>
-          </a:bodyPr>
-          <a:lstStyle xmlns:a="http://schemas.openxmlformats.org/drawingml/2006/main"/>
-          <a:p xmlns:a="http://schemas.openxmlformats.org/drawingml/2006/main">
-            <a:pPr algn="ctr">
-              <a:buNone/>
-              <a:defRPr sz="1575" b="1" i="0">
-                <a:solidFill>
-                  <a:srgbClr val="6C63B5"/>
-                </a:solidFill>
-                <a:latin typeface="PingFang SC"/>
-                <a:ea typeface="PingFang SC"/>
-                <a:cs typeface="PingFang SC"/>
-              </a:defRPr>
-            </a:pPr>
-            <a:r>
-              <a:rPr sz="1575" b="1" i="0">
-                <a:solidFill>
-                  <a:srgbClr val="6C63B5"/>
-                </a:solidFill>
-                <a:latin typeface="PingFang SC"/>
-                <a:ea typeface="PingFang SC"/>
-                <a:cs typeface="PingFang SC"/>
-              </a:rPr>
-              <a:t>关键变化：同一目标可跨 turn / session 自适应；学习的是攻击策略，而不是重复固定模板。</a:t>
-            </a:r>
-          </a:p>
-        </p:txBody>
-      </p:sp>
+      <p:pic>
+        <p:nvPicPr>
+          <p:cNvPr id="23" name=""/>
+          <p:cNvPicPr>
+            <a:picLocks xmlns:a="http://schemas.openxmlformats.org/drawingml/2006/main" noChangeAspect="1"/>
+          </p:cNvPicPr>
+          <p:nvPr/>
+        </p:nvPicPr>
+        <p:blipFill>
+          <a:blip xmlns:r="http://schemas.openxmlformats.org/officeDocument/2006/relationships" xmlns:a="http://schemas.openxmlformats.org/drawingml/2006/main" r:embed="R4e98fe6532be4f2f"/>
+          <a:srcRect xmlns:a="http://schemas.openxmlformats.org/drawingml/2006/main" l="0" t="0" r="0" b="0"/>
+          <a:stretch xmlns:a="http://schemas.openxmlformats.org/drawingml/2006/main"/>
+        </p:blipFill>
+        <p:spPr>
+          <a:xfrm xmlns:a="http://schemas.openxmlformats.org/drawingml/2006/main" flipH="0" flipV="0">
+            <a:off x="400050" y="1466850"/>
+            <a:ext cx="11029950" cy="4667250"/>
+          </a:xfrm>
+          <a:prstGeom xmlns:a="http://schemas.openxmlformats.org/drawingml/2006/main" prst="rect">
+            <a:avLst/>
+          </a:prstGeom>
+        </p:spPr>
+      </p:pic>
     </p:spTree>
     <p:extLst>
       <p:ext uri="{BB962C8B-B14F-4D97-AF65-F5344CB8AC3E}">
-        <p14:creationId xmlns:p14="http://schemas.microsoft.com/office/powerpoint/2010/main" val="103396954"/>
+        <p14:creationId xmlns:p14="http://schemas.microsoft.com/office/powerpoint/2010/main" val="1302671042"/>
       </p:ext>
     </p:extLst>
   </p:cSld>
@@ -34230,7 +33730,7 @@
           <p:nvPr/>
         </p:nvPicPr>
         <p:blipFill>
-          <a:blip xmlns:r="http://schemas.openxmlformats.org/officeDocument/2006/relationships" xmlns:a="http://schemas.openxmlformats.org/drawingml/2006/main" r:embed="R5eca0b917d8d413e"/>
+          <a:blip xmlns:r="http://schemas.openxmlformats.org/officeDocument/2006/relationships" xmlns:a="http://schemas.openxmlformats.org/drawingml/2006/main" r:embed="R96df1865a235462b"/>
           <a:stretch xmlns:a="http://schemas.openxmlformats.org/drawingml/2006/main"/>
         </p:blipFill>
         <p:spPr>
@@ -34274,10 +33774,10 @@
       </p:grpSpPr>
       <p:sp>
         <p:nvSpPr>
-          <p:cNvPr id="22" name="section-kicker">
-            <a:extLst xmlns:a="http://schemas.openxmlformats.org/drawingml/2006/main">
-              <a:ext uri="{FF2B5EF4-FFF2-40B4-BE49-F238E27FC236}">
-                <a16:creationId xmlns:a16="http://schemas.microsoft.com/office/drawing/2014/main" id="{982B63FE-AFFC-45D8-B11F-ACE9BF28B34E}"/>
+          <p:cNvPr id="17" name="section-kicker">
+            <a:extLst xmlns:a="http://schemas.openxmlformats.org/drawingml/2006/main">
+              <a:ext uri="{FF2B5EF4-FFF2-40B4-BE49-F238E27FC236}">
+                <a16:creationId xmlns:a16="http://schemas.microsoft.com/office/drawing/2014/main" id="{A07FB4AA-710F-4E87-AACA-77E3DAFAB71C}"/>
               </a:ext>
             </a:extLst>
           </p:cNvPr>
@@ -34326,7 +33826,7 @@
                 <a:ea typeface="Helvetica Neue"/>
                 <a:cs typeface="Helvetica Neue"/>
               </a:rPr>
-              <a:t>MULTI-TURN ATTACKER · 27B RL</a:t>
+              <a:t>MULTI-TURN ATTACKER · 27B RL BEFORE / AFTER</a:t>
             </a:r>
           </a:p>
         </p:txBody>
@@ -34336,7 +33836,7 @@
           <p:cNvPr id="2" name="slide-title">
             <a:extLst xmlns:a="http://schemas.openxmlformats.org/drawingml/2006/main">
               <a:ext uri="{FF2B5EF4-FFF2-40B4-BE49-F238E27FC236}">
-                <a16:creationId xmlns:a16="http://schemas.microsoft.com/office/drawing/2014/main" id="{BBC91221-9472-4599-B41B-A14DB3A3658D}"/>
+                <a16:creationId xmlns:a16="http://schemas.microsoft.com/office/drawing/2014/main" id="{0AB68E79-FE67-4F15-8262-963D89D18C22}"/>
               </a:ext>
             </a:extLst>
           </p:cNvPr>
@@ -34385,7 +33885,7 @@
                 <a:ea typeface="PingFang SC"/>
                 <a:cs typeface="PingFang SC"/>
               </a:rPr>
-              <a:t>双语 27B attacker 在 122B 上达到 95.5% ASR@3</a:t>
+              <a:t>27B 训练前后：ASR@3 28.0% → 95.5%</a:t>
             </a:r>
           </a:p>
         </p:txBody>
@@ -34395,7 +33895,7 @@
           <p:cNvPr id="3" name="title-accent">
             <a:extLst xmlns:a="http://schemas.openxmlformats.org/drawingml/2006/main">
               <a:ext uri="{FF2B5EF4-FFF2-40B4-BE49-F238E27FC236}">
-                <a16:creationId xmlns:a16="http://schemas.microsoft.com/office/drawing/2014/main" id="{0D3F7AA2-0F2E-407E-8B66-803ADFDBC63D}"/>
+                <a16:creationId xmlns:a16="http://schemas.microsoft.com/office/drawing/2014/main" id="{FF47AB6C-34CD-4012-9125-03FF460B8A1E}"/>
               </a:ext>
             </a:extLst>
           </p:cNvPr>
@@ -34426,7 +33926,7 @@
           <p:cNvPr id="4" name="page-number">
             <a:extLst xmlns:a="http://schemas.openxmlformats.org/drawingml/2006/main">
               <a:ext uri="{FF2B5EF4-FFF2-40B4-BE49-F238E27FC236}">
-                <a16:creationId xmlns:a16="http://schemas.microsoft.com/office/drawing/2014/main" id="{F8030601-6B38-41A4-BF41-BB0376BCB503}"/>
+                <a16:creationId xmlns:a16="http://schemas.microsoft.com/office/drawing/2014/main" id="{D8302D7A-002C-4448-8BEB-845DCB925374}"/>
               </a:ext>
             </a:extLst>
           </p:cNvPr>
@@ -34480,800 +33980,33 @@
           </a:p>
         </p:txBody>
       </p:sp>
-      <p:sp>
-        <p:nvSpPr>
-          <p:cNvPr id="7" name="text">
-            <a:extLst xmlns:a="http://schemas.openxmlformats.org/drawingml/2006/main">
-              <a:ext uri="{FF2B5EF4-FFF2-40B4-BE49-F238E27FC236}">
-                <a16:creationId xmlns:a16="http://schemas.microsoft.com/office/drawing/2014/main" id="{E52DAB75-C1B6-4936-B730-9FF4E3E140E9}"/>
-              </a:ext>
-            </a:extLst>
-          </p:cNvPr>
-          <p:cNvSpPr>
-            <a:spLocks xmlns:a="http://schemas.openxmlformats.org/drawingml/2006/main" noGrp="1"/>
-          </p:cNvSpPr>
-          <p:nvPr/>
-        </p:nvSpPr>
-        <p:spPr>
-          <a:xfrm xmlns:a="http://schemas.openxmlformats.org/drawingml/2006/main">
-            <a:off x="6896100" y="1695450"/>
-            <a:ext cx="2400300" cy="400050"/>
-          </a:xfrm>
-          <a:prstGeom xmlns:a="http://schemas.openxmlformats.org/drawingml/2006/main" prst="rect">
-            <a:avLst/>
-          </a:prstGeom>
-          <a:noFill xmlns:a="http://schemas.openxmlformats.org/drawingml/2006/main"/>
-          <a:ln xmlns:a="http://schemas.openxmlformats.org/drawingml/2006/main" w="0">
-            <a:noFill/>
-            <a:prstDash val="solid"/>
-          </a:ln>
-        </p:spPr>
-        <p:txBody>
-          <a:bodyPr xmlns:a="http://schemas.openxmlformats.org/drawingml/2006/main" wrap="square" lIns="0" tIns="0" rIns="0" bIns="0" anchor="t">
-            <a:normAutofit fontScale="100000"/>
-          </a:bodyPr>
-          <a:lstStyle xmlns:a="http://schemas.openxmlformats.org/drawingml/2006/main"/>
-          <a:p xmlns:a="http://schemas.openxmlformats.org/drawingml/2006/main">
-            <a:pPr algn="l">
-              <a:buNone/>
-              <a:defRPr sz="2400" b="1" i="0">
-                <a:solidFill>
-                  <a:srgbClr val="3D8DFF"/>
-                </a:solidFill>
-                <a:latin typeface="Helvetica Neue"/>
-                <a:ea typeface="Helvetica Neue"/>
-                <a:cs typeface="Helvetica Neue"/>
-              </a:defRPr>
-            </a:pPr>
-            <a:r>
-              <a:rPr sz="2400" b="1" i="0">
-                <a:solidFill>
-                  <a:srgbClr val="3D8DFF"/>
-                </a:solidFill>
-                <a:latin typeface="Helvetica Neue"/>
-                <a:ea typeface="Helvetica Neue"/>
-                <a:cs typeface="Helvetica Neue"/>
-              </a:rPr>
-              <a:t>27B</a:t>
-            </a:r>
-          </a:p>
-        </p:txBody>
-      </p:sp>
-      <p:sp>
-        <p:nvSpPr>
-          <p:cNvPr id="8" name="text">
-            <a:extLst xmlns:a="http://schemas.openxmlformats.org/drawingml/2006/main">
-              <a:ext uri="{FF2B5EF4-FFF2-40B4-BE49-F238E27FC236}">
-                <a16:creationId xmlns:a16="http://schemas.microsoft.com/office/drawing/2014/main" id="{EA2FA1AF-CF6C-43F3-89B3-74D5064C0098}"/>
-              </a:ext>
-            </a:extLst>
-          </p:cNvPr>
-          <p:cNvSpPr>
-            <a:spLocks xmlns:a="http://schemas.openxmlformats.org/drawingml/2006/main" noGrp="1"/>
-          </p:cNvSpPr>
-          <p:nvPr/>
-        </p:nvSpPr>
-        <p:spPr>
-          <a:xfrm xmlns:a="http://schemas.openxmlformats.org/drawingml/2006/main">
-            <a:off x="9410700" y="1714500"/>
-            <a:ext cx="2152650" cy="285750"/>
-          </a:xfrm>
-          <a:prstGeom xmlns:a="http://schemas.openxmlformats.org/drawingml/2006/main" prst="rect">
-            <a:avLst/>
-          </a:prstGeom>
-          <a:noFill xmlns:a="http://schemas.openxmlformats.org/drawingml/2006/main"/>
-          <a:ln xmlns:a="http://schemas.openxmlformats.org/drawingml/2006/main" w="0">
-            <a:noFill/>
-            <a:prstDash val="solid"/>
-          </a:ln>
-        </p:spPr>
-        <p:txBody>
-          <a:bodyPr xmlns:a="http://schemas.openxmlformats.org/drawingml/2006/main" wrap="square" lIns="0" tIns="0" rIns="0" bIns="0" anchor="t">
-            <a:normAutofit fontScale="100000"/>
-          </a:bodyPr>
-          <a:lstStyle xmlns:a="http://schemas.openxmlformats.org/drawingml/2006/main"/>
-          <a:p xmlns:a="http://schemas.openxmlformats.org/drawingml/2006/main">
-            <a:pPr algn="l">
-              <a:buNone/>
-              <a:defRPr sz="1350" b="1" i="0">
-                <a:solidFill>
-                  <a:srgbClr val="0A0A0A"/>
-                </a:solidFill>
-                <a:latin typeface="PingFang SC"/>
-                <a:ea typeface="PingFang SC"/>
-                <a:cs typeface="PingFang SC"/>
-              </a:defRPr>
-            </a:pPr>
-            <a:r>
-              <a:rPr sz="1350" b="1" i="0">
-                <a:solidFill>
-                  <a:srgbClr val="0A0A0A"/>
-                </a:solidFill>
-                <a:latin typeface="PingFang SC"/>
-                <a:ea typeface="PingFang SC"/>
-                <a:cs typeface="PingFang SC"/>
-              </a:rPr>
-              <a:t>Attacker</a:t>
-            </a:r>
-          </a:p>
-        </p:txBody>
-      </p:sp>
-      <p:sp>
-        <p:nvSpPr>
-          <p:cNvPr id="9" name="text">
-            <a:extLst xmlns:a="http://schemas.openxmlformats.org/drawingml/2006/main">
-              <a:ext uri="{FF2B5EF4-FFF2-40B4-BE49-F238E27FC236}">
-                <a16:creationId xmlns:a16="http://schemas.microsoft.com/office/drawing/2014/main" id="{CEE2C4C3-4E94-402B-AD86-0234195DD209}"/>
-              </a:ext>
-            </a:extLst>
-          </p:cNvPr>
-          <p:cNvSpPr>
-            <a:spLocks xmlns:a="http://schemas.openxmlformats.org/drawingml/2006/main" noGrp="1"/>
-          </p:cNvSpPr>
-          <p:nvPr/>
-        </p:nvSpPr>
-        <p:spPr>
-          <a:xfrm xmlns:a="http://schemas.openxmlformats.org/drawingml/2006/main">
-            <a:off x="9410700" y="2057400"/>
-            <a:ext cx="2152650" cy="285750"/>
-          </a:xfrm>
-          <a:prstGeom xmlns:a="http://schemas.openxmlformats.org/drawingml/2006/main" prst="rect">
-            <a:avLst/>
-          </a:prstGeom>
-          <a:noFill xmlns:a="http://schemas.openxmlformats.org/drawingml/2006/main"/>
-          <a:ln xmlns:a="http://schemas.openxmlformats.org/drawingml/2006/main" w="0">
-            <a:noFill/>
-            <a:prstDash val="solid"/>
-          </a:ln>
-        </p:spPr>
-        <p:txBody>
-          <a:bodyPr xmlns:a="http://schemas.openxmlformats.org/drawingml/2006/main" wrap="square" lIns="0" tIns="0" rIns="0" bIns="0" anchor="t">
-            <a:normAutofit fontScale="100000"/>
-          </a:bodyPr>
-          <a:lstStyle xmlns:a="http://schemas.openxmlformats.org/drawingml/2006/main"/>
-          <a:p xmlns:a="http://schemas.openxmlformats.org/drawingml/2006/main">
-            <a:pPr algn="l">
-              <a:buNone/>
-              <a:defRPr sz="1125" b="0" i="0">
-                <a:solidFill>
-                  <a:srgbClr val="59616D"/>
-                </a:solidFill>
-                <a:latin typeface="PingFang SC"/>
-                <a:ea typeface="PingFang SC"/>
-                <a:cs typeface="PingFang SC"/>
-              </a:defRPr>
-            </a:pPr>
-            <a:r>
-              <a:rPr sz="1125" b="0" i="0">
-                <a:solidFill>
-                  <a:srgbClr val="59616D"/>
-                </a:solidFill>
-                <a:latin typeface="PingFang SC"/>
-                <a:ea typeface="PingFang SC"/>
-                <a:cs typeface="PingFang SC"/>
-              </a:rPr>
-              <a:t>bilingual RL</a:t>
-            </a:r>
-          </a:p>
-        </p:txBody>
-      </p:sp>
-      <p:cxnSp>
-        <p:nvCxnSpPr>
-          <p:cNvPr id="483" name="rule"/>
-          <p:cNvCxnSpPr/>
-          <p:nvPr/>
-        </p:nvCxnSpPr>
-        <p:spPr>
-          <a:xfrm xmlns:a="http://schemas.openxmlformats.org/drawingml/2006/main">
-            <a:off x="6896100" y="2571750"/>
-            <a:ext cx="4667250" cy="95"/>
-          </a:xfrm>
-          <a:prstGeom xmlns:a="http://schemas.openxmlformats.org/drawingml/2006/main" prst="straightConnector1">
-            <a:avLst/>
-          </a:prstGeom>
-          <a:ln xmlns:a="http://schemas.openxmlformats.org/drawingml/2006/main" w="9525">
-            <a:solidFill>
-              <a:srgbClr val="B8BCC4"/>
-            </a:solidFill>
-            <a:prstDash val="solid"/>
-          </a:ln>
-        </p:spPr>
-      </p:cxnSp>
-      <p:sp>
-        <p:nvSpPr>
-          <p:cNvPr id="11" name="text">
-            <a:extLst xmlns:a="http://schemas.openxmlformats.org/drawingml/2006/main">
-              <a:ext uri="{FF2B5EF4-FFF2-40B4-BE49-F238E27FC236}">
-                <a16:creationId xmlns:a16="http://schemas.microsoft.com/office/drawing/2014/main" id="{647FAD0C-A30E-4B94-AE75-D7A91049B334}"/>
-              </a:ext>
-            </a:extLst>
-          </p:cNvPr>
-          <p:cNvSpPr>
-            <a:spLocks xmlns:a="http://schemas.openxmlformats.org/drawingml/2006/main" noGrp="1"/>
-          </p:cNvSpPr>
-          <p:nvPr/>
-        </p:nvSpPr>
-        <p:spPr>
-          <a:xfrm xmlns:a="http://schemas.openxmlformats.org/drawingml/2006/main">
-            <a:off x="6896100" y="2914650"/>
-            <a:ext cx="2400300" cy="400050"/>
-          </a:xfrm>
-          <a:prstGeom xmlns:a="http://schemas.openxmlformats.org/drawingml/2006/main" prst="rect">
-            <a:avLst/>
-          </a:prstGeom>
-          <a:noFill xmlns:a="http://schemas.openxmlformats.org/drawingml/2006/main"/>
-          <a:ln xmlns:a="http://schemas.openxmlformats.org/drawingml/2006/main" w="0">
-            <a:noFill/>
-            <a:prstDash val="solid"/>
-          </a:ln>
-        </p:spPr>
-        <p:txBody>
-          <a:bodyPr xmlns:a="http://schemas.openxmlformats.org/drawingml/2006/main" wrap="square" lIns="0" tIns="0" rIns="0" bIns="0" anchor="t">
-            <a:normAutofit fontScale="100000"/>
-          </a:bodyPr>
-          <a:lstStyle xmlns:a="http://schemas.openxmlformats.org/drawingml/2006/main"/>
-          <a:p xmlns:a="http://schemas.openxmlformats.org/drawingml/2006/main">
-            <a:pPr algn="l">
-              <a:buNone/>
-              <a:defRPr sz="2400" b="1" i="0">
-                <a:solidFill>
-                  <a:srgbClr val="D84A4A"/>
-                </a:solidFill>
-                <a:latin typeface="Helvetica Neue"/>
-                <a:ea typeface="Helvetica Neue"/>
-                <a:cs typeface="Helvetica Neue"/>
-              </a:defRPr>
-            </a:pPr>
-            <a:r>
-              <a:rPr sz="2400" b="1" i="0">
-                <a:solidFill>
-                  <a:srgbClr val="D84A4A"/>
-                </a:solidFill>
-                <a:latin typeface="Helvetica Neue"/>
-                <a:ea typeface="Helvetica Neue"/>
-                <a:cs typeface="Helvetica Neue"/>
-              </a:rPr>
-              <a:t>122B</a:t>
-            </a:r>
-          </a:p>
-        </p:txBody>
-      </p:sp>
-      <p:sp>
-        <p:nvSpPr>
-          <p:cNvPr id="12" name="text">
-            <a:extLst xmlns:a="http://schemas.openxmlformats.org/drawingml/2006/main">
-              <a:ext uri="{FF2B5EF4-FFF2-40B4-BE49-F238E27FC236}">
-                <a16:creationId xmlns:a16="http://schemas.microsoft.com/office/drawing/2014/main" id="{B75B1331-59AA-4F74-B403-D42ED90FA70D}"/>
-              </a:ext>
-            </a:extLst>
-          </p:cNvPr>
-          <p:cNvSpPr>
-            <a:spLocks xmlns:a="http://schemas.openxmlformats.org/drawingml/2006/main" noGrp="1"/>
-          </p:cNvSpPr>
-          <p:nvPr/>
-        </p:nvSpPr>
-        <p:spPr>
-          <a:xfrm xmlns:a="http://schemas.openxmlformats.org/drawingml/2006/main">
-            <a:off x="9410700" y="2933700"/>
-            <a:ext cx="2152650" cy="285750"/>
-          </a:xfrm>
-          <a:prstGeom xmlns:a="http://schemas.openxmlformats.org/drawingml/2006/main" prst="rect">
-            <a:avLst/>
-          </a:prstGeom>
-          <a:noFill xmlns:a="http://schemas.openxmlformats.org/drawingml/2006/main"/>
-          <a:ln xmlns:a="http://schemas.openxmlformats.org/drawingml/2006/main" w="0">
-            <a:noFill/>
-            <a:prstDash val="solid"/>
-          </a:ln>
-        </p:spPr>
-        <p:txBody>
-          <a:bodyPr xmlns:a="http://schemas.openxmlformats.org/drawingml/2006/main" wrap="square" lIns="0" tIns="0" rIns="0" bIns="0" anchor="t">
-            <a:normAutofit fontScale="100000"/>
-          </a:bodyPr>
-          <a:lstStyle xmlns:a="http://schemas.openxmlformats.org/drawingml/2006/main"/>
-          <a:p xmlns:a="http://schemas.openxmlformats.org/drawingml/2006/main">
-            <a:pPr algn="l">
-              <a:buNone/>
-              <a:defRPr sz="1350" b="1" i="0">
-                <a:solidFill>
-                  <a:srgbClr val="0A0A0A"/>
-                </a:solidFill>
-                <a:latin typeface="PingFang SC"/>
-                <a:ea typeface="PingFang SC"/>
-                <a:cs typeface="PingFang SC"/>
-              </a:defRPr>
-            </a:pPr>
-            <a:r>
-              <a:rPr sz="1350" b="1" i="0">
-                <a:solidFill>
-                  <a:srgbClr val="0A0A0A"/>
-                </a:solidFill>
-                <a:latin typeface="PingFang SC"/>
-                <a:ea typeface="PingFang SC"/>
-                <a:cs typeface="PingFang SC"/>
-              </a:rPr>
-              <a:t>Training victim</a:t>
-            </a:r>
-          </a:p>
-        </p:txBody>
-      </p:sp>
-      <p:sp>
-        <p:nvSpPr>
-          <p:cNvPr id="13" name="text">
-            <a:extLst xmlns:a="http://schemas.openxmlformats.org/drawingml/2006/main">
-              <a:ext uri="{FF2B5EF4-FFF2-40B4-BE49-F238E27FC236}">
-                <a16:creationId xmlns:a16="http://schemas.microsoft.com/office/drawing/2014/main" id="{800D6D90-1C7B-4848-9184-A551BC555502}"/>
-              </a:ext>
-            </a:extLst>
-          </p:cNvPr>
-          <p:cNvSpPr>
-            <a:spLocks xmlns:a="http://schemas.openxmlformats.org/drawingml/2006/main" noGrp="1"/>
-          </p:cNvSpPr>
-          <p:nvPr/>
-        </p:nvSpPr>
-        <p:spPr>
-          <a:xfrm xmlns:a="http://schemas.openxmlformats.org/drawingml/2006/main">
-            <a:off x="9410700" y="3276600"/>
-            <a:ext cx="2152650" cy="285750"/>
-          </a:xfrm>
-          <a:prstGeom xmlns:a="http://schemas.openxmlformats.org/drawingml/2006/main" prst="rect">
-            <a:avLst/>
-          </a:prstGeom>
-          <a:noFill xmlns:a="http://schemas.openxmlformats.org/drawingml/2006/main"/>
-          <a:ln xmlns:a="http://schemas.openxmlformats.org/drawingml/2006/main" w="0">
-            <a:noFill/>
-            <a:prstDash val="solid"/>
-          </a:ln>
-        </p:spPr>
-        <p:txBody>
-          <a:bodyPr xmlns:a="http://schemas.openxmlformats.org/drawingml/2006/main" wrap="square" lIns="0" tIns="0" rIns="0" bIns="0" anchor="t">
-            <a:normAutofit fontScale="100000"/>
-          </a:bodyPr>
-          <a:lstStyle xmlns:a="http://schemas.openxmlformats.org/drawingml/2006/main"/>
-          <a:p xmlns:a="http://schemas.openxmlformats.org/drawingml/2006/main">
-            <a:pPr algn="l">
-              <a:buNone/>
-              <a:defRPr sz="1125" b="0" i="0">
-                <a:solidFill>
-                  <a:srgbClr val="59616D"/>
-                </a:solidFill>
-                <a:latin typeface="PingFang SC"/>
-                <a:ea typeface="PingFang SC"/>
-                <a:cs typeface="PingFang SC"/>
-              </a:defRPr>
-            </a:pPr>
-            <a:r>
-              <a:rPr sz="1125" b="0" i="0">
-                <a:solidFill>
-                  <a:srgbClr val="59616D"/>
-                </a:solidFill>
-                <a:latin typeface="PingFang SC"/>
-                <a:ea typeface="PingFang SC"/>
-                <a:cs typeface="PingFang SC"/>
-              </a:rPr>
-              <a:t>Qwen3.5-122B-A10B</a:t>
-            </a:r>
-          </a:p>
-        </p:txBody>
-      </p:sp>
-      <p:cxnSp>
-        <p:nvCxnSpPr>
-          <p:cNvPr id="487" name="rule"/>
-          <p:cNvCxnSpPr/>
-          <p:nvPr/>
-        </p:nvCxnSpPr>
-        <p:spPr>
-          <a:xfrm xmlns:a="http://schemas.openxmlformats.org/drawingml/2006/main">
-            <a:off x="6896100" y="3790950"/>
-            <a:ext cx="4667250" cy="95"/>
-          </a:xfrm>
-          <a:prstGeom xmlns:a="http://schemas.openxmlformats.org/drawingml/2006/main" prst="straightConnector1">
-            <a:avLst/>
-          </a:prstGeom>
-          <a:ln xmlns:a="http://schemas.openxmlformats.org/drawingml/2006/main" w="9525">
-            <a:solidFill>
-              <a:srgbClr val="B8BCC4"/>
-            </a:solidFill>
-            <a:prstDash val="solid"/>
-          </a:ln>
-        </p:spPr>
-      </p:cxnSp>
-      <p:sp>
-        <p:nvSpPr>
-          <p:cNvPr id="15" name="text">
-            <a:extLst xmlns:a="http://schemas.openxmlformats.org/drawingml/2006/main">
-              <a:ext uri="{FF2B5EF4-FFF2-40B4-BE49-F238E27FC236}">
-                <a16:creationId xmlns:a16="http://schemas.microsoft.com/office/drawing/2014/main" id="{2887DE25-C034-491B-9EAF-AD4173166FE8}"/>
-              </a:ext>
-            </a:extLst>
-          </p:cNvPr>
-          <p:cNvSpPr>
-            <a:spLocks xmlns:a="http://schemas.openxmlformats.org/drawingml/2006/main" noGrp="1"/>
-          </p:cNvSpPr>
-          <p:nvPr/>
-        </p:nvSpPr>
-        <p:spPr>
-          <a:xfrm xmlns:a="http://schemas.openxmlformats.org/drawingml/2006/main">
-            <a:off x="6896100" y="4133850"/>
-            <a:ext cx="2400300" cy="400050"/>
-          </a:xfrm>
-          <a:prstGeom xmlns:a="http://schemas.openxmlformats.org/drawingml/2006/main" prst="rect">
-            <a:avLst/>
-          </a:prstGeom>
-          <a:noFill xmlns:a="http://schemas.openxmlformats.org/drawingml/2006/main"/>
-          <a:ln xmlns:a="http://schemas.openxmlformats.org/drawingml/2006/main" w="0">
-            <a:noFill/>
-            <a:prstDash val="solid"/>
-          </a:ln>
-        </p:spPr>
-        <p:txBody>
-          <a:bodyPr xmlns:a="http://schemas.openxmlformats.org/drawingml/2006/main" wrap="square" lIns="0" tIns="0" rIns="0" bIns="0" anchor="t">
-            <a:normAutofit fontScale="100000"/>
-          </a:bodyPr>
-          <a:lstStyle xmlns:a="http://schemas.openxmlformats.org/drawingml/2006/main"/>
-          <a:p xmlns:a="http://schemas.openxmlformats.org/drawingml/2006/main">
-            <a:pPr algn="l">
-              <a:buNone/>
-              <a:defRPr sz="2025" b="1" i="0">
-                <a:solidFill>
-                  <a:srgbClr val="6C63B5"/>
-                </a:solidFill>
-                <a:latin typeface="Helvetica Neue"/>
-                <a:ea typeface="Helvetica Neue"/>
-                <a:cs typeface="Helvetica Neue"/>
-              </a:defRPr>
-            </a:pPr>
-            <a:r>
-              <a:rPr sz="2025" b="1" i="0">
-                <a:solidFill>
-                  <a:srgbClr val="6C63B5"/>
-                </a:solidFill>
-                <a:latin typeface="Helvetica Neue"/>
-                <a:ea typeface="Helvetica Neue"/>
-                <a:cs typeface="Helvetica Neue"/>
-              </a:rPr>
-              <a:t>95.5%</a:t>
-            </a:r>
-          </a:p>
-        </p:txBody>
-      </p:sp>
-      <p:sp>
-        <p:nvSpPr>
-          <p:cNvPr id="16" name="text">
-            <a:extLst xmlns:a="http://schemas.openxmlformats.org/drawingml/2006/main">
-              <a:ext uri="{FF2B5EF4-FFF2-40B4-BE49-F238E27FC236}">
-                <a16:creationId xmlns:a16="http://schemas.microsoft.com/office/drawing/2014/main" id="{720A6D4D-83F4-4247-AA58-8B7BA298B4E3}"/>
-              </a:ext>
-            </a:extLst>
-          </p:cNvPr>
-          <p:cNvSpPr>
-            <a:spLocks xmlns:a="http://schemas.openxmlformats.org/drawingml/2006/main" noGrp="1"/>
-          </p:cNvSpPr>
-          <p:nvPr/>
-        </p:nvSpPr>
-        <p:spPr>
-          <a:xfrm xmlns:a="http://schemas.openxmlformats.org/drawingml/2006/main">
-            <a:off x="9410700" y="4152900"/>
-            <a:ext cx="2152650" cy="285750"/>
-          </a:xfrm>
-          <a:prstGeom xmlns:a="http://schemas.openxmlformats.org/drawingml/2006/main" prst="rect">
-            <a:avLst/>
-          </a:prstGeom>
-          <a:noFill xmlns:a="http://schemas.openxmlformats.org/drawingml/2006/main"/>
-          <a:ln xmlns:a="http://schemas.openxmlformats.org/drawingml/2006/main" w="0">
-            <a:noFill/>
-            <a:prstDash val="solid"/>
-          </a:ln>
-        </p:spPr>
-        <p:txBody>
-          <a:bodyPr xmlns:a="http://schemas.openxmlformats.org/drawingml/2006/main" wrap="square" lIns="0" tIns="0" rIns="0" bIns="0" anchor="t">
-            <a:normAutofit fontScale="100000"/>
-          </a:bodyPr>
-          <a:lstStyle xmlns:a="http://schemas.openxmlformats.org/drawingml/2006/main"/>
-          <a:p xmlns:a="http://schemas.openxmlformats.org/drawingml/2006/main">
-            <a:pPr algn="l">
-              <a:buNone/>
-              <a:defRPr sz="1350" b="1" i="0">
-                <a:solidFill>
-                  <a:srgbClr val="0A0A0A"/>
-                </a:solidFill>
-                <a:latin typeface="PingFang SC"/>
-                <a:ea typeface="PingFang SC"/>
-                <a:cs typeface="PingFang SC"/>
-              </a:defRPr>
-            </a:pPr>
-            <a:r>
-              <a:rPr sz="1350" b="1" i="0">
-                <a:solidFill>
-                  <a:srgbClr val="0A0A0A"/>
-                </a:solidFill>
-                <a:latin typeface="PingFang SC"/>
-                <a:ea typeface="PingFang SC"/>
-                <a:cs typeface="PingFang SC"/>
-              </a:rPr>
-              <a:t>Final ASR@3</a:t>
-            </a:r>
-          </a:p>
-        </p:txBody>
-      </p:sp>
-      <p:sp>
-        <p:nvSpPr>
-          <p:cNvPr id="17" name="text">
-            <a:extLst xmlns:a="http://schemas.openxmlformats.org/drawingml/2006/main">
-              <a:ext uri="{FF2B5EF4-FFF2-40B4-BE49-F238E27FC236}">
-                <a16:creationId xmlns:a16="http://schemas.microsoft.com/office/drawing/2014/main" id="{BF01CA0A-C427-4147-B049-808691741E55}"/>
-              </a:ext>
-            </a:extLst>
-          </p:cNvPr>
-          <p:cNvSpPr>
-            <a:spLocks xmlns:a="http://schemas.openxmlformats.org/drawingml/2006/main" noGrp="1"/>
-          </p:cNvSpPr>
-          <p:nvPr/>
-        </p:nvSpPr>
-        <p:spPr>
-          <a:xfrm xmlns:a="http://schemas.openxmlformats.org/drawingml/2006/main">
-            <a:off x="9410700" y="4495800"/>
-            <a:ext cx="2152650" cy="285750"/>
-          </a:xfrm>
-          <a:prstGeom xmlns:a="http://schemas.openxmlformats.org/drawingml/2006/main" prst="rect">
-            <a:avLst/>
-          </a:prstGeom>
-          <a:noFill xmlns:a="http://schemas.openxmlformats.org/drawingml/2006/main"/>
-          <a:ln xmlns:a="http://schemas.openxmlformats.org/drawingml/2006/main" w="0">
-            <a:noFill/>
-            <a:prstDash val="solid"/>
-          </a:ln>
-        </p:spPr>
-        <p:txBody>
-          <a:bodyPr xmlns:a="http://schemas.openxmlformats.org/drawingml/2006/main" wrap="square" lIns="0" tIns="0" rIns="0" bIns="0" anchor="t">
-            <a:normAutofit fontScale="100000"/>
-          </a:bodyPr>
-          <a:lstStyle xmlns:a="http://schemas.openxmlformats.org/drawingml/2006/main"/>
-          <a:p xmlns:a="http://schemas.openxmlformats.org/drawingml/2006/main">
-            <a:pPr algn="l">
-              <a:buNone/>
-              <a:defRPr sz="1125" b="0" i="0">
-                <a:solidFill>
-                  <a:srgbClr val="59616D"/>
-                </a:solidFill>
-                <a:latin typeface="PingFang SC"/>
-                <a:ea typeface="PingFang SC"/>
-                <a:cs typeface="PingFang SC"/>
-              </a:defRPr>
-            </a:pPr>
-            <a:r>
-              <a:rPr sz="1125" b="0" i="0">
-                <a:solidFill>
-                  <a:srgbClr val="59616D"/>
-                </a:solidFill>
-                <a:latin typeface="PingFang SC"/>
-                <a:ea typeface="PingFang SC"/>
-                <a:cs typeface="PingFang SC"/>
-              </a:rPr>
-              <a:t>step 240 re-evaluation</a:t>
-            </a:r>
-          </a:p>
-        </p:txBody>
-      </p:sp>
-      <p:cxnSp>
-        <p:nvCxnSpPr>
-          <p:cNvPr id="491" name="rule"/>
-          <p:cNvCxnSpPr/>
-          <p:nvPr/>
-        </p:nvCxnSpPr>
-        <p:spPr>
-          <a:xfrm xmlns:a="http://schemas.openxmlformats.org/drawingml/2006/main">
-            <a:off x="6896100" y="5010150"/>
-            <a:ext cx="4667250" cy="95"/>
-          </a:xfrm>
-          <a:prstGeom xmlns:a="http://schemas.openxmlformats.org/drawingml/2006/main" prst="straightConnector1">
-            <a:avLst/>
-          </a:prstGeom>
-          <a:ln xmlns:a="http://schemas.openxmlformats.org/drawingml/2006/main" w="9525">
-            <a:solidFill>
-              <a:srgbClr val="B8BCC4"/>
-            </a:solidFill>
-            <a:prstDash val="solid"/>
-          </a:ln>
-        </p:spPr>
-      </p:cxnSp>
-      <p:sp>
-        <p:nvSpPr>
-          <p:cNvPr id="19" name="text">
-            <a:extLst xmlns:a="http://schemas.openxmlformats.org/drawingml/2006/main">
-              <a:ext uri="{FF2B5EF4-FFF2-40B4-BE49-F238E27FC236}">
-                <a16:creationId xmlns:a16="http://schemas.microsoft.com/office/drawing/2014/main" id="{65934087-22D5-48BE-BCA4-9E58A58E1FD2}"/>
-              </a:ext>
-            </a:extLst>
-          </p:cNvPr>
-          <p:cNvSpPr>
-            <a:spLocks xmlns:a="http://schemas.openxmlformats.org/drawingml/2006/main" noGrp="1"/>
-          </p:cNvSpPr>
-          <p:nvPr/>
-        </p:nvSpPr>
-        <p:spPr>
-          <a:xfrm xmlns:a="http://schemas.openxmlformats.org/drawingml/2006/main">
-            <a:off x="6896100" y="5353050"/>
-            <a:ext cx="2400300" cy="400050"/>
-          </a:xfrm>
-          <a:prstGeom xmlns:a="http://schemas.openxmlformats.org/drawingml/2006/main" prst="rect">
-            <a:avLst/>
-          </a:prstGeom>
-          <a:noFill xmlns:a="http://schemas.openxmlformats.org/drawingml/2006/main"/>
-          <a:ln xmlns:a="http://schemas.openxmlformats.org/drawingml/2006/main" w="0">
-            <a:noFill/>
-            <a:prstDash val="solid"/>
-          </a:ln>
-        </p:spPr>
-        <p:txBody>
-          <a:bodyPr xmlns:a="http://schemas.openxmlformats.org/drawingml/2006/main" wrap="square" lIns="0" tIns="0" rIns="0" bIns="0" anchor="t">
-            <a:normAutofit fontScale="100000"/>
-          </a:bodyPr>
-          <a:lstStyle xmlns:a="http://schemas.openxmlformats.org/drawingml/2006/main"/>
-          <a:p xmlns:a="http://schemas.openxmlformats.org/drawingml/2006/main">
-            <a:pPr algn="l">
-              <a:buNone/>
-              <a:defRPr sz="2400" b="1" i="0">
-                <a:solidFill>
-                  <a:srgbClr val="2BA84A"/>
-                </a:solidFill>
-                <a:latin typeface="Helvetica Neue"/>
-                <a:ea typeface="Helvetica Neue"/>
-                <a:cs typeface="Helvetica Neue"/>
-              </a:defRPr>
-            </a:pPr>
-            <a:r>
-              <a:rPr sz="2400" b="1" i="0">
-                <a:solidFill>
-                  <a:srgbClr val="2BA84A"/>
-                </a:solidFill>
-                <a:latin typeface="Helvetica Neue"/>
-                <a:ea typeface="Helvetica Neue"/>
-                <a:cs typeface="Helvetica Neue"/>
-              </a:rPr>
-              <a:t>+20.0pp</a:t>
-            </a:r>
-          </a:p>
-        </p:txBody>
-      </p:sp>
-      <p:sp>
-        <p:nvSpPr>
-          <p:cNvPr id="20" name="text">
-            <a:extLst xmlns:a="http://schemas.openxmlformats.org/drawingml/2006/main">
-              <a:ext uri="{FF2B5EF4-FFF2-40B4-BE49-F238E27FC236}">
-                <a16:creationId xmlns:a16="http://schemas.microsoft.com/office/drawing/2014/main" id="{1F6333C0-CC11-4805-B4C7-AEA6645125A9}"/>
-              </a:ext>
-            </a:extLst>
-          </p:cNvPr>
-          <p:cNvSpPr>
-            <a:spLocks xmlns:a="http://schemas.openxmlformats.org/drawingml/2006/main" noGrp="1"/>
-          </p:cNvSpPr>
-          <p:nvPr/>
-        </p:nvSpPr>
-        <p:spPr>
-          <a:xfrm xmlns:a="http://schemas.openxmlformats.org/drawingml/2006/main">
-            <a:off x="9410700" y="5372100"/>
-            <a:ext cx="2152650" cy="285750"/>
-          </a:xfrm>
-          <a:prstGeom xmlns:a="http://schemas.openxmlformats.org/drawingml/2006/main" prst="rect">
-            <a:avLst/>
-          </a:prstGeom>
-          <a:noFill xmlns:a="http://schemas.openxmlformats.org/drawingml/2006/main"/>
-          <a:ln xmlns:a="http://schemas.openxmlformats.org/drawingml/2006/main" w="0">
-            <a:noFill/>
-            <a:prstDash val="solid"/>
-          </a:ln>
-        </p:spPr>
-        <p:txBody>
-          <a:bodyPr xmlns:a="http://schemas.openxmlformats.org/drawingml/2006/main" wrap="square" lIns="0" tIns="0" rIns="0" bIns="0" anchor="t">
-            <a:normAutofit fontScale="100000"/>
-          </a:bodyPr>
-          <a:lstStyle xmlns:a="http://schemas.openxmlformats.org/drawingml/2006/main"/>
-          <a:p xmlns:a="http://schemas.openxmlformats.org/drawingml/2006/main">
-            <a:pPr algn="l">
-              <a:buNone/>
-              <a:defRPr sz="1350" b="1" i="0">
-                <a:solidFill>
-                  <a:srgbClr val="0A0A0A"/>
-                </a:solidFill>
-                <a:latin typeface="PingFang SC"/>
-                <a:ea typeface="PingFang SC"/>
-                <a:cs typeface="PingFang SC"/>
-              </a:defRPr>
-            </a:pPr>
-            <a:r>
-              <a:rPr sz="1350" b="1" i="0">
-                <a:solidFill>
-                  <a:srgbClr val="0A0A0A"/>
-                </a:solidFill>
-                <a:latin typeface="PingFang SC"/>
-                <a:ea typeface="PingFang SC"/>
-                <a:cs typeface="PingFang SC"/>
-              </a:rPr>
-              <a:t>vs. Heretic</a:t>
-            </a:r>
-          </a:p>
-        </p:txBody>
-      </p:sp>
-      <p:sp>
-        <p:nvSpPr>
-          <p:cNvPr id="21" name="text">
-            <a:extLst xmlns:a="http://schemas.openxmlformats.org/drawingml/2006/main">
-              <a:ext uri="{FF2B5EF4-FFF2-40B4-BE49-F238E27FC236}">
-                <a16:creationId xmlns:a16="http://schemas.microsoft.com/office/drawing/2014/main" id="{F57DC6F1-5860-4C8D-A326-CB085C8CC696}"/>
-              </a:ext>
-            </a:extLst>
-          </p:cNvPr>
-          <p:cNvSpPr>
-            <a:spLocks xmlns:a="http://schemas.openxmlformats.org/drawingml/2006/main" noGrp="1"/>
-          </p:cNvSpPr>
-          <p:nvPr/>
-        </p:nvSpPr>
-        <p:spPr>
-          <a:xfrm xmlns:a="http://schemas.openxmlformats.org/drawingml/2006/main">
-            <a:off x="9410700" y="5715000"/>
-            <a:ext cx="2152650" cy="285750"/>
-          </a:xfrm>
-          <a:prstGeom xmlns:a="http://schemas.openxmlformats.org/drawingml/2006/main" prst="rect">
-            <a:avLst/>
-          </a:prstGeom>
-          <a:noFill xmlns:a="http://schemas.openxmlformats.org/drawingml/2006/main"/>
-          <a:ln xmlns:a="http://schemas.openxmlformats.org/drawingml/2006/main" w="0">
-            <a:noFill/>
-            <a:prstDash val="solid"/>
-          </a:ln>
-        </p:spPr>
-        <p:txBody>
-          <a:bodyPr xmlns:a="http://schemas.openxmlformats.org/drawingml/2006/main" wrap="square" lIns="0" tIns="0" rIns="0" bIns="0" anchor="t">
-            <a:normAutofit fontScale="100000"/>
-          </a:bodyPr>
-          <a:lstStyle xmlns:a="http://schemas.openxmlformats.org/drawingml/2006/main"/>
-          <a:p xmlns:a="http://schemas.openxmlformats.org/drawingml/2006/main">
-            <a:pPr algn="l">
-              <a:buNone/>
-              <a:defRPr sz="1125" b="0" i="0">
-                <a:solidFill>
-                  <a:srgbClr val="59616D"/>
-                </a:solidFill>
-                <a:latin typeface="PingFang SC"/>
-                <a:ea typeface="PingFang SC"/>
-                <a:cs typeface="PingFang SC"/>
-              </a:defRPr>
-            </a:pPr>
-            <a:r>
-              <a:rPr sz="1125" b="0" i="0">
-                <a:solidFill>
-                  <a:srgbClr val="59616D"/>
-                </a:solidFill>
-                <a:latin typeface="PingFang SC"/>
-                <a:ea typeface="PingFang SC"/>
-                <a:cs typeface="PingFang SC"/>
-              </a:rPr>
-              <a:t>zero-shot：75.5%</a:t>
-            </a:r>
-          </a:p>
-        </p:txBody>
-      </p:sp>
-      <p:graphicFrame>
-        <p:nvGraphicFramePr>
-          <p:cNvPr id="495" name="Chart"/>
-          <p:cNvGraphicFramePr/>
-          <p:nvPr/>
-        </p:nvGraphicFramePr>
-        <p:xfrm>
-          <a:off xmlns:a="http://schemas.openxmlformats.org/drawingml/2006/main" x="156482" y="2200275"/>
-          <a:ext xmlns:a="http://schemas.openxmlformats.org/drawingml/2006/main" cx="6222214" cy="3119188"/>
-        </p:xfrm>
-        <a:graphic xmlns:a="http://schemas.openxmlformats.org/drawingml/2006/main">
-          <a:graphicData uri="http://schemas.openxmlformats.org/drawingml/2006/chart">
-            <c:chart xmlns:r="http://schemas.openxmlformats.org/officeDocument/2006/relationships" xmlns:c="http://schemas.openxmlformats.org/drawingml/2006/chart" r:id="R8751969121ae4346"/>
-          </a:graphicData>
-        </a:graphic>
-      </p:graphicFrame>
+      <p:pic>
+        <p:nvPicPr>
+          <p:cNvPr id="23" name=""/>
+          <p:cNvPicPr>
+            <a:picLocks xmlns:a="http://schemas.openxmlformats.org/drawingml/2006/main" noChangeAspect="1"/>
+          </p:cNvPicPr>
+          <p:nvPr/>
+        </p:nvPicPr>
+        <p:blipFill>
+          <a:blip xmlns:r="http://schemas.openxmlformats.org/officeDocument/2006/relationships" xmlns:a="http://schemas.openxmlformats.org/drawingml/2006/main" r:embed="Rf813a6eb50b54040"/>
+          <a:srcRect xmlns:a="http://schemas.openxmlformats.org/drawingml/2006/main" l="0" t="17800" r="0" b="9100"/>
+          <a:stretch xmlns:a="http://schemas.openxmlformats.org/drawingml/2006/main"/>
+        </p:blipFill>
+        <p:spPr>
+          <a:xfrm xmlns:a="http://schemas.openxmlformats.org/drawingml/2006/main" flipH="0" flipV="0">
+            <a:off x="400050" y="1466850"/>
+            <a:ext cx="11029950" cy="4667250"/>
+          </a:xfrm>
+          <a:prstGeom xmlns:a="http://schemas.openxmlformats.org/drawingml/2006/main" prst="rect">
+            <a:avLst/>
+          </a:prstGeom>
+        </p:spPr>
+      </p:pic>
     </p:spTree>
     <p:extLst>
       <p:ext uri="{BB962C8B-B14F-4D97-AF65-F5344CB8AC3E}">
-        <p14:creationId xmlns:p14="http://schemas.microsoft.com/office/powerpoint/2010/main" val="2049111161"/>
+        <p14:creationId xmlns:p14="http://schemas.microsoft.com/office/powerpoint/2010/main" val="1302671042"/>
       </p:ext>
     </p:extLst>
   </p:cSld>
@@ -35519,7 +34252,7 @@
         </p:xfrm>
         <a:graphic xmlns:a="http://schemas.openxmlformats.org/drawingml/2006/main">
           <a:graphicData uri="http://schemas.openxmlformats.org/drawingml/2006/chart">
-            <c:chart xmlns:r="http://schemas.openxmlformats.org/officeDocument/2006/relationships" xmlns:c="http://schemas.openxmlformats.org/drawingml/2006/chart" r:id="Rfc9eff35dc164bfb"/>
+            <c:chart xmlns:r="http://schemas.openxmlformats.org/officeDocument/2006/relationships" xmlns:c="http://schemas.openxmlformats.org/drawingml/2006/chart" r:id="R6511872d63564cb2"/>
           </a:graphicData>
         </a:graphic>
       </p:graphicFrame>
@@ -36087,6 +34820,1328 @@
             </a:r>
           </a:p>
         </p:txBody>
+      </p:sp>
+    </p:spTree>
+    <p:extLst>
+      <p:ext uri="{BB962C8B-B14F-4D97-AF65-F5344CB8AC3E}">
+        <p14:creationId xmlns:p14="http://schemas.microsoft.com/office/powerpoint/2010/main" val="1302671042"/>
+      </p:ext>
+    </p:extLst>
+  </p:cSld>
+</p:sld>
+</file>
+
+<file path=ppt/slides/slide35.xml><?xml version="1.0" encoding="utf-8"?>
+<p:sld xmlns:p="http://schemas.openxmlformats.org/presentationml/2006/main">
+  <p:cSld>
+    <p:bg>
+      <p:bgPr>
+        <a:solidFill xmlns:a="http://schemas.openxmlformats.org/drawingml/2006/main">
+          <a:srgbClr val="FFFFFF"/>
+        </a:solidFill>
+      </p:bgPr>
+    </p:bg>
+    <p:spTree>
+      <p:nvGrpSpPr>
+        <p:cNvPr id="1" name=""/>
+        <p:cNvGrpSpPr/>
+        <p:nvPr/>
+      </p:nvGrpSpPr>
+      <p:grpSpPr>
+        <a:xfrm xmlns:a="http://schemas.openxmlformats.org/drawingml/2006/main"/>
+      </p:grpSpPr>
+      <p:sp>
+        <p:nvSpPr>
+          <p:cNvPr id="22" name="section-kicker">
+            <a:extLst xmlns:a="http://schemas.openxmlformats.org/drawingml/2006/main">
+              <a:ext uri="{FF2B5EF4-FFF2-40B4-BE49-F238E27FC236}">
+                <a16:creationId xmlns:a16="http://schemas.microsoft.com/office/drawing/2014/main" id="{982B63FE-AFFC-45D8-B11F-ACE9BF28B34E}"/>
+              </a:ext>
+            </a:extLst>
+          </p:cNvPr>
+          <p:cNvSpPr>
+            <a:spLocks xmlns:a="http://schemas.openxmlformats.org/drawingml/2006/main" noGrp="1"/>
+          </p:cNvSpPr>
+          <p:nvPr/>
+        </p:nvSpPr>
+        <p:spPr>
+          <a:xfrm xmlns:a="http://schemas.openxmlformats.org/drawingml/2006/main">
+            <a:off x="400050" y="228600"/>
+            <a:ext cx="5905500" cy="228600"/>
+          </a:xfrm>
+          <a:prstGeom xmlns:a="http://schemas.openxmlformats.org/drawingml/2006/main" prst="rect">
+            <a:avLst/>
+          </a:prstGeom>
+          <a:noFill xmlns:a="http://schemas.openxmlformats.org/drawingml/2006/main"/>
+          <a:ln xmlns:a="http://schemas.openxmlformats.org/drawingml/2006/main" w="0">
+            <a:noFill/>
+            <a:prstDash val="solid"/>
+          </a:ln>
+        </p:spPr>
+        <p:txBody>
+          <a:bodyPr xmlns:a="http://schemas.openxmlformats.org/drawingml/2006/main" wrap="square" lIns="0" tIns="0" rIns="0" bIns="0" anchor="t">
+            <a:noAutofit/>
+          </a:bodyPr>
+          <a:lstStyle xmlns:a="http://schemas.openxmlformats.org/drawingml/2006/main"/>
+          <a:p xmlns:a="http://schemas.openxmlformats.org/drawingml/2006/main">
+            <a:pPr algn="l">
+              <a:buNone/>
+              <a:defRPr sz="1050" b="1" i="0">
+                <a:solidFill>
+                  <a:srgbClr val="3D8DFF"/>
+                </a:solidFill>
+                <a:latin typeface="Helvetica Neue"/>
+                <a:ea typeface="Helvetica Neue"/>
+                <a:cs typeface="Helvetica Neue"/>
+              </a:defRPr>
+            </a:pPr>
+            <a:r>
+              <a:rPr sz="1050" b="1" i="0">
+                <a:solidFill>
+                  <a:srgbClr val="3D8DFF"/>
+                </a:solidFill>
+                <a:latin typeface="Helvetica Neue"/>
+                <a:ea typeface="Helvetica Neue"/>
+                <a:cs typeface="Helvetica Neue"/>
+              </a:rPr>
+              <a:t>MULTI-TURN ATTACKER · SINGLE VS MULTI</a:t>
+            </a:r>
+          </a:p>
+        </p:txBody>
+      </p:sp>
+      <p:sp>
+        <p:nvSpPr>
+          <p:cNvPr id="2" name="slide-title">
+            <a:extLst xmlns:a="http://schemas.openxmlformats.org/drawingml/2006/main">
+              <a:ext uri="{FF2B5EF4-FFF2-40B4-BE49-F238E27FC236}">
+                <a16:creationId xmlns:a16="http://schemas.microsoft.com/office/drawing/2014/main" id="{BBC91221-9472-4599-B41B-A14DB3A3658D}"/>
+              </a:ext>
+            </a:extLst>
+          </p:cNvPr>
+          <p:cNvSpPr>
+            <a:spLocks xmlns:a="http://schemas.openxmlformats.org/drawingml/2006/main" noGrp="1"/>
+          </p:cNvSpPr>
+          <p:nvPr/>
+        </p:nvSpPr>
+        <p:spPr>
+          <a:xfrm xmlns:a="http://schemas.openxmlformats.org/drawingml/2006/main">
+            <a:off x="400050" y="495300"/>
+            <a:ext cx="10991850" cy="590550"/>
+          </a:xfrm>
+          <a:prstGeom xmlns:a="http://schemas.openxmlformats.org/drawingml/2006/main" prst="rect">
+            <a:avLst/>
+          </a:prstGeom>
+          <a:noFill xmlns:a="http://schemas.openxmlformats.org/drawingml/2006/main"/>
+          <a:ln xmlns:a="http://schemas.openxmlformats.org/drawingml/2006/main" w="0">
+            <a:noFill/>
+            <a:prstDash val="solid"/>
+          </a:ln>
+        </p:spPr>
+        <p:txBody>
+          <a:bodyPr xmlns:a="http://schemas.openxmlformats.org/drawingml/2006/main" wrap="square" lIns="0" tIns="0" rIns="0" bIns="0" anchor="t">
+            <a:normAutofit fontScale="100000"/>
+          </a:bodyPr>
+          <a:lstStyle xmlns:a="http://schemas.openxmlformats.org/drawingml/2006/main"/>
+          <a:p xmlns:a="http://schemas.openxmlformats.org/drawingml/2006/main">
+            <a:pPr algn="l">
+              <a:buNone/>
+              <a:defRPr sz="3450" b="1" i="0">
+                <a:solidFill>
+                  <a:srgbClr val="0A0A0A"/>
+                </a:solidFill>
+                <a:latin typeface="PingFang SC"/>
+                <a:ea typeface="PingFang SC"/>
+                <a:cs typeface="PingFang SC"/>
+              </a:defRPr>
+            </a:pPr>
+            <a:r>
+              <a:rPr sz="3450" b="1" i="0">
+                <a:solidFill>
+                  <a:srgbClr val="0A0A0A"/>
+                </a:solidFill>
+                <a:latin typeface="PingFang SC"/>
+                <a:ea typeface="PingFang SC"/>
+                <a:cs typeface="PingFang SC"/>
+              </a:rPr>
+              <a:t>单轮 vs 多轮：3 个数据集平均 1.2% → 26.7%</a:t>
+            </a:r>
+          </a:p>
+        </p:txBody>
+      </p:sp>
+      <p:sp>
+        <p:nvSpPr>
+          <p:cNvPr id="3" name="title-accent">
+            <a:extLst xmlns:a="http://schemas.openxmlformats.org/drawingml/2006/main">
+              <a:ext uri="{FF2B5EF4-FFF2-40B4-BE49-F238E27FC236}">
+                <a16:creationId xmlns:a16="http://schemas.microsoft.com/office/drawing/2014/main" id="{0D3F7AA2-0F2E-407E-8B66-803ADFDBC63D}"/>
+              </a:ext>
+            </a:extLst>
+          </p:cNvPr>
+          <p:cNvSpPr>
+            <a:spLocks xmlns:a="http://schemas.openxmlformats.org/drawingml/2006/main" noGrp="1"/>
+          </p:cNvSpPr>
+          <p:nvPr/>
+        </p:nvSpPr>
+        <p:spPr>
+          <a:xfrm xmlns:a="http://schemas.openxmlformats.org/drawingml/2006/main">
+            <a:off x="400050" y="1181100"/>
+            <a:ext cx="819150" cy="38100"/>
+          </a:xfrm>
+          <a:prstGeom xmlns:a="http://schemas.openxmlformats.org/drawingml/2006/main" prst="rect">
+            <a:avLst/>
+          </a:prstGeom>
+          <a:solidFill xmlns:a="http://schemas.openxmlformats.org/drawingml/2006/main">
+            <a:srgbClr val="3D8DFF"/>
+          </a:solidFill>
+          <a:ln xmlns:a="http://schemas.openxmlformats.org/drawingml/2006/main" w="0">
+            <a:noFill/>
+            <a:prstDash val="solid"/>
+          </a:ln>
+        </p:spPr>
+      </p:sp>
+      <p:sp>
+        <p:nvSpPr>
+          <p:cNvPr id="4" name="page-number">
+            <a:extLst xmlns:a="http://schemas.openxmlformats.org/drawingml/2006/main">
+              <a:ext uri="{FF2B5EF4-FFF2-40B4-BE49-F238E27FC236}">
+                <a16:creationId xmlns:a16="http://schemas.microsoft.com/office/drawing/2014/main" id="{F8030601-6B38-41A4-BF41-BB0376BCB503}"/>
+              </a:ext>
+            </a:extLst>
+          </p:cNvPr>
+          <p:cNvSpPr>
+            <a:spLocks xmlns:a="http://schemas.openxmlformats.org/drawingml/2006/main" noGrp="1"/>
+          </p:cNvSpPr>
+          <p:nvPr/>
+        </p:nvSpPr>
+        <p:spPr>
+          <a:xfrm xmlns:a="http://schemas.openxmlformats.org/drawingml/2006/main">
+            <a:off x="11277600" y="6324600"/>
+            <a:ext cx="514350" cy="228600"/>
+          </a:xfrm>
+          <a:prstGeom xmlns:a="http://schemas.openxmlformats.org/drawingml/2006/main" prst="rect">
+            <a:avLst/>
+          </a:prstGeom>
+          <a:noFill xmlns:a="http://schemas.openxmlformats.org/drawingml/2006/main"/>
+          <a:ln xmlns:a="http://schemas.openxmlformats.org/drawingml/2006/main" w="0">
+            <a:noFill/>
+            <a:prstDash val="solid"/>
+          </a:ln>
+        </p:spPr>
+        <p:txBody>
+          <a:bodyPr xmlns:a="http://schemas.openxmlformats.org/drawingml/2006/main" wrap="square" lIns="0" tIns="0" rIns="0" bIns="0" anchor="t">
+            <a:noAutofit/>
+          </a:bodyPr>
+          <a:lstStyle xmlns:a="http://schemas.openxmlformats.org/drawingml/2006/main"/>
+          <a:p xmlns:a="http://schemas.openxmlformats.org/drawingml/2006/main">
+            <a:pPr algn="r">
+              <a:buNone/>
+              <a:defRPr sz="975" b="0" i="0">
+                <a:solidFill>
+                  <a:srgbClr val="59616D"/>
+                </a:solidFill>
+                <a:latin typeface="Helvetica Neue"/>
+                <a:ea typeface="Helvetica Neue"/>
+                <a:cs typeface="Helvetica Neue"/>
+              </a:defRPr>
+            </a:pPr>
+            <a:r>
+              <a:rPr sz="975" b="0" i="0">
+                <a:solidFill>
+                  <a:srgbClr val="59616D"/>
+                </a:solidFill>
+                <a:latin typeface="Helvetica Neue"/>
+                <a:ea typeface="Helvetica Neue"/>
+                <a:cs typeface="Helvetica Neue"/>
+              </a:rPr>
+              <a:t>35</a:t>
+            </a:r>
+          </a:p>
+        </p:txBody>
+      </p:sp>
+      <p:sp>
+        <p:nvSpPr>
+          <p:cNvPr id="7" name="text">
+            <a:extLst xmlns:a="http://schemas.openxmlformats.org/drawingml/2006/main">
+              <a:ext uri="{FF2B5EF4-FFF2-40B4-BE49-F238E27FC236}">
+                <a16:creationId xmlns:a16="http://schemas.microsoft.com/office/drawing/2014/main" id="{E52DAB75-C1B6-4936-B730-9FF4E3E140E9}"/>
+              </a:ext>
+            </a:extLst>
+          </p:cNvPr>
+          <p:cNvSpPr>
+            <a:spLocks xmlns:a="http://schemas.openxmlformats.org/drawingml/2006/main" noGrp="1"/>
+          </p:cNvSpPr>
+          <p:nvPr/>
+        </p:nvSpPr>
+        <p:spPr>
+          <a:xfrm xmlns:a="http://schemas.openxmlformats.org/drawingml/2006/main">
+            <a:off x="6896100" y="1695450"/>
+            <a:ext cx="2400300" cy="400050"/>
+          </a:xfrm>
+          <a:prstGeom xmlns:a="http://schemas.openxmlformats.org/drawingml/2006/main" prst="rect">
+            <a:avLst/>
+          </a:prstGeom>
+          <a:noFill xmlns:a="http://schemas.openxmlformats.org/drawingml/2006/main"/>
+          <a:ln xmlns:a="http://schemas.openxmlformats.org/drawingml/2006/main" w="0">
+            <a:noFill/>
+            <a:prstDash val="solid"/>
+          </a:ln>
+        </p:spPr>
+        <p:txBody>
+          <a:bodyPr xmlns:a="http://schemas.openxmlformats.org/drawingml/2006/main" wrap="square" lIns="0" tIns="0" rIns="0" bIns="0" anchor="t">
+            <a:normAutofit fontScale="100000"/>
+          </a:bodyPr>
+          <a:lstStyle xmlns:a="http://schemas.openxmlformats.org/drawingml/2006/main"/>
+          <a:p xmlns:a="http://schemas.openxmlformats.org/drawingml/2006/main">
+            <a:pPr algn="l">
+              <a:buNone/>
+              <a:defRPr sz="2400" b="1" i="0">
+                <a:solidFill>
+                  <a:srgbClr val="3D8DFF"/>
+                </a:solidFill>
+                <a:latin typeface="Helvetica Neue"/>
+                <a:ea typeface="Helvetica Neue"/>
+                <a:cs typeface="Helvetica Neue"/>
+              </a:defRPr>
+            </a:pPr>
+            <a:r>
+              <a:rPr sz="2400" b="1" i="0">
+                <a:solidFill>
+                  <a:srgbClr val="3D8DFF"/>
+                </a:solidFill>
+                <a:latin typeface="Helvetica Neue"/>
+                <a:ea typeface="Helvetica Neue"/>
+                <a:cs typeface="Helvetica Neue"/>
+              </a:rPr>
+              <a:t>1.2%</a:t>
+            </a:r>
+          </a:p>
+        </p:txBody>
+      </p:sp>
+      <p:sp>
+        <p:nvSpPr>
+          <p:cNvPr id="8" name="text">
+            <a:extLst xmlns:a="http://schemas.openxmlformats.org/drawingml/2006/main">
+              <a:ext uri="{FF2B5EF4-FFF2-40B4-BE49-F238E27FC236}">
+                <a16:creationId xmlns:a16="http://schemas.microsoft.com/office/drawing/2014/main" id="{EA2FA1AF-CF6C-43F3-89B3-74D5064C0098}"/>
+              </a:ext>
+            </a:extLst>
+          </p:cNvPr>
+          <p:cNvSpPr>
+            <a:spLocks xmlns:a="http://schemas.openxmlformats.org/drawingml/2006/main" noGrp="1"/>
+          </p:cNvSpPr>
+          <p:nvPr/>
+        </p:nvSpPr>
+        <p:spPr>
+          <a:xfrm xmlns:a="http://schemas.openxmlformats.org/drawingml/2006/main">
+            <a:off x="9410700" y="1714500"/>
+            <a:ext cx="2152650" cy="285750"/>
+          </a:xfrm>
+          <a:prstGeom xmlns:a="http://schemas.openxmlformats.org/drawingml/2006/main" prst="rect">
+            <a:avLst/>
+          </a:prstGeom>
+          <a:noFill xmlns:a="http://schemas.openxmlformats.org/drawingml/2006/main"/>
+          <a:ln xmlns:a="http://schemas.openxmlformats.org/drawingml/2006/main" w="0">
+            <a:noFill/>
+            <a:prstDash val="solid"/>
+          </a:ln>
+        </p:spPr>
+        <p:txBody>
+          <a:bodyPr xmlns:a="http://schemas.openxmlformats.org/drawingml/2006/main" wrap="square" lIns="0" tIns="0" rIns="0" bIns="0" anchor="t">
+            <a:normAutofit fontScale="100000"/>
+          </a:bodyPr>
+          <a:lstStyle xmlns:a="http://schemas.openxmlformats.org/drawingml/2006/main"/>
+          <a:p xmlns:a="http://schemas.openxmlformats.org/drawingml/2006/main">
+            <a:pPr algn="l">
+              <a:buNone/>
+              <a:defRPr sz="1350" b="1" i="0">
+                <a:solidFill>
+                  <a:srgbClr val="0A0A0A"/>
+                </a:solidFill>
+                <a:latin typeface="PingFang SC"/>
+                <a:ea typeface="PingFang SC"/>
+                <a:cs typeface="PingFang SC"/>
+              </a:defRPr>
+            </a:pPr>
+            <a:r>
+              <a:rPr sz="1350" b="1" i="0">
+                <a:solidFill>
+                  <a:srgbClr val="0A0A0A"/>
+                </a:solidFill>
+                <a:latin typeface="PingFang SC"/>
+                <a:ea typeface="PingFang SC"/>
+                <a:cs typeface="PingFang SC"/>
+              </a:rPr>
+              <a:t>单轮直送</a:t>
+            </a:r>
+          </a:p>
+        </p:txBody>
+      </p:sp>
+      <p:sp>
+        <p:nvSpPr>
+          <p:cNvPr id="9" name="text">
+            <a:extLst xmlns:a="http://schemas.openxmlformats.org/drawingml/2006/main">
+              <a:ext uri="{FF2B5EF4-FFF2-40B4-BE49-F238E27FC236}">
+                <a16:creationId xmlns:a16="http://schemas.microsoft.com/office/drawing/2014/main" id="{CEE2C4C3-4E94-402B-AD86-0234195DD209}"/>
+              </a:ext>
+            </a:extLst>
+          </p:cNvPr>
+          <p:cNvSpPr>
+            <a:spLocks xmlns:a="http://schemas.openxmlformats.org/drawingml/2006/main" noGrp="1"/>
+          </p:cNvSpPr>
+          <p:nvPr/>
+        </p:nvSpPr>
+        <p:spPr>
+          <a:xfrm xmlns:a="http://schemas.openxmlformats.org/drawingml/2006/main">
+            <a:off x="9410700" y="2057400"/>
+            <a:ext cx="2152650" cy="285750"/>
+          </a:xfrm>
+          <a:prstGeom xmlns:a="http://schemas.openxmlformats.org/drawingml/2006/main" prst="rect">
+            <a:avLst/>
+          </a:prstGeom>
+          <a:noFill xmlns:a="http://schemas.openxmlformats.org/drawingml/2006/main"/>
+          <a:ln xmlns:a="http://schemas.openxmlformats.org/drawingml/2006/main" w="0">
+            <a:noFill/>
+            <a:prstDash val="solid"/>
+          </a:ln>
+        </p:spPr>
+        <p:txBody>
+          <a:bodyPr xmlns:a="http://schemas.openxmlformats.org/drawingml/2006/main" wrap="square" lIns="0" tIns="0" rIns="0" bIns="0" anchor="t">
+            <a:normAutofit fontScale="100000"/>
+          </a:bodyPr>
+          <a:lstStyle xmlns:a="http://schemas.openxmlformats.org/drawingml/2006/main"/>
+          <a:p xmlns:a="http://schemas.openxmlformats.org/drawingml/2006/main">
+            <a:pPr algn="l">
+              <a:buNone/>
+              <a:defRPr sz="1125" b="0" i="0">
+                <a:solidFill>
+                  <a:srgbClr val="59616D"/>
+                </a:solidFill>
+                <a:latin typeface="PingFang SC"/>
+                <a:ea typeface="PingFang SC"/>
+                <a:cs typeface="PingFang SC"/>
+              </a:defRPr>
+            </a:pPr>
+            <a:r>
+              <a:rPr sz="1125" b="0" i="0">
+                <a:solidFill>
+                  <a:srgbClr val="59616D"/>
+                </a:solidFill>
+                <a:latin typeface="PingFang SC"/>
+                <a:ea typeface="PingFang SC"/>
+                <a:cs typeface="PingFang SC"/>
+              </a:rPr>
+              <a:t>12 cells macro</a:t>
+            </a:r>
+          </a:p>
+        </p:txBody>
+      </p:sp>
+      <p:cxnSp>
+        <p:nvCxnSpPr>
+          <p:cNvPr id="653" name="rule"/>
+          <p:cNvCxnSpPr/>
+          <p:nvPr/>
+        </p:nvCxnSpPr>
+        <p:spPr>
+          <a:xfrm xmlns:a="http://schemas.openxmlformats.org/drawingml/2006/main">
+            <a:off x="6896100" y="2571750"/>
+            <a:ext cx="4667250" cy="95"/>
+          </a:xfrm>
+          <a:prstGeom xmlns:a="http://schemas.openxmlformats.org/drawingml/2006/main" prst="straightConnector1">
+            <a:avLst/>
+          </a:prstGeom>
+          <a:ln xmlns:a="http://schemas.openxmlformats.org/drawingml/2006/main" w="9525">
+            <a:solidFill>
+              <a:srgbClr val="B8BCC4"/>
+            </a:solidFill>
+            <a:prstDash val="solid"/>
+          </a:ln>
+        </p:spPr>
+      </p:cxnSp>
+      <p:sp>
+        <p:nvSpPr>
+          <p:cNvPr id="11" name="text">
+            <a:extLst xmlns:a="http://schemas.openxmlformats.org/drawingml/2006/main">
+              <a:ext uri="{FF2B5EF4-FFF2-40B4-BE49-F238E27FC236}">
+                <a16:creationId xmlns:a16="http://schemas.microsoft.com/office/drawing/2014/main" id="{647FAD0C-A30E-4B94-AE75-D7A91049B334}"/>
+              </a:ext>
+            </a:extLst>
+          </p:cNvPr>
+          <p:cNvSpPr>
+            <a:spLocks xmlns:a="http://schemas.openxmlformats.org/drawingml/2006/main" noGrp="1"/>
+          </p:cNvSpPr>
+          <p:nvPr/>
+        </p:nvSpPr>
+        <p:spPr>
+          <a:xfrm xmlns:a="http://schemas.openxmlformats.org/drawingml/2006/main">
+            <a:off x="6896100" y="2914650"/>
+            <a:ext cx="2400300" cy="400050"/>
+          </a:xfrm>
+          <a:prstGeom xmlns:a="http://schemas.openxmlformats.org/drawingml/2006/main" prst="rect">
+            <a:avLst/>
+          </a:prstGeom>
+          <a:noFill xmlns:a="http://schemas.openxmlformats.org/drawingml/2006/main"/>
+          <a:ln xmlns:a="http://schemas.openxmlformats.org/drawingml/2006/main" w="0">
+            <a:noFill/>
+            <a:prstDash val="solid"/>
+          </a:ln>
+        </p:spPr>
+        <p:txBody>
+          <a:bodyPr xmlns:a="http://schemas.openxmlformats.org/drawingml/2006/main" wrap="square" lIns="0" tIns="0" rIns="0" bIns="0" anchor="t">
+            <a:normAutofit fontScale="100000"/>
+          </a:bodyPr>
+          <a:lstStyle xmlns:a="http://schemas.openxmlformats.org/drawingml/2006/main"/>
+          <a:p xmlns:a="http://schemas.openxmlformats.org/drawingml/2006/main">
+            <a:pPr algn="l">
+              <a:buNone/>
+              <a:defRPr sz="2400" b="1" i="0">
+                <a:solidFill>
+                  <a:srgbClr val="D84A4A"/>
+                </a:solidFill>
+                <a:latin typeface="Helvetica Neue"/>
+                <a:ea typeface="Helvetica Neue"/>
+                <a:cs typeface="Helvetica Neue"/>
+              </a:defRPr>
+            </a:pPr>
+            <a:r>
+              <a:rPr sz="2400" b="1" i="0">
+                <a:solidFill>
+                  <a:srgbClr val="D84A4A"/>
+                </a:solidFill>
+                <a:latin typeface="Helvetica Neue"/>
+                <a:ea typeface="Helvetica Neue"/>
+                <a:cs typeface="Helvetica Neue"/>
+              </a:rPr>
+              <a:t>26.7%</a:t>
+            </a:r>
+          </a:p>
+        </p:txBody>
+      </p:sp>
+      <p:sp>
+        <p:nvSpPr>
+          <p:cNvPr id="12" name="text">
+            <a:extLst xmlns:a="http://schemas.openxmlformats.org/drawingml/2006/main">
+              <a:ext uri="{FF2B5EF4-FFF2-40B4-BE49-F238E27FC236}">
+                <a16:creationId xmlns:a16="http://schemas.microsoft.com/office/drawing/2014/main" id="{B75B1331-59AA-4F74-B403-D42ED90FA70D}"/>
+              </a:ext>
+            </a:extLst>
+          </p:cNvPr>
+          <p:cNvSpPr>
+            <a:spLocks xmlns:a="http://schemas.openxmlformats.org/drawingml/2006/main" noGrp="1"/>
+          </p:cNvSpPr>
+          <p:nvPr/>
+        </p:nvSpPr>
+        <p:spPr>
+          <a:xfrm xmlns:a="http://schemas.openxmlformats.org/drawingml/2006/main">
+            <a:off x="9410700" y="2933700"/>
+            <a:ext cx="2152650" cy="285750"/>
+          </a:xfrm>
+          <a:prstGeom xmlns:a="http://schemas.openxmlformats.org/drawingml/2006/main" prst="rect">
+            <a:avLst/>
+          </a:prstGeom>
+          <a:noFill xmlns:a="http://schemas.openxmlformats.org/drawingml/2006/main"/>
+          <a:ln xmlns:a="http://schemas.openxmlformats.org/drawingml/2006/main" w="0">
+            <a:noFill/>
+            <a:prstDash val="solid"/>
+          </a:ln>
+        </p:spPr>
+        <p:txBody>
+          <a:bodyPr xmlns:a="http://schemas.openxmlformats.org/drawingml/2006/main" wrap="square" lIns="0" tIns="0" rIns="0" bIns="0" anchor="t">
+            <a:normAutofit fontScale="100000"/>
+          </a:bodyPr>
+          <a:lstStyle xmlns:a="http://schemas.openxmlformats.org/drawingml/2006/main"/>
+          <a:p xmlns:a="http://schemas.openxmlformats.org/drawingml/2006/main">
+            <a:pPr algn="l">
+              <a:buNone/>
+              <a:defRPr sz="1350" b="1" i="0">
+                <a:solidFill>
+                  <a:srgbClr val="0A0A0A"/>
+                </a:solidFill>
+                <a:latin typeface="PingFang SC"/>
+                <a:ea typeface="PingFang SC"/>
+                <a:cs typeface="PingFang SC"/>
+              </a:defRPr>
+            </a:pPr>
+            <a:r>
+              <a:rPr sz="1350" b="1" i="0">
+                <a:solidFill>
+                  <a:srgbClr val="0A0A0A"/>
+                </a:solidFill>
+                <a:latin typeface="PingFang SC"/>
+                <a:ea typeface="PingFang SC"/>
+                <a:cs typeface="PingFang SC"/>
+              </a:rPr>
+              <a:t>多轮 skill</a:t>
+            </a:r>
+          </a:p>
+        </p:txBody>
+      </p:sp>
+      <p:sp>
+        <p:nvSpPr>
+          <p:cNvPr id="13" name="text">
+            <a:extLst xmlns:a="http://schemas.openxmlformats.org/drawingml/2006/main">
+              <a:ext uri="{FF2B5EF4-FFF2-40B4-BE49-F238E27FC236}">
+                <a16:creationId xmlns:a16="http://schemas.microsoft.com/office/drawing/2014/main" id="{800D6D90-1C7B-4848-9184-A551BC555502}"/>
+              </a:ext>
+            </a:extLst>
+          </p:cNvPr>
+          <p:cNvSpPr>
+            <a:spLocks xmlns:a="http://schemas.openxmlformats.org/drawingml/2006/main" noGrp="1"/>
+          </p:cNvSpPr>
+          <p:nvPr/>
+        </p:nvSpPr>
+        <p:spPr>
+          <a:xfrm xmlns:a="http://schemas.openxmlformats.org/drawingml/2006/main">
+            <a:off x="9410700" y="3276600"/>
+            <a:ext cx="2152650" cy="285750"/>
+          </a:xfrm>
+          <a:prstGeom xmlns:a="http://schemas.openxmlformats.org/drawingml/2006/main" prst="rect">
+            <a:avLst/>
+          </a:prstGeom>
+          <a:noFill xmlns:a="http://schemas.openxmlformats.org/drawingml/2006/main"/>
+          <a:ln xmlns:a="http://schemas.openxmlformats.org/drawingml/2006/main" w="0">
+            <a:noFill/>
+            <a:prstDash val="solid"/>
+          </a:ln>
+        </p:spPr>
+        <p:txBody>
+          <a:bodyPr xmlns:a="http://schemas.openxmlformats.org/drawingml/2006/main" wrap="square" lIns="0" tIns="0" rIns="0" bIns="0" anchor="t">
+            <a:normAutofit fontScale="100000"/>
+          </a:bodyPr>
+          <a:lstStyle xmlns:a="http://schemas.openxmlformats.org/drawingml/2006/main"/>
+          <a:p xmlns:a="http://schemas.openxmlformats.org/drawingml/2006/main">
+            <a:pPr algn="l">
+              <a:buNone/>
+              <a:defRPr sz="1125" b="0" i="0">
+                <a:solidFill>
+                  <a:srgbClr val="59616D"/>
+                </a:solidFill>
+                <a:latin typeface="PingFang SC"/>
+                <a:ea typeface="PingFang SC"/>
+                <a:cs typeface="PingFang SC"/>
+              </a:defRPr>
+            </a:pPr>
+            <a:r>
+              <a:rPr sz="1125" b="0" i="0">
+                <a:solidFill>
+                  <a:srgbClr val="59616D"/>
+                </a:solidFill>
+                <a:latin typeface="PingFang SC"/>
+                <a:ea typeface="PingFang SC"/>
+                <a:cs typeface="PingFang SC"/>
+              </a:rPr>
+              <a:t>canonical base27B</a:t>
+            </a:r>
+          </a:p>
+        </p:txBody>
+      </p:sp>
+      <p:cxnSp>
+        <p:nvCxnSpPr>
+          <p:cNvPr id="657" name="rule"/>
+          <p:cNvCxnSpPr/>
+          <p:nvPr/>
+        </p:nvCxnSpPr>
+        <p:spPr>
+          <a:xfrm xmlns:a="http://schemas.openxmlformats.org/drawingml/2006/main">
+            <a:off x="6896100" y="3790950"/>
+            <a:ext cx="4667250" cy="95"/>
+          </a:xfrm>
+          <a:prstGeom xmlns:a="http://schemas.openxmlformats.org/drawingml/2006/main" prst="straightConnector1">
+            <a:avLst/>
+          </a:prstGeom>
+          <a:ln xmlns:a="http://schemas.openxmlformats.org/drawingml/2006/main" w="9525">
+            <a:solidFill>
+              <a:srgbClr val="B8BCC4"/>
+            </a:solidFill>
+            <a:prstDash val="solid"/>
+          </a:ln>
+        </p:spPr>
+      </p:cxnSp>
+      <p:sp>
+        <p:nvSpPr>
+          <p:cNvPr id="15" name="text">
+            <a:extLst xmlns:a="http://schemas.openxmlformats.org/drawingml/2006/main">
+              <a:ext uri="{FF2B5EF4-FFF2-40B4-BE49-F238E27FC236}">
+                <a16:creationId xmlns:a16="http://schemas.microsoft.com/office/drawing/2014/main" id="{2887DE25-C034-491B-9EAF-AD4173166FE8}"/>
+              </a:ext>
+            </a:extLst>
+          </p:cNvPr>
+          <p:cNvSpPr>
+            <a:spLocks xmlns:a="http://schemas.openxmlformats.org/drawingml/2006/main" noGrp="1"/>
+          </p:cNvSpPr>
+          <p:nvPr/>
+        </p:nvSpPr>
+        <p:spPr>
+          <a:xfrm xmlns:a="http://schemas.openxmlformats.org/drawingml/2006/main">
+            <a:off x="6896100" y="4133850"/>
+            <a:ext cx="2400300" cy="400050"/>
+          </a:xfrm>
+          <a:prstGeom xmlns:a="http://schemas.openxmlformats.org/drawingml/2006/main" prst="rect">
+            <a:avLst/>
+          </a:prstGeom>
+          <a:noFill xmlns:a="http://schemas.openxmlformats.org/drawingml/2006/main"/>
+          <a:ln xmlns:a="http://schemas.openxmlformats.org/drawingml/2006/main" w="0">
+            <a:noFill/>
+            <a:prstDash val="solid"/>
+          </a:ln>
+        </p:spPr>
+        <p:txBody>
+          <a:bodyPr xmlns:a="http://schemas.openxmlformats.org/drawingml/2006/main" wrap="square" lIns="0" tIns="0" rIns="0" bIns="0" anchor="t">
+            <a:normAutofit fontScale="100000"/>
+          </a:bodyPr>
+          <a:lstStyle xmlns:a="http://schemas.openxmlformats.org/drawingml/2006/main"/>
+          <a:p xmlns:a="http://schemas.openxmlformats.org/drawingml/2006/main">
+            <a:pPr algn="l">
+              <a:buNone/>
+              <a:defRPr sz="2025" b="1" i="0">
+                <a:solidFill>
+                  <a:srgbClr val="6C63B5"/>
+                </a:solidFill>
+                <a:latin typeface="Helvetica Neue"/>
+                <a:ea typeface="Helvetica Neue"/>
+                <a:cs typeface="Helvetica Neue"/>
+              </a:defRPr>
+            </a:pPr>
+            <a:r>
+              <a:rPr sz="2025" b="1" i="0">
+                <a:solidFill>
+                  <a:srgbClr val="6C63B5"/>
+                </a:solidFill>
+                <a:latin typeface="Helvetica Neue"/>
+                <a:ea typeface="Helvetica Neue"/>
+                <a:cs typeface="Helvetica Neue"/>
+              </a:rPr>
+              <a:t>+25.5pp</a:t>
+            </a:r>
+          </a:p>
+        </p:txBody>
+      </p:sp>
+      <p:sp>
+        <p:nvSpPr>
+          <p:cNvPr id="16" name="text">
+            <a:extLst xmlns:a="http://schemas.openxmlformats.org/drawingml/2006/main">
+              <a:ext uri="{FF2B5EF4-FFF2-40B4-BE49-F238E27FC236}">
+                <a16:creationId xmlns:a16="http://schemas.microsoft.com/office/drawing/2014/main" id="{720A6D4D-83F4-4247-AA58-8B7BA298B4E3}"/>
+              </a:ext>
+            </a:extLst>
+          </p:cNvPr>
+          <p:cNvSpPr>
+            <a:spLocks xmlns:a="http://schemas.openxmlformats.org/drawingml/2006/main" noGrp="1"/>
+          </p:cNvSpPr>
+          <p:nvPr/>
+        </p:nvSpPr>
+        <p:spPr>
+          <a:xfrm xmlns:a="http://schemas.openxmlformats.org/drawingml/2006/main">
+            <a:off x="9410700" y="4152900"/>
+            <a:ext cx="2152650" cy="285750"/>
+          </a:xfrm>
+          <a:prstGeom xmlns:a="http://schemas.openxmlformats.org/drawingml/2006/main" prst="rect">
+            <a:avLst/>
+          </a:prstGeom>
+          <a:noFill xmlns:a="http://schemas.openxmlformats.org/drawingml/2006/main"/>
+          <a:ln xmlns:a="http://schemas.openxmlformats.org/drawingml/2006/main" w="0">
+            <a:noFill/>
+            <a:prstDash val="solid"/>
+          </a:ln>
+        </p:spPr>
+        <p:txBody>
+          <a:bodyPr xmlns:a="http://schemas.openxmlformats.org/drawingml/2006/main" wrap="square" lIns="0" tIns="0" rIns="0" bIns="0" anchor="t">
+            <a:normAutofit fontScale="100000"/>
+          </a:bodyPr>
+          <a:lstStyle xmlns:a="http://schemas.openxmlformats.org/drawingml/2006/main"/>
+          <a:p xmlns:a="http://schemas.openxmlformats.org/drawingml/2006/main">
+            <a:pPr algn="l">
+              <a:buNone/>
+              <a:defRPr sz="1350" b="1" i="0">
+                <a:solidFill>
+                  <a:srgbClr val="0A0A0A"/>
+                </a:solidFill>
+                <a:latin typeface="PingFang SC"/>
+                <a:ea typeface="PingFang SC"/>
+                <a:cs typeface="PingFang SC"/>
+              </a:defRPr>
+            </a:pPr>
+            <a:r>
+              <a:rPr sz="1350" b="1" i="0">
+                <a:solidFill>
+                  <a:srgbClr val="0A0A0A"/>
+                </a:solidFill>
+                <a:latin typeface="PingFang SC"/>
+                <a:ea typeface="PingFang SC"/>
+                <a:cs typeface="PingFang SC"/>
+              </a:rPr>
+              <a:t>Absolute uplift</a:t>
+            </a:r>
+          </a:p>
+        </p:txBody>
+      </p:sp>
+      <p:sp>
+        <p:nvSpPr>
+          <p:cNvPr id="17" name="text">
+            <a:extLst xmlns:a="http://schemas.openxmlformats.org/drawingml/2006/main">
+              <a:ext uri="{FF2B5EF4-FFF2-40B4-BE49-F238E27FC236}">
+                <a16:creationId xmlns:a16="http://schemas.microsoft.com/office/drawing/2014/main" id="{BF01CA0A-C427-4147-B049-808691741E55}"/>
+              </a:ext>
+            </a:extLst>
+          </p:cNvPr>
+          <p:cNvSpPr>
+            <a:spLocks xmlns:a="http://schemas.openxmlformats.org/drawingml/2006/main" noGrp="1"/>
+          </p:cNvSpPr>
+          <p:nvPr/>
+        </p:nvSpPr>
+        <p:spPr>
+          <a:xfrm xmlns:a="http://schemas.openxmlformats.org/drawingml/2006/main">
+            <a:off x="9410700" y="4495800"/>
+            <a:ext cx="2152650" cy="285750"/>
+          </a:xfrm>
+          <a:prstGeom xmlns:a="http://schemas.openxmlformats.org/drawingml/2006/main" prst="rect">
+            <a:avLst/>
+          </a:prstGeom>
+          <a:noFill xmlns:a="http://schemas.openxmlformats.org/drawingml/2006/main"/>
+          <a:ln xmlns:a="http://schemas.openxmlformats.org/drawingml/2006/main" w="0">
+            <a:noFill/>
+            <a:prstDash val="solid"/>
+          </a:ln>
+        </p:spPr>
+        <p:txBody>
+          <a:bodyPr xmlns:a="http://schemas.openxmlformats.org/drawingml/2006/main" wrap="square" lIns="0" tIns="0" rIns="0" bIns="0" anchor="t">
+            <a:normAutofit fontScale="100000"/>
+          </a:bodyPr>
+          <a:lstStyle xmlns:a="http://schemas.openxmlformats.org/drawingml/2006/main"/>
+          <a:p xmlns:a="http://schemas.openxmlformats.org/drawingml/2006/main">
+            <a:pPr algn="l">
+              <a:buNone/>
+              <a:defRPr sz="1125" b="0" i="0">
+                <a:solidFill>
+                  <a:srgbClr val="59616D"/>
+                </a:solidFill>
+                <a:latin typeface="PingFang SC"/>
+                <a:ea typeface="PingFang SC"/>
+                <a:cs typeface="PingFang SC"/>
+              </a:defRPr>
+            </a:pPr>
+            <a:r>
+              <a:rPr sz="1125" b="0" i="0">
+                <a:solidFill>
+                  <a:srgbClr val="59616D"/>
+                </a:solidFill>
+                <a:latin typeface="PingFang SC"/>
+                <a:ea typeface="PingFang SC"/>
+                <a:cs typeface="PingFang SC"/>
+              </a:rPr>
+              <a:t>22.4× relative</a:t>
+            </a:r>
+          </a:p>
+        </p:txBody>
+      </p:sp>
+      <p:cxnSp>
+        <p:nvCxnSpPr>
+          <p:cNvPr id="661" name="rule"/>
+          <p:cNvCxnSpPr/>
+          <p:nvPr/>
+        </p:nvCxnSpPr>
+        <p:spPr>
+          <a:xfrm xmlns:a="http://schemas.openxmlformats.org/drawingml/2006/main">
+            <a:off x="6896100" y="5010150"/>
+            <a:ext cx="4667250" cy="95"/>
+          </a:xfrm>
+          <a:prstGeom xmlns:a="http://schemas.openxmlformats.org/drawingml/2006/main" prst="straightConnector1">
+            <a:avLst/>
+          </a:prstGeom>
+          <a:ln xmlns:a="http://schemas.openxmlformats.org/drawingml/2006/main" w="9525">
+            <a:solidFill>
+              <a:srgbClr val="B8BCC4"/>
+            </a:solidFill>
+            <a:prstDash val="solid"/>
+          </a:ln>
+        </p:spPr>
+      </p:cxnSp>
+      <p:sp>
+        <p:nvSpPr>
+          <p:cNvPr id="19" name="text">
+            <a:extLst xmlns:a="http://schemas.openxmlformats.org/drawingml/2006/main">
+              <a:ext uri="{FF2B5EF4-FFF2-40B4-BE49-F238E27FC236}">
+                <a16:creationId xmlns:a16="http://schemas.microsoft.com/office/drawing/2014/main" id="{65934087-22D5-48BE-BCA4-9E58A58E1FD2}"/>
+              </a:ext>
+            </a:extLst>
+          </p:cNvPr>
+          <p:cNvSpPr>
+            <a:spLocks xmlns:a="http://schemas.openxmlformats.org/drawingml/2006/main" noGrp="1"/>
+          </p:cNvSpPr>
+          <p:nvPr/>
+        </p:nvSpPr>
+        <p:spPr>
+          <a:xfrm xmlns:a="http://schemas.openxmlformats.org/drawingml/2006/main">
+            <a:off x="6896100" y="5353050"/>
+            <a:ext cx="2400300" cy="400050"/>
+          </a:xfrm>
+          <a:prstGeom xmlns:a="http://schemas.openxmlformats.org/drawingml/2006/main" prst="rect">
+            <a:avLst/>
+          </a:prstGeom>
+          <a:noFill xmlns:a="http://schemas.openxmlformats.org/drawingml/2006/main"/>
+          <a:ln xmlns:a="http://schemas.openxmlformats.org/drawingml/2006/main" w="0">
+            <a:noFill/>
+            <a:prstDash val="solid"/>
+          </a:ln>
+        </p:spPr>
+        <p:txBody>
+          <a:bodyPr xmlns:a="http://schemas.openxmlformats.org/drawingml/2006/main" wrap="square" lIns="0" tIns="0" rIns="0" bIns="0" anchor="t">
+            <a:normAutofit fontScale="100000"/>
+          </a:bodyPr>
+          <a:lstStyle xmlns:a="http://schemas.openxmlformats.org/drawingml/2006/main"/>
+          <a:p xmlns:a="http://schemas.openxmlformats.org/drawingml/2006/main">
+            <a:pPr algn="l">
+              <a:buNone/>
+              <a:defRPr sz="2400" b="1" i="0">
+                <a:solidFill>
+                  <a:srgbClr val="2BA84A"/>
+                </a:solidFill>
+                <a:latin typeface="Helvetica Neue"/>
+                <a:ea typeface="Helvetica Neue"/>
+                <a:cs typeface="Helvetica Neue"/>
+              </a:defRPr>
+            </a:pPr>
+            <a:r>
+              <a:rPr sz="2400" b="1" i="0">
+                <a:solidFill>
+                  <a:srgbClr val="2BA84A"/>
+                </a:solidFill>
+                <a:latin typeface="Helvetica Neue"/>
+                <a:ea typeface="Helvetica Neue"/>
+                <a:cs typeface="Helvetica Neue"/>
+              </a:rPr>
+              <a:t>4 / 4</a:t>
+            </a:r>
+          </a:p>
+        </p:txBody>
+      </p:sp>
+      <p:sp>
+        <p:nvSpPr>
+          <p:cNvPr id="20" name="text">
+            <a:extLst xmlns:a="http://schemas.openxmlformats.org/drawingml/2006/main">
+              <a:ext uri="{FF2B5EF4-FFF2-40B4-BE49-F238E27FC236}">
+                <a16:creationId xmlns:a16="http://schemas.microsoft.com/office/drawing/2014/main" id="{1F6333C0-CC11-4805-B4C7-AEA6645125A9}"/>
+              </a:ext>
+            </a:extLst>
+          </p:cNvPr>
+          <p:cNvSpPr>
+            <a:spLocks xmlns:a="http://schemas.openxmlformats.org/drawingml/2006/main" noGrp="1"/>
+          </p:cNvSpPr>
+          <p:nvPr/>
+        </p:nvSpPr>
+        <p:spPr>
+          <a:xfrm xmlns:a="http://schemas.openxmlformats.org/drawingml/2006/main">
+            <a:off x="9410700" y="5372100"/>
+            <a:ext cx="2152650" cy="285750"/>
+          </a:xfrm>
+          <a:prstGeom xmlns:a="http://schemas.openxmlformats.org/drawingml/2006/main" prst="rect">
+            <a:avLst/>
+          </a:prstGeom>
+          <a:noFill xmlns:a="http://schemas.openxmlformats.org/drawingml/2006/main"/>
+          <a:ln xmlns:a="http://schemas.openxmlformats.org/drawingml/2006/main" w="0">
+            <a:noFill/>
+            <a:prstDash val="solid"/>
+          </a:ln>
+        </p:spPr>
+        <p:txBody>
+          <a:bodyPr xmlns:a="http://schemas.openxmlformats.org/drawingml/2006/main" wrap="square" lIns="0" tIns="0" rIns="0" bIns="0" anchor="t">
+            <a:normAutofit fontScale="100000"/>
+          </a:bodyPr>
+          <a:lstStyle xmlns:a="http://schemas.openxmlformats.org/drawingml/2006/main"/>
+          <a:p xmlns:a="http://schemas.openxmlformats.org/drawingml/2006/main">
+            <a:pPr algn="l">
+              <a:buNone/>
+              <a:defRPr sz="1350" b="1" i="0">
+                <a:solidFill>
+                  <a:srgbClr val="0A0A0A"/>
+                </a:solidFill>
+                <a:latin typeface="PingFang SC"/>
+                <a:ea typeface="PingFang SC"/>
+                <a:cs typeface="PingFang SC"/>
+              </a:defRPr>
+            </a:pPr>
+            <a:r>
+              <a:rPr sz="1350" b="1" i="0">
+                <a:solidFill>
+                  <a:srgbClr val="0A0A0A"/>
+                </a:solidFill>
+                <a:latin typeface="PingFang SC"/>
+                <a:ea typeface="PingFang SC"/>
+                <a:cs typeface="PingFang SC"/>
+              </a:rPr>
+              <a:t>Victims improve</a:t>
+            </a:r>
+          </a:p>
+        </p:txBody>
+      </p:sp>
+      <p:sp>
+        <p:nvSpPr>
+          <p:cNvPr id="21" name="text">
+            <a:extLst xmlns:a="http://schemas.openxmlformats.org/drawingml/2006/main">
+              <a:ext uri="{FF2B5EF4-FFF2-40B4-BE49-F238E27FC236}">
+                <a16:creationId xmlns:a16="http://schemas.microsoft.com/office/drawing/2014/main" id="{F57DC6F1-5860-4C8D-A326-CB085C8CC696}"/>
+              </a:ext>
+            </a:extLst>
+          </p:cNvPr>
+          <p:cNvSpPr>
+            <a:spLocks xmlns:a="http://schemas.openxmlformats.org/drawingml/2006/main" noGrp="1"/>
+          </p:cNvSpPr>
+          <p:nvPr/>
+        </p:nvSpPr>
+        <p:spPr>
+          <a:xfrm xmlns:a="http://schemas.openxmlformats.org/drawingml/2006/main">
+            <a:off x="9410700" y="5715000"/>
+            <a:ext cx="2152650" cy="285750"/>
+          </a:xfrm>
+          <a:prstGeom xmlns:a="http://schemas.openxmlformats.org/drawingml/2006/main" prst="rect">
+            <a:avLst/>
+          </a:prstGeom>
+          <a:noFill xmlns:a="http://schemas.openxmlformats.org/drawingml/2006/main"/>
+          <a:ln xmlns:a="http://schemas.openxmlformats.org/drawingml/2006/main" w="0">
+            <a:noFill/>
+            <a:prstDash val="solid"/>
+          </a:ln>
+        </p:spPr>
+        <p:txBody>
+          <a:bodyPr xmlns:a="http://schemas.openxmlformats.org/drawingml/2006/main" wrap="square" lIns="0" tIns="0" rIns="0" bIns="0" anchor="t">
+            <a:normAutofit fontScale="100000"/>
+          </a:bodyPr>
+          <a:lstStyle xmlns:a="http://schemas.openxmlformats.org/drawingml/2006/main"/>
+          <a:p xmlns:a="http://schemas.openxmlformats.org/drawingml/2006/main">
+            <a:pPr algn="l">
+              <a:buNone/>
+              <a:defRPr sz="1125" b="0" i="0">
+                <a:solidFill>
+                  <a:srgbClr val="59616D"/>
+                </a:solidFill>
+                <a:latin typeface="PingFang SC"/>
+                <a:ea typeface="PingFang SC"/>
+                <a:cs typeface="PingFang SC"/>
+              </a:defRPr>
+            </a:pPr>
+            <a:r>
+              <a:rPr sz="1125" b="0" i="0">
+                <a:solidFill>
+                  <a:srgbClr val="59616D"/>
+                </a:solidFill>
+                <a:latin typeface="PingFang SC"/>
+                <a:ea typeface="PingFang SC"/>
+                <a:cs typeface="PingFang SC"/>
+              </a:rPr>
+              <a:t>GLM · Kimi · Ling · Qwen</a:t>
+            </a:r>
+          </a:p>
+        </p:txBody>
+      </p:sp>
+      <p:graphicFrame>
+        <p:nvGraphicFramePr>
+          <p:cNvPr id="665" name="Chart"/>
+          <p:cNvGraphicFramePr/>
+          <p:nvPr/>
+        </p:nvGraphicFramePr>
+        <p:xfrm>
+          <a:off xmlns:a="http://schemas.openxmlformats.org/drawingml/2006/main" x="156496" y="2200275"/>
+          <a:ext xmlns:a="http://schemas.openxmlformats.org/drawingml/2006/main" cx="6222206" cy="3119152"/>
+        </p:xfrm>
+        <a:graphic xmlns:a="http://schemas.openxmlformats.org/drawingml/2006/main">
+          <a:graphicData uri="http://schemas.openxmlformats.org/drawingml/2006/chart">
+            <c:chart xmlns:r="http://schemas.openxmlformats.org/officeDocument/2006/relationships" xmlns:c="http://schemas.openxmlformats.org/drawingml/2006/chart" r:id="R1b5559c47ede4bde"/>
+          </a:graphicData>
+        </a:graphic>
+      </p:graphicFrame>
+    </p:spTree>
+    <p:extLst>
+      <p:ext uri="{BB962C8B-B14F-4D97-AF65-F5344CB8AC3E}">
+        <p14:creationId xmlns:p14="http://schemas.microsoft.com/office/powerpoint/2010/main" val="2049111161"/>
+      </p:ext>
+    </p:extLst>
+  </p:cSld>
+</p:sld>
+</file>
+
+<file path=ppt/slides/slide36.xml><?xml version="1.0" encoding="utf-8"?>
+<p:sld xmlns:p="http://schemas.openxmlformats.org/presentationml/2006/main">
+  <p:cSld>
+    <p:bg>
+      <p:bgPr>
+        <a:solidFill xmlns:a="http://schemas.openxmlformats.org/drawingml/2006/main">
+          <a:srgbClr val="FFFFFF"/>
+        </a:solidFill>
+      </p:bgPr>
+    </p:bg>
+    <p:spTree>
+      <p:nvGrpSpPr>
+        <p:cNvPr id="1" name=""/>
+        <p:cNvGrpSpPr/>
+        <p:nvPr/>
+      </p:nvGrpSpPr>
+      <p:grpSpPr>
+        <a:xfrm xmlns:a="http://schemas.openxmlformats.org/drawingml/2006/main"/>
+      </p:grpSpPr>
+      <p:sp>
+        <p:nvSpPr>
+          <p:cNvPr id="17" name="section-kicker">
+            <a:extLst xmlns:a="http://schemas.openxmlformats.org/drawingml/2006/main">
+              <a:ext uri="{FF2B5EF4-FFF2-40B4-BE49-F238E27FC236}">
+                <a16:creationId xmlns:a16="http://schemas.microsoft.com/office/drawing/2014/main" id="{A07FB4AA-710F-4E87-AACA-77E3DAFAB71C}"/>
+              </a:ext>
+            </a:extLst>
+          </p:cNvPr>
+          <p:cNvSpPr>
+            <a:spLocks xmlns:a="http://schemas.openxmlformats.org/drawingml/2006/main" noGrp="1"/>
+          </p:cNvSpPr>
+          <p:nvPr/>
+        </p:nvSpPr>
+        <p:spPr>
+          <a:xfrm xmlns:a="http://schemas.openxmlformats.org/drawingml/2006/main">
+            <a:off x="400050" y="228600"/>
+            <a:ext cx="5905500" cy="228600"/>
+          </a:xfrm>
+          <a:prstGeom xmlns:a="http://schemas.openxmlformats.org/drawingml/2006/main" prst="rect">
+            <a:avLst/>
+          </a:prstGeom>
+          <a:noFill xmlns:a="http://schemas.openxmlformats.org/drawingml/2006/main"/>
+          <a:ln xmlns:a="http://schemas.openxmlformats.org/drawingml/2006/main" w="0">
+            <a:noFill/>
+            <a:prstDash val="solid"/>
+          </a:ln>
+        </p:spPr>
+        <p:txBody>
+          <a:bodyPr xmlns:a="http://schemas.openxmlformats.org/drawingml/2006/main" wrap="square" lIns="0" tIns="0" rIns="0" bIns="0" anchor="t">
+            <a:noAutofit/>
+          </a:bodyPr>
+          <a:lstStyle xmlns:a="http://schemas.openxmlformats.org/drawingml/2006/main"/>
+          <a:p xmlns:a="http://schemas.openxmlformats.org/drawingml/2006/main">
+            <a:pPr algn="l">
+              <a:buNone/>
+              <a:defRPr sz="1050" b="1" i="0">
+                <a:solidFill>
+                  <a:srgbClr val="3D8DFF"/>
+                </a:solidFill>
+                <a:latin typeface="Helvetica Neue"/>
+                <a:ea typeface="Helvetica Neue"/>
+                <a:cs typeface="Helvetica Neue"/>
+              </a:defRPr>
+            </a:pPr>
+            <a:r>
+              <a:rPr sz="1050" b="1" i="0">
+                <a:solidFill>
+                  <a:srgbClr val="3D8DFF"/>
+                </a:solidFill>
+                <a:latin typeface="Helvetica Neue"/>
+                <a:ea typeface="Helvetica Neue"/>
+                <a:cs typeface="Helvetica Neue"/>
+              </a:rPr>
+              <a:t>MULTI-TURN ATTACKER · CROSS-DATASET</a:t>
+            </a:r>
+          </a:p>
+        </p:txBody>
+      </p:sp>
+      <p:sp>
+        <p:nvSpPr>
+          <p:cNvPr id="2" name="slide-title">
+            <a:extLst xmlns:a="http://schemas.openxmlformats.org/drawingml/2006/main">
+              <a:ext uri="{FF2B5EF4-FFF2-40B4-BE49-F238E27FC236}">
+                <a16:creationId xmlns:a16="http://schemas.microsoft.com/office/drawing/2014/main" id="{0AB68E79-FE67-4F15-8262-963D89D18C22}"/>
+              </a:ext>
+            </a:extLst>
+          </p:cNvPr>
+          <p:cNvSpPr>
+            <a:spLocks xmlns:a="http://schemas.openxmlformats.org/drawingml/2006/main" noGrp="1"/>
+          </p:cNvSpPr>
+          <p:nvPr/>
+        </p:nvSpPr>
+        <p:spPr>
+          <a:xfrm xmlns:a="http://schemas.openxmlformats.org/drawingml/2006/main">
+            <a:off x="400050" y="495300"/>
+            <a:ext cx="10991850" cy="590550"/>
+          </a:xfrm>
+          <a:prstGeom xmlns:a="http://schemas.openxmlformats.org/drawingml/2006/main" prst="rect">
+            <a:avLst/>
+          </a:prstGeom>
+          <a:noFill xmlns:a="http://schemas.openxmlformats.org/drawingml/2006/main"/>
+          <a:ln xmlns:a="http://schemas.openxmlformats.org/drawingml/2006/main" w="0">
+            <a:noFill/>
+            <a:prstDash val="solid"/>
+          </a:ln>
+        </p:spPr>
+        <p:txBody>
+          <a:bodyPr xmlns:a="http://schemas.openxmlformats.org/drawingml/2006/main" wrap="square" lIns="0" tIns="0" rIns="0" bIns="0" anchor="t">
+            <a:normAutofit fontScale="93140"/>
+          </a:bodyPr>
+          <a:lstStyle xmlns:a="http://schemas.openxmlformats.org/drawingml/2006/main"/>
+          <a:p xmlns:a="http://schemas.openxmlformats.org/drawingml/2006/main">
+            <a:pPr algn="l">
+              <a:buNone/>
+              <a:defRPr sz="3450" b="1" i="0">
+                <a:solidFill>
+                  <a:srgbClr val="0A0A0A"/>
+                </a:solidFill>
+                <a:latin typeface="PingFang SC"/>
+                <a:ea typeface="PingFang SC"/>
+                <a:cs typeface="PingFang SC"/>
+              </a:defRPr>
+            </a:pPr>
+            <a:r>
+              <a:rPr sz="3450" b="1" i="0">
+                <a:solidFill>
+                  <a:srgbClr val="0A0A0A"/>
+                </a:solidFill>
+                <a:latin typeface="PingFang SC"/>
+                <a:ea typeface="PingFang SC"/>
+                <a:cs typeface="PingFang SC"/>
+              </a:rPr>
+              <a:t>纯英文 27B policy 跨数据集保持 93.8%–96.0% ASR@3</a:t>
+            </a:r>
+          </a:p>
+        </p:txBody>
+      </p:sp>
+      <p:sp>
+        <p:nvSpPr>
+          <p:cNvPr id="3" name="title-accent">
+            <a:extLst xmlns:a="http://schemas.openxmlformats.org/drawingml/2006/main">
+              <a:ext uri="{FF2B5EF4-FFF2-40B4-BE49-F238E27FC236}">
+                <a16:creationId xmlns:a16="http://schemas.microsoft.com/office/drawing/2014/main" id="{FF47AB6C-34CD-4012-9125-03FF460B8A1E}"/>
+              </a:ext>
+            </a:extLst>
+          </p:cNvPr>
+          <p:cNvSpPr>
+            <a:spLocks xmlns:a="http://schemas.openxmlformats.org/drawingml/2006/main" noGrp="1"/>
+          </p:cNvSpPr>
+          <p:nvPr/>
+        </p:nvSpPr>
+        <p:spPr>
+          <a:xfrm xmlns:a="http://schemas.openxmlformats.org/drawingml/2006/main">
+            <a:off x="400050" y="1181100"/>
+            <a:ext cx="819150" cy="38100"/>
+          </a:xfrm>
+          <a:prstGeom xmlns:a="http://schemas.openxmlformats.org/drawingml/2006/main" prst="rect">
+            <a:avLst/>
+          </a:prstGeom>
+          <a:solidFill xmlns:a="http://schemas.openxmlformats.org/drawingml/2006/main">
+            <a:srgbClr val="3D8DFF"/>
+          </a:solidFill>
+          <a:ln xmlns:a="http://schemas.openxmlformats.org/drawingml/2006/main" w="0">
+            <a:noFill/>
+            <a:prstDash val="solid"/>
+          </a:ln>
+        </p:spPr>
+      </p:sp>
+      <p:sp>
+        <p:nvSpPr>
+          <p:cNvPr id="4" name="page-number">
+            <a:extLst xmlns:a="http://schemas.openxmlformats.org/drawingml/2006/main">
+              <a:ext uri="{FF2B5EF4-FFF2-40B4-BE49-F238E27FC236}">
+                <a16:creationId xmlns:a16="http://schemas.microsoft.com/office/drawing/2014/main" id="{D8302D7A-002C-4448-8BEB-845DCB925374}"/>
+              </a:ext>
+            </a:extLst>
+          </p:cNvPr>
+          <p:cNvSpPr>
+            <a:spLocks xmlns:a="http://schemas.openxmlformats.org/drawingml/2006/main" noGrp="1"/>
+          </p:cNvSpPr>
+          <p:nvPr/>
+        </p:nvSpPr>
+        <p:spPr>
+          <a:xfrm xmlns:a="http://schemas.openxmlformats.org/drawingml/2006/main">
+            <a:off x="11277600" y="6324600"/>
+            <a:ext cx="514350" cy="228600"/>
+          </a:xfrm>
+          <a:prstGeom xmlns:a="http://schemas.openxmlformats.org/drawingml/2006/main" prst="rect">
+            <a:avLst/>
+          </a:prstGeom>
+          <a:noFill xmlns:a="http://schemas.openxmlformats.org/drawingml/2006/main"/>
+          <a:ln xmlns:a="http://schemas.openxmlformats.org/drawingml/2006/main" w="0">
+            <a:noFill/>
+            <a:prstDash val="solid"/>
+          </a:ln>
+        </p:spPr>
+        <p:txBody>
+          <a:bodyPr xmlns:a="http://schemas.openxmlformats.org/drawingml/2006/main" wrap="square" lIns="0" tIns="0" rIns="0" bIns="0" anchor="t">
+            <a:noAutofit/>
+          </a:bodyPr>
+          <a:lstStyle xmlns:a="http://schemas.openxmlformats.org/drawingml/2006/main"/>
+          <a:p xmlns:a="http://schemas.openxmlformats.org/drawingml/2006/main">
+            <a:pPr algn="r">
+              <a:buNone/>
+              <a:defRPr sz="975" b="0" i="0">
+                <a:solidFill>
+                  <a:srgbClr val="59616D"/>
+                </a:solidFill>
+                <a:latin typeface="Helvetica Neue"/>
+                <a:ea typeface="Helvetica Neue"/>
+                <a:cs typeface="Helvetica Neue"/>
+              </a:defRPr>
+            </a:pPr>
+            <a:r>
+              <a:rPr sz="975" b="0" i="0">
+                <a:solidFill>
+                  <a:srgbClr val="59616D"/>
+                </a:solidFill>
+                <a:latin typeface="Helvetica Neue"/>
+                <a:ea typeface="Helvetica Neue"/>
+                <a:cs typeface="Helvetica Neue"/>
+              </a:rPr>
+              <a:t>36</a:t>
+            </a:r>
+          </a:p>
+        </p:txBody>
+      </p:sp>
+      <p:pic>
+        <p:nvPicPr>
+          <p:cNvPr id="25" name=""/>
+          <p:cNvPicPr>
+            <a:picLocks xmlns:a="http://schemas.openxmlformats.org/drawingml/2006/main" noChangeAspect="1"/>
+          </p:cNvPicPr>
+          <p:nvPr/>
+        </p:nvPicPr>
+        <p:blipFill>
+          <a:blip xmlns:r="http://schemas.openxmlformats.org/officeDocument/2006/relationships" xmlns:a="http://schemas.openxmlformats.org/drawingml/2006/main" r:embed="Rf82d06928d584e65"/>
+          <a:srcRect xmlns:a="http://schemas.openxmlformats.org/drawingml/2006/main" l="0" t="12219" r="0" b="12219"/>
+          <a:stretch xmlns:a="http://schemas.openxmlformats.org/drawingml/2006/main">
+            <a:fillRect l="0" t="0" r="0" b="0"/>
+          </a:stretch>
+        </p:blipFill>
+        <p:spPr>
+          <a:xfrm xmlns:a="http://schemas.openxmlformats.org/drawingml/2006/main">
+            <a:off x="400050" y="1466850"/>
+            <a:ext cx="11029950" cy="4667250"/>
+          </a:xfrm>
+          <a:prstGeom xmlns:a="http://schemas.openxmlformats.org/drawingml/2006/main" prst="rect">
+            <a:avLst/>
+          </a:prstGeom>
+        </p:spPr>
+      </p:pic>
+      <p:sp>
+        <p:nvSpPr>
+          <p:cNvPr id="19" name="">
+            <a:extLst xmlns:a="http://schemas.openxmlformats.org/drawingml/2006/main">
+              <a:ext uri="{FF2B5EF4-FFF2-40B4-BE49-F238E27FC236}">
+                <a16:creationId xmlns:a16="http://schemas.microsoft.com/office/drawing/2014/main" id="{2806F215-F8CA-4AB1-BCDF-146E932C8141}"/>
+              </a:ext>
+            </a:extLst>
+          </p:cNvPr>
+          <p:cNvSpPr>
+            <a:spLocks xmlns:a="http://schemas.openxmlformats.org/drawingml/2006/main" noGrp="1"/>
+          </p:cNvSpPr>
+          <p:nvPr/>
+        </p:nvSpPr>
+        <p:spPr>
+          <a:xfrm xmlns:a="http://schemas.openxmlformats.org/drawingml/2006/main">
+            <a:off x="400050" y="1466850"/>
+            <a:ext cx="11029950" cy="209550"/>
+          </a:xfrm>
+          <a:prstGeom xmlns:a="http://schemas.openxmlformats.org/drawingml/2006/main" prst="rect">
+            <a:avLst/>
+          </a:prstGeom>
+          <a:solidFill xmlns:a="http://schemas.openxmlformats.org/drawingml/2006/main">
+            <a:srgbClr val="FFFFFF"/>
+          </a:solidFill>
+          <a:ln xmlns:a="http://schemas.openxmlformats.org/drawingml/2006/main" w="0">
+            <a:solidFill>
+              <a:srgbClr val="FFFFFF"/>
+            </a:solidFill>
+            <a:prstDash val="solid"/>
+          </a:ln>
+        </p:spPr>
       </p:sp>
     </p:spTree>
     <p:extLst>
@@ -36386,7 +36441,7 @@
       </p:sp>
       <p:cxnSp>
         <p:nvCxnSpPr>
-          <p:cNvPr id="409" name="rule"/>
+          <p:cNvPr id="569" name="rule"/>
           <p:cNvCxnSpPr/>
           <p:nvPr/>
         </p:nvCxnSpPr>
@@ -36526,7 +36581,7 @@
         </p:spPr>
         <p:txBody>
           <a:bodyPr xmlns:a="http://schemas.openxmlformats.org/drawingml/2006/main" wrap="square" lIns="0" tIns="0" rIns="0" bIns="0" anchor="t">
-            <a:normAutofit/>
+            <a:normAutofit fontScale="100000"/>
           </a:bodyPr>
           <a:lstStyle xmlns:a="http://schemas.openxmlformats.org/drawingml/2006/main"/>
           <a:p xmlns:a="http://schemas.openxmlformats.org/drawingml/2006/main">
@@ -36554,6 +36609,9 @@
             </a:r>
           </a:p>
           <a:p xmlns:a="http://schemas.openxmlformats.org/drawingml/2006/main">
+            <a:r>
+              <a:t/>
+            </a:r>
             <a:endParaRPr sz="1500" b="0" i="0">
               <a:solidFill>
                 <a:srgbClr val="59616D"/>
@@ -36632,18 +36690,7 @@
                 <a:ea typeface="PingFang SC"/>
                 <a:cs typeface="PingFang SC"/>
               </a:rPr>
-              <a:t>Uncertainty for IPS · </a:t>
-            </a:r>
-            <a:r>
-              <a:rPr sz="1500" b="0" i="0">
-                <a:solidFill>
-                  <a:srgbClr val="59616D"/>
-                </a:solidFill>
-                <a:latin typeface="PingFang SC"/>
-                <a:ea typeface="PingFang SC"/>
-                <a:cs typeface="PingFang SC"/>
-              </a:rPr>
-              <a:t>TKDE 2025</a:t>
+              <a:t>Uncertainty for IPS · TKDE 2025（学生一作）</a:t>
             </a:r>
           </a:p>
         </p:txBody>
@@ -36709,7 +36756,7 @@
       </p:sp>
       <p:cxnSp>
         <p:nvCxnSpPr>
-          <p:cNvPr id="414" name="rule"/>
+          <p:cNvPr id="574" name="rule"/>
           <p:cNvCxnSpPr/>
           <p:nvPr/>
         </p:nvCxnSpPr>
@@ -36973,7 +37020,7 @@
       </p:sp>
       <p:cxnSp>
         <p:nvCxnSpPr>
-          <p:cNvPr id="419" name="rule"/>
+          <p:cNvPr id="579" name="rule"/>
           <p:cNvCxnSpPr/>
           <p:nvPr/>
         </p:nvCxnSpPr>
@@ -37113,7 +37160,7 @@
         </p:spPr>
         <p:txBody>
           <a:bodyPr xmlns:a="http://schemas.openxmlformats.org/drawingml/2006/main" wrap="square" lIns="0" tIns="0" rIns="0" bIns="0" anchor="t">
-            <a:normAutofit/>
+            <a:normAutofit fontScale="95062"/>
           </a:bodyPr>
           <a:lstStyle xmlns:a="http://schemas.openxmlformats.org/drawingml/2006/main"/>
           <a:p xmlns:a="http://schemas.openxmlformats.org/drawingml/2006/main">
@@ -37141,6 +37188,9 @@
             </a:r>
           </a:p>
           <a:p xmlns:a="http://schemas.openxmlformats.org/drawingml/2006/main">
+            <a:r>
+              <a:t/>
+            </a:r>
             <a:endParaRPr sz="1500" b="0" i="0">
               <a:solidFill>
                 <a:srgbClr val="59616D"/>
@@ -37171,18 +37221,7 @@
                 <a:ea typeface="PingFang SC"/>
                 <a:cs typeface="PingFang SC"/>
               </a:rPr>
-              <a:t>KBQA–R1 · </a:t>
-            </a:r>
-            <a:r>
-              <a:rPr sz="1500">
-                <a:solidFill>
-                  <a:srgbClr val="59616D"/>
-                </a:solidFill>
-                <a:latin typeface="PingFang SC"/>
-                <a:ea typeface="PingFang SC"/>
-                <a:cs typeface="PingFang SC"/>
-              </a:rPr>
-              <a:t>ICML 2026</a:t>
+              <a:t>KBQA–R1 · ICML 2026</a:t>
             </a:r>
             <a:endParaRPr sz="1500" b="0" i="0">
               <a:solidFill>
@@ -37214,7 +37253,7 @@
                 <a:ea typeface="PingFang SC"/>
                 <a:cs typeface="PingFang SC"/>
               </a:rPr>
-              <a:t>GAPD · EMNLP 2026 投稿中</a:t>
+              <a:t>GAPD · EMNLP 2026 Findings</a:t>
             </a:r>
           </a:p>
           <a:p xmlns:a="http://schemas.openxmlformats.org/drawingml/2006/main">
@@ -37659,7 +37698,7 @@
       </p:sp>
       <p:cxnSp>
         <p:nvCxnSpPr>
-          <p:cNvPr id="509" name="rule"/>
+          <p:cNvPr id="709" name="rule"/>
           <p:cNvCxnSpPr/>
           <p:nvPr/>
         </p:nvCxnSpPr>
@@ -37858,7 +37897,7 @@
       </p:sp>
       <p:cxnSp>
         <p:nvCxnSpPr>
-          <p:cNvPr id="513" name="rule"/>
+          <p:cNvPr id="713" name="rule"/>
           <p:cNvCxnSpPr/>
           <p:nvPr/>
         </p:nvCxnSpPr>
@@ -38057,7 +38096,7 @@
       </p:sp>
       <p:cxnSp>
         <p:nvCxnSpPr>
-          <p:cNvPr id="517" name="rule"/>
+          <p:cNvPr id="717" name="rule"/>
           <p:cNvCxnSpPr/>
           <p:nvPr/>
         </p:nvCxnSpPr>
@@ -38256,7 +38295,7 @@
       </p:sp>
       <p:cxnSp>
         <p:nvCxnSpPr>
-          <p:cNvPr id="521" name="rule"/>
+          <p:cNvPr id="721" name="rule"/>
           <p:cNvCxnSpPr/>
           <p:nvPr/>
         </p:nvCxnSpPr>
@@ -38912,7 +38951,7 @@
           <p:nvPr/>
         </p:nvPicPr>
         <p:blipFill>
-          <a:blip xmlns:r="http://schemas.openxmlformats.org/officeDocument/2006/relationships" xmlns:a="http://schemas.openxmlformats.org/drawingml/2006/main" r:embed="R18e5b44c0fab43b2"/>
+          <a:blip xmlns:r="http://schemas.openxmlformats.org/officeDocument/2006/relationships" xmlns:a="http://schemas.openxmlformats.org/drawingml/2006/main" r:embed="R0ce3d19e7e9f4a57"/>
           <a:stretch xmlns:a="http://schemas.openxmlformats.org/drawingml/2006/main"/>
         </p:blipFill>
         <p:spPr>
@@ -39461,7 +39500,7 @@
       </p:sp>
       <p:cxnSp>
         <p:nvCxnSpPr>
-          <p:cNvPr id="278" name="rule"/>
+          <p:cNvPr id="378" name="rule"/>
           <p:cNvCxnSpPr/>
           <p:nvPr/>
         </p:nvCxnSpPr>
@@ -41397,7 +41436,7 @@
           <p:nvPr/>
         </p:nvPicPr>
         <p:blipFill>
-          <a:blip xmlns:r="http://schemas.openxmlformats.org/officeDocument/2006/relationships" xmlns:a="http://schemas.openxmlformats.org/drawingml/2006/main" r:embed="R61e9b705f0574bfb"/>
+          <a:blip xmlns:r="http://schemas.openxmlformats.org/officeDocument/2006/relationships" xmlns:a="http://schemas.openxmlformats.org/drawingml/2006/main" r:embed="R1471095f011843a5"/>
           <a:stretch xmlns:a="http://schemas.openxmlformats.org/drawingml/2006/main">
             <a:fillRect l="0" t="0" r="0" b="0"/>
           </a:stretch>
@@ -41847,7 +41886,7 @@
       </p:sp>
       <p:cxnSp>
         <p:nvCxnSpPr>
-          <p:cNvPr id="453" name="rule"/>
+          <p:cNvPr id="623" name="rule"/>
           <p:cNvCxnSpPr/>
           <p:nvPr/>
         </p:nvCxnSpPr>
@@ -42065,7 +42104,7 @@
       </p:sp>
       <p:cxnSp>
         <p:nvCxnSpPr>
-          <p:cNvPr id="457" name="rule"/>
+          <p:cNvPr id="627" name="rule"/>
           <p:cNvCxnSpPr/>
           <p:nvPr/>
         </p:nvCxnSpPr>
@@ -42267,7 +42306,7 @@
       </p:sp>
       <p:cxnSp>
         <p:nvCxnSpPr>
-          <p:cNvPr id="461" name="rule"/>
+          <p:cNvPr id="631" name="rule"/>
           <p:cNvCxnSpPr/>
           <p:nvPr/>
         </p:nvCxnSpPr>
@@ -42575,14 +42614,14 @@
       </p:sp>
       <p:pic>
         <p:nvPicPr>
-          <p:cNvPr id="467" name="图片 5"/>
+          <p:cNvPr id="637" name="图片 5"/>
           <p:cNvPicPr>
             <a:picLocks xmlns:a="http://schemas.openxmlformats.org/drawingml/2006/main" noChangeAspect="1"/>
           </p:cNvPicPr>
           <p:nvPr/>
         </p:nvPicPr>
         <p:blipFill>
-          <a:blip xmlns:r="http://schemas.openxmlformats.org/officeDocument/2006/relationships" xmlns:a="http://schemas.openxmlformats.org/drawingml/2006/main" r:embed="Ra234c8a590b346a9"/>
+          <a:blip xmlns:r="http://schemas.openxmlformats.org/officeDocument/2006/relationships" xmlns:a="http://schemas.openxmlformats.org/drawingml/2006/main" r:embed="Rdfacf2e241004a97"/>
           <a:stretch xmlns:a="http://schemas.openxmlformats.org/drawingml/2006/main">
             <a:fillRect l="0" t="0" r="0" b="0"/>
           </a:stretch>

</xml_diff>